<commit_message>
feat: icon pake SHAPE (diamond/square/triangle) bukan text unicode
- Semua icon sekarang pake shape: app, gear, city, web, phone, link,
  check, star, arrow, box
- Zero text unicode icons — render sempurna di PowerPoint manapun
- Zero circles/ovals — murni diamond, rectangle, triangle, chevron
- Per item: icon shape + number + teks lebih strategis
- Total 164 shapes di 7 slide
</commit_message>
<xml_diff>
--- a/RESUME_TUPOKSI_egov.pptx
+++ b/RESUME_TUPOKSI_egov.pptx
@@ -3239,14 +3239,14 @@
         </p:nvSpPr>
         <p:spPr>
           <a:xfrm>
-            <a:off x="-457200" y="5486400"/>
-            <a:ext cx="3200400" cy="1828800"/>
-          </a:xfrm>
-          <a:prstGeom prst="rect">
-            <a:avLst/>
-          </a:prstGeom>
-          <a:solidFill>
-            <a:srgbClr val="0F2A4A"/>
+            <a:off x="0" y="6601968"/>
+            <a:ext cx="12191695" cy="256032"/>
+          </a:xfrm>
+          <a:prstGeom prst="rect">
+            <a:avLst/>
+          </a:prstGeom>
+          <a:solidFill>
+            <a:srgbClr val="0D9488"/>
           </a:solidFill>
           <a:ln>
             <a:noFill/>
@@ -3276,20 +3276,20 @@
       </p:sp>
       <p:sp>
         <p:nvSpPr>
-          <p:cNvPr id="6" name="Rectangle 5"/>
-          <p:cNvSpPr/>
-          <p:nvPr/>
-        </p:nvSpPr>
-        <p:spPr>
-          <a:xfrm>
-            <a:off x="-457200" y="0"/>
-            <a:ext cx="2286000" cy="1371600"/>
-          </a:xfrm>
-          <a:prstGeom prst="rect">
-            <a:avLst/>
-          </a:prstGeom>
-          <a:solidFill>
-            <a:srgbClr val="0F2A4A"/>
+          <p:cNvPr id="6" name="Rounded Rectangle 5"/>
+          <p:cNvSpPr/>
+          <p:nvPr/>
+        </p:nvSpPr>
+        <p:spPr>
+          <a:xfrm>
+            <a:off x="822959" y="1371600"/>
+            <a:ext cx="731520" cy="731520"/>
+          </a:xfrm>
+          <a:prstGeom prst="roundRect">
+            <a:avLst/>
+          </a:prstGeom>
+          <a:solidFill>
+            <a:srgbClr val="0D9488"/>
           </a:solidFill>
           <a:ln>
             <a:noFill/>
@@ -3325,14 +3325,14 @@
         </p:nvSpPr>
         <p:spPr>
           <a:xfrm>
-            <a:off x="0" y="6601968"/>
-            <a:ext cx="12191695" cy="256032"/>
-          </a:xfrm>
-          <a:prstGeom prst="rect">
-            <a:avLst/>
-          </a:prstGeom>
-          <a:solidFill>
-            <a:srgbClr val="0D9488"/>
+            <a:off x="1005839" y="1554480"/>
+            <a:ext cx="365760" cy="365760"/>
+          </a:xfrm>
+          <a:prstGeom prst="rect">
+            <a:avLst/>
+          </a:prstGeom>
+          <a:solidFill>
+            <a:srgbClr val="FFFFFF"/>
           </a:solidFill>
           <a:ln>
             <a:noFill/>
@@ -3362,19 +3362,17 @@
       </p:sp>
       <p:sp>
         <p:nvSpPr>
-          <p:cNvPr id="8" name="Rounded Rectangle 7"/>
-          <p:cNvSpPr/>
-          <p:nvPr/>
-        </p:nvSpPr>
-        <p:spPr>
-          <a:xfrm>
-            <a:off x="548640" y="1463040"/>
-            <a:ext cx="640080" cy="640080"/>
-          </a:xfrm>
-          <a:prstGeom prst="roundRect">
-            <a:avLst>
-              <a:gd name="adj" fmla="val 15000"/>
-            </a:avLst>
+          <p:cNvPr id="8" name="Rectangle 7"/>
+          <p:cNvSpPr/>
+          <p:nvPr/>
+        </p:nvSpPr>
+        <p:spPr>
+          <a:xfrm>
+            <a:off x="1120139" y="1668780"/>
+            <a:ext cx="137160" cy="137160"/>
+          </a:xfrm>
+          <a:prstGeom prst="rect">
+            <a:avLst/>
           </a:prstGeom>
           <a:solidFill>
             <a:srgbClr val="0D9488"/>
@@ -3413,44 +3411,8 @@
         </p:nvSpPr>
         <p:spPr>
           <a:xfrm>
-            <a:off x="548640" y="1559052"/>
-            <a:ext cx="640080" cy="448055"/>
-          </a:xfrm>
-          <a:prstGeom prst="rect">
-            <a:avLst/>
-          </a:prstGeom>
-          <a:noFill/>
-        </p:spPr>
-        <p:txBody>
-          <a:bodyPr wrap="square">
-            <a:spAutoFit/>
-          </a:bodyPr>
-          <a:lstStyle/>
-          <a:p>
-            <a:pPr algn="ctr">
-              <a:defRPr sz="2200">
-                <a:solidFill>
-                  <a:srgbClr val="FFFFFF"/>
-                </a:solidFill>
-                <a:latin typeface="Calibri"/>
-              </a:defRPr>
-            </a:pPr>
-            <a:r>
-              <a:t>▣</a:t>
-            </a:r>
-          </a:p>
-        </p:txBody>
-      </p:sp>
-      <p:sp>
-        <p:nvSpPr>
-          <p:cNvPr id="10" name="TextBox 9"/>
-          <p:cNvSpPr txBox="1"/>
-          <p:nvPr/>
-        </p:nvSpPr>
-        <p:spPr>
-          <a:xfrm>
-            <a:off x="1463040" y="1463040"/>
-            <a:ext cx="9722815" cy="731520"/>
+            <a:off x="1920240" y="1463040"/>
+            <a:ext cx="9265615" cy="731520"/>
           </a:xfrm>
           <a:prstGeom prst="rect">
             <a:avLst/>
@@ -3479,13 +3441,13 @@
       </p:sp>
       <p:sp>
         <p:nvSpPr>
-          <p:cNvPr id="11" name="TextBox 10"/>
+          <p:cNvPr id="10" name="TextBox 9"/>
           <p:cNvSpPr txBox="1"/>
           <p:nvPr/>
         </p:nvSpPr>
         <p:spPr>
           <a:xfrm>
-            <a:off x="548640" y="2560320"/>
+            <a:off x="548640" y="2651760"/>
             <a:ext cx="11094415" cy="457200"/>
           </a:xfrm>
           <a:prstGeom prst="rect">
@@ -3515,13 +3477,13 @@
       </p:sp>
       <p:sp>
         <p:nvSpPr>
-          <p:cNvPr id="12" name="TextBox 11"/>
+          <p:cNvPr id="11" name="TextBox 10"/>
           <p:cNvSpPr txBox="1"/>
           <p:nvPr/>
         </p:nvSpPr>
         <p:spPr>
           <a:xfrm>
-            <a:off x="548640" y="3108960"/>
+            <a:off x="548640" y="3200400"/>
             <a:ext cx="11094415" cy="365760"/>
           </a:xfrm>
           <a:prstGeom prst="rect">
@@ -3551,13 +3513,13 @@
       </p:sp>
       <p:sp>
         <p:nvSpPr>
-          <p:cNvPr id="13" name="Rectangle 12"/>
-          <p:cNvSpPr/>
-          <p:nvPr/>
-        </p:nvSpPr>
-        <p:spPr>
-          <a:xfrm>
-            <a:off x="548640" y="3657600"/>
+          <p:cNvPr id="12" name="Rectangle 11"/>
+          <p:cNvSpPr/>
+          <p:nvPr/>
+        </p:nvSpPr>
+        <p:spPr>
+          <a:xfrm>
+            <a:off x="548640" y="3749039"/>
             <a:ext cx="2286000" cy="34838640000"/>
           </a:xfrm>
           <a:prstGeom prst="rect">
@@ -3594,13 +3556,13 @@
       </p:sp>
       <p:sp>
         <p:nvSpPr>
-          <p:cNvPr id="14" name="TextBox 13"/>
+          <p:cNvPr id="13" name="TextBox 12"/>
           <p:cNvSpPr txBox="1"/>
           <p:nvPr/>
         </p:nvSpPr>
         <p:spPr>
           <a:xfrm>
-            <a:off x="548640" y="3931920"/>
+            <a:off x="548640" y="4023360"/>
             <a:ext cx="11094415" cy="274320"/>
           </a:xfrm>
           <a:prstGeom prst="rect">
@@ -3863,8 +3825,8 @@
         </p:nvSpPr>
         <p:spPr>
           <a:xfrm>
-            <a:off x="548639" y="1417320"/>
-            <a:ext cx="3484778" cy="3657600"/>
+            <a:off x="548639" y="1371600"/>
+            <a:ext cx="3484778" cy="3840480"/>
           </a:xfrm>
           <a:prstGeom prst="roundRect">
             <a:avLst>
@@ -3910,7 +3872,7 @@
         </p:nvSpPr>
         <p:spPr>
           <a:xfrm>
-            <a:off x="548639" y="1417320"/>
+            <a:off x="548639" y="1371600"/>
             <a:ext cx="3484778" cy="73152"/>
           </a:xfrm>
           <a:prstGeom prst="rect">
@@ -3953,13 +3915,11 @@
         </p:nvSpPr>
         <p:spPr>
           <a:xfrm>
-            <a:off x="777239" y="1691640"/>
+            <a:off x="777239" y="1645920"/>
             <a:ext cx="502920" cy="502920"/>
           </a:xfrm>
           <a:prstGeom prst="roundRect">
-            <a:avLst>
-              <a:gd name="adj" fmla="val 15000"/>
-            </a:avLst>
+            <a:avLst/>
           </a:prstGeom>
           <a:solidFill>
             <a:srgbClr val="0A1628"/>
@@ -3992,50 +3952,100 @@
       </p:sp>
       <p:sp>
         <p:nvSpPr>
-          <p:cNvPr id="10" name="TextBox 9"/>
+          <p:cNvPr id="10" name="Rectangle 9"/>
+          <p:cNvSpPr/>
+          <p:nvPr/>
+        </p:nvSpPr>
+        <p:spPr>
+          <a:xfrm>
+            <a:off x="960119" y="1828800"/>
+            <a:ext cx="137160" cy="137160"/>
+          </a:xfrm>
+          <a:prstGeom prst="rect">
+            <a:avLst/>
+          </a:prstGeom>
+          <a:solidFill>
+            <a:srgbClr val="FFFFFF"/>
+          </a:solidFill>
+          <a:ln>
+            <a:noFill/>
+          </a:ln>
+        </p:spPr>
+        <p:style>
+          <a:lnRef idx="1">
+            <a:schemeClr val="accent1"/>
+          </a:lnRef>
+          <a:fillRef idx="3">
+            <a:schemeClr val="accent1"/>
+          </a:fillRef>
+          <a:effectRef idx="2">
+            <a:schemeClr val="accent1"/>
+          </a:effectRef>
+          <a:fontRef idx="minor">
+            <a:schemeClr val="lt1"/>
+          </a:fontRef>
+        </p:style>
+        <p:txBody>
+          <a:bodyPr rtlCol="0" anchor="ctr"/>
+          <a:lstStyle/>
+          <a:p>
+            <a:pPr algn="ctr"/>
+          </a:p>
+        </p:txBody>
+      </p:sp>
+      <p:sp>
+        <p:nvSpPr>
+          <p:cNvPr id="11" name="Rectangle 10"/>
+          <p:cNvSpPr/>
+          <p:nvPr/>
+        </p:nvSpPr>
+        <p:spPr>
+          <a:xfrm>
+            <a:off x="960119" y="1828800"/>
+            <a:ext cx="137160" cy="137160"/>
+          </a:xfrm>
+          <a:prstGeom prst="rect">
+            <a:avLst/>
+          </a:prstGeom>
+          <a:solidFill>
+            <a:srgbClr val="0A1628"/>
+          </a:solidFill>
+          <a:ln>
+            <a:noFill/>
+          </a:ln>
+        </p:spPr>
+        <p:style>
+          <a:lnRef idx="1">
+            <a:schemeClr val="accent1"/>
+          </a:lnRef>
+          <a:fillRef idx="3">
+            <a:schemeClr val="accent1"/>
+          </a:fillRef>
+          <a:effectRef idx="2">
+            <a:schemeClr val="accent1"/>
+          </a:effectRef>
+          <a:fontRef idx="minor">
+            <a:schemeClr val="lt1"/>
+          </a:fontRef>
+        </p:style>
+        <p:txBody>
+          <a:bodyPr rtlCol="0" anchor="ctr"/>
+          <a:lstStyle/>
+          <a:p>
+            <a:pPr algn="ctr"/>
+          </a:p>
+        </p:txBody>
+      </p:sp>
+      <p:sp>
+        <p:nvSpPr>
+          <p:cNvPr id="12" name="TextBox 11"/>
           <p:cNvSpPr txBox="1"/>
           <p:nvPr/>
         </p:nvSpPr>
         <p:spPr>
           <a:xfrm>
-            <a:off x="777239" y="1767078"/>
-            <a:ext cx="502920" cy="352044"/>
-          </a:xfrm>
-          <a:prstGeom prst="rect">
-            <a:avLst/>
-          </a:prstGeom>
-          <a:noFill/>
-        </p:spPr>
-        <p:txBody>
-          <a:bodyPr wrap="square">
-            <a:spAutoFit/>
-          </a:bodyPr>
-          <a:lstStyle/>
-          <a:p>
-            <a:pPr algn="ctr">
-              <a:defRPr sz="2000">
-                <a:solidFill>
-                  <a:srgbClr val="FFFFFF"/>
-                </a:solidFill>
-                <a:latin typeface="Calibri"/>
-              </a:defRPr>
-            </a:pPr>
-            <a:r>
-              <a:t>▣</a:t>
-            </a:r>
-          </a:p>
-        </p:txBody>
-      </p:sp>
-      <p:sp>
-        <p:nvSpPr>
-          <p:cNvPr id="11" name="TextBox 10"/>
-          <p:cNvSpPr txBox="1"/>
-          <p:nvPr/>
-        </p:nvSpPr>
-        <p:spPr>
-          <a:xfrm>
-            <a:off x="1417319" y="1737360"/>
-            <a:ext cx="548640" cy="274320"/>
+            <a:off x="1417319" y="1719072"/>
+            <a:ext cx="457200" cy="274320"/>
           </a:xfrm>
           <a:prstGeom prst="rect">
             <a:avLst/>
@@ -4064,13 +4074,13 @@
       </p:sp>
       <p:sp>
         <p:nvSpPr>
-          <p:cNvPr id="12" name="TextBox 11"/>
+          <p:cNvPr id="13" name="TextBox 12"/>
           <p:cNvSpPr txBox="1"/>
           <p:nvPr/>
         </p:nvSpPr>
         <p:spPr>
           <a:xfrm>
-            <a:off x="777239" y="2377440"/>
+            <a:off x="777239" y="2423160"/>
             <a:ext cx="3027578" cy="777240"/>
           </a:xfrm>
           <a:prstGeom prst="rect">
@@ -4104,13 +4114,13 @@
       </p:sp>
       <p:sp>
         <p:nvSpPr>
-          <p:cNvPr id="13" name="Rectangle 12"/>
-          <p:cNvSpPr/>
-          <p:nvPr/>
-        </p:nvSpPr>
-        <p:spPr>
-          <a:xfrm>
-            <a:off x="777239" y="3246120"/>
+          <p:cNvPr id="14" name="Rectangle 13"/>
+          <p:cNvSpPr/>
+          <p:nvPr/>
+        </p:nvSpPr>
+        <p:spPr>
+          <a:xfrm>
+            <a:off x="777239" y="3291840"/>
             <a:ext cx="3027578" cy="17419320000"/>
           </a:xfrm>
           <a:prstGeom prst="rect">
@@ -4147,14 +4157,14 @@
       </p:sp>
       <p:sp>
         <p:nvSpPr>
-          <p:cNvPr id="14" name="TextBox 13"/>
+          <p:cNvPr id="15" name="TextBox 14"/>
           <p:cNvSpPr txBox="1"/>
           <p:nvPr/>
         </p:nvSpPr>
         <p:spPr>
           <a:xfrm>
-            <a:off x="777239" y="3429000"/>
-            <a:ext cx="3027578" cy="1371600"/>
+            <a:off x="777239" y="3474720"/>
+            <a:ext cx="3027578" cy="1463040"/>
           </a:xfrm>
           <a:prstGeom prst="rect">
             <a:avLst/>
@@ -4195,14 +4205,14 @@
       </p:sp>
       <p:sp>
         <p:nvSpPr>
-          <p:cNvPr id="15" name="Rounded Rectangle 14"/>
-          <p:cNvSpPr/>
-          <p:nvPr/>
-        </p:nvSpPr>
-        <p:spPr>
-          <a:xfrm>
-            <a:off x="4353458" y="1417320"/>
-            <a:ext cx="3484778" cy="3657600"/>
+          <p:cNvPr id="16" name="Rounded Rectangle 15"/>
+          <p:cNvSpPr/>
+          <p:nvPr/>
+        </p:nvSpPr>
+        <p:spPr>
+          <a:xfrm>
+            <a:off x="4353458" y="1371600"/>
+            <a:ext cx="3484778" cy="3840480"/>
           </a:xfrm>
           <a:prstGeom prst="roundRect">
             <a:avLst>
@@ -4242,13 +4252,13 @@
       </p:sp>
       <p:sp>
         <p:nvSpPr>
-          <p:cNvPr id="16" name="Rectangle 15"/>
-          <p:cNvSpPr/>
-          <p:nvPr/>
-        </p:nvSpPr>
-        <p:spPr>
-          <a:xfrm>
-            <a:off x="4353458" y="1417320"/>
+          <p:cNvPr id="17" name="Rectangle 16"/>
+          <p:cNvSpPr/>
+          <p:nvPr/>
+        </p:nvSpPr>
+        <p:spPr>
+          <a:xfrm>
+            <a:off x="4353458" y="1371600"/>
             <a:ext cx="3484778" cy="73152"/>
           </a:xfrm>
           <a:prstGeom prst="rect">
@@ -4285,19 +4295,17 @@
       </p:sp>
       <p:sp>
         <p:nvSpPr>
-          <p:cNvPr id="17" name="Rounded Rectangle 16"/>
-          <p:cNvSpPr/>
-          <p:nvPr/>
-        </p:nvSpPr>
-        <p:spPr>
-          <a:xfrm>
-            <a:off x="4582058" y="1691640"/>
+          <p:cNvPr id="18" name="Pentagon 17"/>
+          <p:cNvSpPr/>
+          <p:nvPr/>
+        </p:nvSpPr>
+        <p:spPr>
+          <a:xfrm>
+            <a:off x="4582058" y="1645920"/>
             <a:ext cx="502920" cy="502920"/>
           </a:xfrm>
-          <a:prstGeom prst="roundRect">
-            <a:avLst>
-              <a:gd name="adj" fmla="val 15000"/>
-            </a:avLst>
+          <a:prstGeom prst="homePlate">
+            <a:avLst/>
           </a:prstGeom>
           <a:solidFill>
             <a:srgbClr val="1A5676"/>
@@ -4330,50 +4338,57 @@
       </p:sp>
       <p:sp>
         <p:nvSpPr>
-          <p:cNvPr id="18" name="TextBox 17"/>
+          <p:cNvPr id="19" name="Rectangle 18"/>
+          <p:cNvSpPr/>
+          <p:nvPr/>
+        </p:nvSpPr>
+        <p:spPr>
+          <a:xfrm>
+            <a:off x="4732934" y="1796796"/>
+            <a:ext cx="201168" cy="201168"/>
+          </a:xfrm>
+          <a:prstGeom prst="rect">
+            <a:avLst/>
+          </a:prstGeom>
+          <a:solidFill>
+            <a:srgbClr val="FFFFFF"/>
+          </a:solidFill>
+          <a:ln>
+            <a:noFill/>
+          </a:ln>
+        </p:spPr>
+        <p:style>
+          <a:lnRef idx="1">
+            <a:schemeClr val="accent1"/>
+          </a:lnRef>
+          <a:fillRef idx="3">
+            <a:schemeClr val="accent1"/>
+          </a:fillRef>
+          <a:effectRef idx="2">
+            <a:schemeClr val="accent1"/>
+          </a:effectRef>
+          <a:fontRef idx="minor">
+            <a:schemeClr val="lt1"/>
+          </a:fontRef>
+        </p:style>
+        <p:txBody>
+          <a:bodyPr rtlCol="0" anchor="ctr"/>
+          <a:lstStyle/>
+          <a:p>
+            <a:pPr algn="ctr"/>
+          </a:p>
+        </p:txBody>
+      </p:sp>
+      <p:sp>
+        <p:nvSpPr>
+          <p:cNvPr id="20" name="TextBox 19"/>
           <p:cNvSpPr txBox="1"/>
           <p:nvPr/>
         </p:nvSpPr>
         <p:spPr>
           <a:xfrm>
-            <a:off x="4582058" y="1767078"/>
-            <a:ext cx="502920" cy="352044"/>
-          </a:xfrm>
-          <a:prstGeom prst="rect">
-            <a:avLst/>
-          </a:prstGeom>
-          <a:noFill/>
-        </p:spPr>
-        <p:txBody>
-          <a:bodyPr wrap="square">
-            <a:spAutoFit/>
-          </a:bodyPr>
-          <a:lstStyle/>
-          <a:p>
-            <a:pPr algn="ctr">
-              <a:defRPr sz="2000">
-                <a:solidFill>
-                  <a:srgbClr val="FFFFFF"/>
-                </a:solidFill>
-                <a:latin typeface="Calibri"/>
-              </a:defRPr>
-            </a:pPr>
-            <a:r>
-              <a:t>⚙</a:t>
-            </a:r>
-          </a:p>
-        </p:txBody>
-      </p:sp>
-      <p:sp>
-        <p:nvSpPr>
-          <p:cNvPr id="19" name="TextBox 18"/>
-          <p:cNvSpPr txBox="1"/>
-          <p:nvPr/>
-        </p:nvSpPr>
-        <p:spPr>
-          <a:xfrm>
-            <a:off x="5222138" y="1737360"/>
-            <a:ext cx="548640" cy="274320"/>
+            <a:off x="5222138" y="1719072"/>
+            <a:ext cx="457200" cy="274320"/>
           </a:xfrm>
           <a:prstGeom prst="rect">
             <a:avLst/>
@@ -4402,13 +4417,13 @@
       </p:sp>
       <p:sp>
         <p:nvSpPr>
-          <p:cNvPr id="20" name="TextBox 19"/>
+          <p:cNvPr id="21" name="TextBox 20"/>
           <p:cNvSpPr txBox="1"/>
           <p:nvPr/>
         </p:nvSpPr>
         <p:spPr>
           <a:xfrm>
-            <a:off x="4582058" y="2377440"/>
+            <a:off x="4582058" y="2423160"/>
             <a:ext cx="3027578" cy="777240"/>
           </a:xfrm>
           <a:prstGeom prst="rect">
@@ -4438,13 +4453,13 @@
       </p:sp>
       <p:sp>
         <p:nvSpPr>
-          <p:cNvPr id="21" name="Rectangle 20"/>
-          <p:cNvSpPr/>
-          <p:nvPr/>
-        </p:nvSpPr>
-        <p:spPr>
-          <a:xfrm>
-            <a:off x="4582058" y="3246120"/>
+          <p:cNvPr id="22" name="Rectangle 21"/>
+          <p:cNvSpPr/>
+          <p:nvPr/>
+        </p:nvSpPr>
+        <p:spPr>
+          <a:xfrm>
+            <a:off x="4582058" y="3291840"/>
             <a:ext cx="3027578" cy="17419320000"/>
           </a:xfrm>
           <a:prstGeom prst="rect">
@@ -4481,14 +4496,14 @@
       </p:sp>
       <p:sp>
         <p:nvSpPr>
-          <p:cNvPr id="22" name="TextBox 21"/>
+          <p:cNvPr id="23" name="TextBox 22"/>
           <p:cNvSpPr txBox="1"/>
           <p:nvPr/>
         </p:nvSpPr>
         <p:spPr>
           <a:xfrm>
-            <a:off x="4582058" y="3429000"/>
-            <a:ext cx="3027578" cy="1371600"/>
+            <a:off x="4582058" y="3474720"/>
+            <a:ext cx="3027578" cy="1463040"/>
           </a:xfrm>
           <a:prstGeom prst="rect">
             <a:avLst/>
@@ -4529,14 +4544,14 @@
       </p:sp>
       <p:sp>
         <p:nvSpPr>
-          <p:cNvPr id="23" name="Rounded Rectangle 22"/>
-          <p:cNvSpPr/>
-          <p:nvPr/>
-        </p:nvSpPr>
-        <p:spPr>
-          <a:xfrm>
-            <a:off x="8158276" y="1417320"/>
-            <a:ext cx="3484778" cy="3657600"/>
+          <p:cNvPr id="24" name="Rounded Rectangle 23"/>
+          <p:cNvSpPr/>
+          <p:nvPr/>
+        </p:nvSpPr>
+        <p:spPr>
+          <a:xfrm>
+            <a:off x="8158276" y="1371600"/>
+            <a:ext cx="3484778" cy="3840480"/>
           </a:xfrm>
           <a:prstGeom prst="roundRect">
             <a:avLst>
@@ -4576,13 +4591,13 @@
       </p:sp>
       <p:sp>
         <p:nvSpPr>
-          <p:cNvPr id="24" name="Rectangle 23"/>
-          <p:cNvSpPr/>
-          <p:nvPr/>
-        </p:nvSpPr>
-        <p:spPr>
-          <a:xfrm>
-            <a:off x="8158276" y="1417320"/>
+          <p:cNvPr id="25" name="Rectangle 24"/>
+          <p:cNvSpPr/>
+          <p:nvPr/>
+        </p:nvSpPr>
+        <p:spPr>
+          <a:xfrm>
+            <a:off x="8158276" y="1371600"/>
             <a:ext cx="3484778" cy="73152"/>
           </a:xfrm>
           <a:prstGeom prst="rect">
@@ -4619,19 +4634,17 @@
       </p:sp>
       <p:sp>
         <p:nvSpPr>
-          <p:cNvPr id="25" name="Rounded Rectangle 24"/>
-          <p:cNvSpPr/>
-          <p:nvPr/>
-        </p:nvSpPr>
-        <p:spPr>
-          <a:xfrm>
-            <a:off x="8386876" y="1691640"/>
-            <a:ext cx="502920" cy="502920"/>
-          </a:xfrm>
-          <a:prstGeom prst="roundRect">
-            <a:avLst>
-              <a:gd name="adj" fmla="val 15000"/>
-            </a:avLst>
+          <p:cNvPr id="26" name="Rectangle 25"/>
+          <p:cNvSpPr/>
+          <p:nvPr/>
+        </p:nvSpPr>
+        <p:spPr>
+          <a:xfrm>
+            <a:off x="8386876" y="1796796"/>
+            <a:ext cx="502920" cy="352044"/>
+          </a:xfrm>
+          <a:prstGeom prst="rect">
+            <a:avLst/>
           </a:prstGeom>
           <a:solidFill>
             <a:srgbClr val="0D9488"/>
@@ -4664,50 +4677,100 @@
       </p:sp>
       <p:sp>
         <p:nvSpPr>
-          <p:cNvPr id="26" name="TextBox 25"/>
+          <p:cNvPr id="27" name="Isosceles Triangle 26"/>
+          <p:cNvSpPr/>
+          <p:nvPr/>
+        </p:nvSpPr>
+        <p:spPr>
+          <a:xfrm>
+            <a:off x="8386876" y="1645920"/>
+            <a:ext cx="502920" cy="251460"/>
+          </a:xfrm>
+          <a:prstGeom prst="triangle">
+            <a:avLst/>
+          </a:prstGeom>
+          <a:solidFill>
+            <a:srgbClr val="0D9488"/>
+          </a:solidFill>
+          <a:ln>
+            <a:noFill/>
+          </a:ln>
+        </p:spPr>
+        <p:style>
+          <a:lnRef idx="1">
+            <a:schemeClr val="accent1"/>
+          </a:lnRef>
+          <a:fillRef idx="3">
+            <a:schemeClr val="accent1"/>
+          </a:fillRef>
+          <a:effectRef idx="2">
+            <a:schemeClr val="accent1"/>
+          </a:effectRef>
+          <a:fontRef idx="minor">
+            <a:schemeClr val="lt1"/>
+          </a:fontRef>
+        </p:style>
+        <p:txBody>
+          <a:bodyPr rtlCol="0" anchor="ctr"/>
+          <a:lstStyle/>
+          <a:p>
+            <a:pPr algn="ctr"/>
+          </a:p>
+        </p:txBody>
+      </p:sp>
+      <p:sp>
+        <p:nvSpPr>
+          <p:cNvPr id="28" name="Rectangle 27"/>
+          <p:cNvSpPr/>
+          <p:nvPr/>
+        </p:nvSpPr>
+        <p:spPr>
+          <a:xfrm>
+            <a:off x="8537752" y="1897380"/>
+            <a:ext cx="75438" cy="75438"/>
+          </a:xfrm>
+          <a:prstGeom prst="rect">
+            <a:avLst/>
+          </a:prstGeom>
+          <a:solidFill>
+            <a:srgbClr val="FFFFFF"/>
+          </a:solidFill>
+          <a:ln>
+            <a:noFill/>
+          </a:ln>
+        </p:spPr>
+        <p:style>
+          <a:lnRef idx="1">
+            <a:schemeClr val="accent1"/>
+          </a:lnRef>
+          <a:fillRef idx="3">
+            <a:schemeClr val="accent1"/>
+          </a:fillRef>
+          <a:effectRef idx="2">
+            <a:schemeClr val="accent1"/>
+          </a:effectRef>
+          <a:fontRef idx="minor">
+            <a:schemeClr val="lt1"/>
+          </a:fontRef>
+        </p:style>
+        <p:txBody>
+          <a:bodyPr rtlCol="0" anchor="ctr"/>
+          <a:lstStyle/>
+          <a:p>
+            <a:pPr algn="ctr"/>
+          </a:p>
+        </p:txBody>
+      </p:sp>
+      <p:sp>
+        <p:nvSpPr>
+          <p:cNvPr id="29" name="TextBox 28"/>
           <p:cNvSpPr txBox="1"/>
           <p:nvPr/>
         </p:nvSpPr>
         <p:spPr>
           <a:xfrm>
-            <a:off x="8386876" y="1767078"/>
-            <a:ext cx="502920" cy="352044"/>
-          </a:xfrm>
-          <a:prstGeom prst="rect">
-            <a:avLst/>
-          </a:prstGeom>
-          <a:noFill/>
-        </p:spPr>
-        <p:txBody>
-          <a:bodyPr wrap="square">
-            <a:spAutoFit/>
-          </a:bodyPr>
-          <a:lstStyle/>
-          <a:p>
-            <a:pPr algn="ctr">
-              <a:defRPr sz="2000">
-                <a:solidFill>
-                  <a:srgbClr val="FFFFFF"/>
-                </a:solidFill>
-                <a:latin typeface="Calibri"/>
-              </a:defRPr>
-            </a:pPr>
-            <a:r>
-              <a:t>🏛</a:t>
-            </a:r>
-          </a:p>
-        </p:txBody>
-      </p:sp>
-      <p:sp>
-        <p:nvSpPr>
-          <p:cNvPr id="27" name="TextBox 26"/>
-          <p:cNvSpPr txBox="1"/>
-          <p:nvPr/>
-        </p:nvSpPr>
-        <p:spPr>
-          <a:xfrm>
-            <a:off x="9026956" y="1737360"/>
-            <a:ext cx="548640" cy="274320"/>
+            <a:off x="9026956" y="1719072"/>
+            <a:ext cx="457200" cy="274320"/>
           </a:xfrm>
           <a:prstGeom prst="rect">
             <a:avLst/>
@@ -4736,13 +4799,13 @@
       </p:sp>
       <p:sp>
         <p:nvSpPr>
-          <p:cNvPr id="28" name="TextBox 27"/>
+          <p:cNvPr id="30" name="TextBox 29"/>
           <p:cNvSpPr txBox="1"/>
           <p:nvPr/>
         </p:nvSpPr>
         <p:spPr>
           <a:xfrm>
-            <a:off x="8386876" y="2377440"/>
+            <a:off x="8386876" y="2423160"/>
             <a:ext cx="3027578" cy="777240"/>
           </a:xfrm>
           <a:prstGeom prst="rect">
@@ -4776,13 +4839,13 @@
       </p:sp>
       <p:sp>
         <p:nvSpPr>
-          <p:cNvPr id="29" name="Rectangle 28"/>
-          <p:cNvSpPr/>
-          <p:nvPr/>
-        </p:nvSpPr>
-        <p:spPr>
-          <a:xfrm>
-            <a:off x="8386876" y="3246120"/>
+          <p:cNvPr id="31" name="Rectangle 30"/>
+          <p:cNvSpPr/>
+          <p:nvPr/>
+        </p:nvSpPr>
+        <p:spPr>
+          <a:xfrm>
+            <a:off x="8386876" y="3291840"/>
             <a:ext cx="3027578" cy="17419320000"/>
           </a:xfrm>
           <a:prstGeom prst="rect">
@@ -4819,14 +4882,14 @@
       </p:sp>
       <p:sp>
         <p:nvSpPr>
-          <p:cNvPr id="30" name="TextBox 29"/>
+          <p:cNvPr id="32" name="TextBox 31"/>
           <p:cNvSpPr txBox="1"/>
           <p:nvPr/>
         </p:nvSpPr>
         <p:spPr>
           <a:xfrm>
-            <a:off x="8386876" y="3429000"/>
-            <a:ext cx="3027578" cy="1371600"/>
+            <a:off x="8386876" y="3474720"/>
+            <a:ext cx="3027578" cy="1463040"/>
           </a:xfrm>
           <a:prstGeom prst="rect">
             <a:avLst/>
@@ -4867,7 +4930,7 @@
       </p:sp>
       <p:sp>
         <p:nvSpPr>
-          <p:cNvPr id="31" name="Rectangle 30"/>
+          <p:cNvPr id="33" name="Rectangle 32"/>
           <p:cNvSpPr/>
           <p:nvPr/>
         </p:nvSpPr>
@@ -4910,7 +4973,7 @@
       </p:sp>
       <p:sp>
         <p:nvSpPr>
-          <p:cNvPr id="32" name="Rectangle 31"/>
+          <p:cNvPr id="34" name="Rectangle 33"/>
           <p:cNvSpPr/>
           <p:nvPr/>
         </p:nvSpPr>
@@ -4953,7 +5016,7 @@
       </p:sp>
       <p:sp>
         <p:nvSpPr>
-          <p:cNvPr id="33" name="TextBox 32"/>
+          <p:cNvPr id="35" name="TextBox 34"/>
           <p:cNvSpPr txBox="1"/>
           <p:nvPr/>
         </p:nvSpPr>
@@ -4989,7 +5052,7 @@
       </p:sp>
       <p:sp>
         <p:nvSpPr>
-          <p:cNvPr id="34" name="TextBox 33"/>
+          <p:cNvPr id="36" name="TextBox 35"/>
           <p:cNvSpPr txBox="1"/>
           <p:nvPr/>
         </p:nvSpPr>
@@ -5299,19 +5362,17 @@
       </p:sp>
       <p:sp>
         <p:nvSpPr>
-          <p:cNvPr id="8" name="Rounded Rectangle 7"/>
+          <p:cNvPr id="8" name="Diamond 7"/>
           <p:cNvSpPr/>
           <p:nvPr/>
         </p:nvSpPr>
         <p:spPr>
           <a:xfrm>
             <a:off x="777239" y="1691640"/>
-            <a:ext cx="594360" cy="594360"/>
-          </a:xfrm>
-          <a:prstGeom prst="roundRect">
-            <a:avLst>
-              <a:gd name="adj" fmla="val 15000"/>
-            </a:avLst>
+            <a:ext cx="548640" cy="548640"/>
+          </a:xfrm>
+          <a:prstGeom prst="diamond">
+            <a:avLst/>
           </a:prstGeom>
           <a:solidFill>
             <a:srgbClr val="0A1628"/>
@@ -5344,37 +5405,44 @@
       </p:sp>
       <p:sp>
         <p:nvSpPr>
-          <p:cNvPr id="9" name="TextBox 8"/>
-          <p:cNvSpPr txBox="1"/>
-          <p:nvPr/>
-        </p:nvSpPr>
-        <p:spPr>
-          <a:xfrm>
-            <a:off x="777239" y="1780794"/>
-            <a:ext cx="594360" cy="416051"/>
-          </a:xfrm>
-          <a:prstGeom prst="rect">
-            <a:avLst/>
-          </a:prstGeom>
-          <a:noFill/>
-        </p:spPr>
-        <p:txBody>
-          <a:bodyPr wrap="square">
-            <a:spAutoFit/>
-          </a:bodyPr>
-          <a:lstStyle/>
-          <a:p>
-            <a:pPr algn="ctr">
-              <a:defRPr sz="2200">
-                <a:solidFill>
-                  <a:srgbClr val="FFFFFF"/>
-                </a:solidFill>
-                <a:latin typeface="Calibri"/>
-              </a:defRPr>
-            </a:pPr>
-            <a:r>
-              <a:t>🌐</a:t>
-            </a:r>
+          <p:cNvPr id="9" name="Rectangle 8"/>
+          <p:cNvSpPr/>
+          <p:nvPr/>
+        </p:nvSpPr>
+        <p:spPr>
+          <a:xfrm>
+            <a:off x="777239" y="1922068"/>
+            <a:ext cx="548640" cy="87782"/>
+          </a:xfrm>
+          <a:prstGeom prst="rect">
+            <a:avLst/>
+          </a:prstGeom>
+          <a:solidFill>
+            <a:srgbClr val="FFFFFF"/>
+          </a:solidFill>
+          <a:ln>
+            <a:noFill/>
+          </a:ln>
+        </p:spPr>
+        <p:style>
+          <a:lnRef idx="1">
+            <a:schemeClr val="accent1"/>
+          </a:lnRef>
+          <a:fillRef idx="3">
+            <a:schemeClr val="accent1"/>
+          </a:fillRef>
+          <a:effectRef idx="2">
+            <a:schemeClr val="accent1"/>
+          </a:effectRef>
+          <a:fontRef idx="minor">
+            <a:schemeClr val="lt1"/>
+          </a:fontRef>
+        </p:style>
+        <p:txBody>
+          <a:bodyPr rtlCol="0" anchor="ctr"/>
+          <a:lstStyle/>
+          <a:p>
+            <a:pPr algn="ctr"/>
           </a:p>
         </p:txBody>
       </p:sp>
@@ -5449,7 +5517,7 @@
             </a:r>
             <a:br/>
             <a:r>
-              <a:t>sebagai pusat informasi &amp; layanan publik</a:t>
+              <a:t>sebagai pusat info &amp; layanan publik</a:t>
             </a:r>
           </a:p>
         </p:txBody>
@@ -5509,13 +5577,11 @@
         </p:nvSpPr>
         <p:spPr>
           <a:xfrm>
-            <a:off x="6507327" y="1691640"/>
-            <a:ext cx="594360" cy="594360"/>
+            <a:off x="6630771" y="1691640"/>
+            <a:ext cx="301752" cy="548640"/>
           </a:xfrm>
           <a:prstGeom prst="roundRect">
-            <a:avLst>
-              <a:gd name="adj" fmla="val 15000"/>
-            </a:avLst>
+            <a:avLst/>
           </a:prstGeom>
           <a:solidFill>
             <a:srgbClr val="1A5676"/>
@@ -5548,43 +5614,93 @@
       </p:sp>
       <p:sp>
         <p:nvSpPr>
-          <p:cNvPr id="14" name="TextBox 13"/>
-          <p:cNvSpPr txBox="1"/>
-          <p:nvPr/>
-        </p:nvSpPr>
-        <p:spPr>
-          <a:xfrm>
-            <a:off x="6507327" y="1780794"/>
-            <a:ext cx="594360" cy="416051"/>
-          </a:xfrm>
-          <a:prstGeom prst="rect">
-            <a:avLst/>
-          </a:prstGeom>
-          <a:noFill/>
-        </p:spPr>
-        <p:txBody>
-          <a:bodyPr wrap="square">
-            <a:spAutoFit/>
-          </a:bodyPr>
-          <a:lstStyle/>
-          <a:p>
-            <a:pPr algn="ctr">
-              <a:defRPr sz="2200">
-                <a:solidFill>
-                  <a:srgbClr val="FFFFFF"/>
-                </a:solidFill>
-                <a:latin typeface="Calibri"/>
-              </a:defRPr>
-            </a:pPr>
-            <a:r>
-              <a:t>📱</a:t>
-            </a:r>
-          </a:p>
-        </p:txBody>
-      </p:sp>
-      <p:sp>
-        <p:nvSpPr>
-          <p:cNvPr id="15" name="TextBox 14"/>
+          <p:cNvPr id="14" name="Rectangle 13"/>
+          <p:cNvSpPr/>
+          <p:nvPr/>
+        </p:nvSpPr>
+        <p:spPr>
+          <a:xfrm>
+            <a:off x="6740499" y="1911095"/>
+            <a:ext cx="82296" cy="164592"/>
+          </a:xfrm>
+          <a:prstGeom prst="rect">
+            <a:avLst/>
+          </a:prstGeom>
+          <a:solidFill>
+            <a:srgbClr val="FFFFFF"/>
+          </a:solidFill>
+          <a:ln>
+            <a:noFill/>
+          </a:ln>
+        </p:spPr>
+        <p:style>
+          <a:lnRef idx="1">
+            <a:schemeClr val="accent1"/>
+          </a:lnRef>
+          <a:fillRef idx="3">
+            <a:schemeClr val="accent1"/>
+          </a:fillRef>
+          <a:effectRef idx="2">
+            <a:schemeClr val="accent1"/>
+          </a:effectRef>
+          <a:fontRef idx="minor">
+            <a:schemeClr val="lt1"/>
+          </a:fontRef>
+        </p:style>
+        <p:txBody>
+          <a:bodyPr rtlCol="0" anchor="ctr"/>
+          <a:lstStyle/>
+          <a:p>
+            <a:pPr algn="ctr"/>
+          </a:p>
+        </p:txBody>
+      </p:sp>
+      <p:sp>
+        <p:nvSpPr>
+          <p:cNvPr id="15" name="Rectangle 14"/>
+          <p:cNvSpPr/>
+          <p:nvPr/>
+        </p:nvSpPr>
+        <p:spPr>
+          <a:xfrm>
+            <a:off x="6721297" y="2130552"/>
+            <a:ext cx="120700" cy="87782"/>
+          </a:xfrm>
+          <a:prstGeom prst="rect">
+            <a:avLst/>
+          </a:prstGeom>
+          <a:solidFill>
+            <a:srgbClr val="FFFFFF"/>
+          </a:solidFill>
+          <a:ln>
+            <a:noFill/>
+          </a:ln>
+        </p:spPr>
+        <p:style>
+          <a:lnRef idx="1">
+            <a:schemeClr val="accent1"/>
+          </a:lnRef>
+          <a:fillRef idx="3">
+            <a:schemeClr val="accent1"/>
+          </a:fillRef>
+          <a:effectRef idx="2">
+            <a:schemeClr val="accent1"/>
+          </a:effectRef>
+          <a:fontRef idx="minor">
+            <a:schemeClr val="lt1"/>
+          </a:fontRef>
+        </p:style>
+        <p:txBody>
+          <a:bodyPr rtlCol="0" anchor="ctr"/>
+          <a:lstStyle/>
+          <a:p>
+            <a:pPr algn="ctr"/>
+          </a:p>
+        </p:txBody>
+      </p:sp>
+      <p:sp>
+        <p:nvSpPr>
+          <p:cNvPr id="16" name="TextBox 15"/>
           <p:cNvSpPr txBox="1"/>
           <p:nvPr/>
         </p:nvSpPr>
@@ -5620,7 +5736,7 @@
       </p:sp>
       <p:sp>
         <p:nvSpPr>
-          <p:cNvPr id="16" name="TextBox 15"/>
+          <p:cNvPr id="17" name="TextBox 16"/>
           <p:cNvSpPr txBox="1"/>
           <p:nvPr/>
         </p:nvSpPr>
@@ -5653,14 +5769,14 @@
             </a:r>
             <a:br/>
             <a:r>
-              <a:t>sebagai layanan kota cerdas terintegrasi</a:t>
-            </a:r>
-          </a:p>
-        </p:txBody>
-      </p:sp>
-      <p:sp>
-        <p:nvSpPr>
-          <p:cNvPr id="17" name="Rounded Rectangle 16"/>
+              <a:t>— layanan kota cerdas terintegrasi</a:t>
+            </a:r>
+          </a:p>
+        </p:txBody>
+      </p:sp>
+      <p:sp>
+        <p:nvSpPr>
+          <p:cNvPr id="18" name="Rounded Rectangle 17"/>
           <p:cNvSpPr/>
           <p:nvPr/>
         </p:nvSpPr>
@@ -5707,19 +5823,17 @@
       </p:sp>
       <p:sp>
         <p:nvSpPr>
-          <p:cNvPr id="18" name="Rounded Rectangle 17"/>
-          <p:cNvSpPr/>
-          <p:nvPr/>
-        </p:nvSpPr>
-        <p:spPr>
-          <a:xfrm>
-            <a:off x="777239" y="3657600"/>
-            <a:ext cx="594360" cy="594360"/>
-          </a:xfrm>
-          <a:prstGeom prst="roundRect">
-            <a:avLst>
-              <a:gd name="adj" fmla="val 15000"/>
-            </a:avLst>
+          <p:cNvPr id="19" name="Rectangle 18"/>
+          <p:cNvSpPr/>
+          <p:nvPr/>
+        </p:nvSpPr>
+        <p:spPr>
+          <a:xfrm>
+            <a:off x="777239" y="3822191"/>
+            <a:ext cx="548640" cy="384048"/>
+          </a:xfrm>
+          <a:prstGeom prst="rect">
+            <a:avLst/>
           </a:prstGeom>
           <a:solidFill>
             <a:srgbClr val="0D9488"/>
@@ -5752,43 +5866,93 @@
       </p:sp>
       <p:sp>
         <p:nvSpPr>
-          <p:cNvPr id="19" name="TextBox 18"/>
-          <p:cNvSpPr txBox="1"/>
-          <p:nvPr/>
-        </p:nvSpPr>
-        <p:spPr>
-          <a:xfrm>
-            <a:off x="777239" y="3746754"/>
-            <a:ext cx="594360" cy="416051"/>
-          </a:xfrm>
-          <a:prstGeom prst="rect">
-            <a:avLst/>
-          </a:prstGeom>
-          <a:noFill/>
-        </p:spPr>
-        <p:txBody>
-          <a:bodyPr wrap="square">
-            <a:spAutoFit/>
-          </a:bodyPr>
-          <a:lstStyle/>
-          <a:p>
-            <a:pPr algn="ctr">
-              <a:defRPr sz="2200">
-                <a:solidFill>
-                  <a:srgbClr val="FFFFFF"/>
-                </a:solidFill>
-                <a:latin typeface="Calibri"/>
-              </a:defRPr>
-            </a:pPr>
-            <a:r>
-              <a:t>🏛</a:t>
-            </a:r>
-          </a:p>
-        </p:txBody>
-      </p:sp>
-      <p:sp>
-        <p:nvSpPr>
-          <p:cNvPr id="20" name="TextBox 19"/>
+          <p:cNvPr id="20" name="Isosceles Triangle 19"/>
+          <p:cNvSpPr/>
+          <p:nvPr/>
+        </p:nvSpPr>
+        <p:spPr>
+          <a:xfrm>
+            <a:off x="777239" y="3657600"/>
+            <a:ext cx="548640" cy="274320"/>
+          </a:xfrm>
+          <a:prstGeom prst="triangle">
+            <a:avLst/>
+          </a:prstGeom>
+          <a:solidFill>
+            <a:srgbClr val="0D9488"/>
+          </a:solidFill>
+          <a:ln>
+            <a:noFill/>
+          </a:ln>
+        </p:spPr>
+        <p:style>
+          <a:lnRef idx="1">
+            <a:schemeClr val="accent1"/>
+          </a:lnRef>
+          <a:fillRef idx="3">
+            <a:schemeClr val="accent1"/>
+          </a:fillRef>
+          <a:effectRef idx="2">
+            <a:schemeClr val="accent1"/>
+          </a:effectRef>
+          <a:fontRef idx="minor">
+            <a:schemeClr val="lt1"/>
+          </a:fontRef>
+        </p:style>
+        <p:txBody>
+          <a:bodyPr rtlCol="0" anchor="ctr"/>
+          <a:lstStyle/>
+          <a:p>
+            <a:pPr algn="ctr"/>
+          </a:p>
+        </p:txBody>
+      </p:sp>
+      <p:sp>
+        <p:nvSpPr>
+          <p:cNvPr id="21" name="Rectangle 20"/>
+          <p:cNvSpPr/>
+          <p:nvPr/>
+        </p:nvSpPr>
+        <p:spPr>
+          <a:xfrm>
+            <a:off x="941831" y="3931920"/>
+            <a:ext cx="82296" cy="82296"/>
+          </a:xfrm>
+          <a:prstGeom prst="rect">
+            <a:avLst/>
+          </a:prstGeom>
+          <a:solidFill>
+            <a:srgbClr val="FFFFFF"/>
+          </a:solidFill>
+          <a:ln>
+            <a:noFill/>
+          </a:ln>
+        </p:spPr>
+        <p:style>
+          <a:lnRef idx="1">
+            <a:schemeClr val="accent1"/>
+          </a:lnRef>
+          <a:fillRef idx="3">
+            <a:schemeClr val="accent1"/>
+          </a:fillRef>
+          <a:effectRef idx="2">
+            <a:schemeClr val="accent1"/>
+          </a:effectRef>
+          <a:fontRef idx="minor">
+            <a:schemeClr val="lt1"/>
+          </a:fontRef>
+        </p:style>
+        <p:txBody>
+          <a:bodyPr rtlCol="0" anchor="ctr"/>
+          <a:lstStyle/>
+          <a:p>
+            <a:pPr algn="ctr"/>
+          </a:p>
+        </p:txBody>
+      </p:sp>
+      <p:sp>
+        <p:nvSpPr>
+          <p:cNvPr id="22" name="TextBox 21"/>
           <p:cNvSpPr txBox="1"/>
           <p:nvPr/>
         </p:nvSpPr>
@@ -5824,7 +5988,7 @@
       </p:sp>
       <p:sp>
         <p:nvSpPr>
-          <p:cNvPr id="21" name="TextBox 20"/>
+          <p:cNvPr id="23" name="TextBox 22"/>
           <p:cNvSpPr txBox="1"/>
           <p:nvPr/>
         </p:nvSpPr>
@@ -5864,7 +6028,7 @@
       </p:sp>
       <p:sp>
         <p:nvSpPr>
-          <p:cNvPr id="22" name="Rounded Rectangle 21"/>
+          <p:cNvPr id="24" name="Rounded Rectangle 23"/>
           <p:cNvSpPr/>
           <p:nvPr/>
         </p:nvSpPr>
@@ -5911,19 +6075,17 @@
       </p:sp>
       <p:sp>
         <p:nvSpPr>
-          <p:cNvPr id="23" name="Rounded Rectangle 22"/>
+          <p:cNvPr id="25" name="Parallelogram 24"/>
           <p:cNvSpPr/>
           <p:nvPr/>
         </p:nvSpPr>
         <p:spPr>
           <a:xfrm>
             <a:off x="6507327" y="3657600"/>
-            <a:ext cx="594360" cy="594360"/>
-          </a:xfrm>
-          <a:prstGeom prst="roundRect">
-            <a:avLst>
-              <a:gd name="adj" fmla="val 15000"/>
-            </a:avLst>
+            <a:ext cx="384048" cy="548640"/>
+          </a:xfrm>
+          <a:prstGeom prst="parallelogram">
+            <a:avLst/>
           </a:prstGeom>
           <a:solidFill>
             <a:srgbClr val="F59E0B"/>
@@ -5956,43 +6118,50 @@
       </p:sp>
       <p:sp>
         <p:nvSpPr>
-          <p:cNvPr id="24" name="TextBox 23"/>
-          <p:cNvSpPr txBox="1"/>
-          <p:nvPr/>
-        </p:nvSpPr>
-        <p:spPr>
-          <a:xfrm>
-            <a:off x="6507327" y="3746754"/>
-            <a:ext cx="594360" cy="416051"/>
-          </a:xfrm>
-          <a:prstGeom prst="rect">
-            <a:avLst/>
-          </a:prstGeom>
-          <a:noFill/>
-        </p:spPr>
-        <p:txBody>
-          <a:bodyPr wrap="square">
-            <a:spAutoFit/>
-          </a:bodyPr>
-          <a:lstStyle/>
-          <a:p>
-            <a:pPr algn="ctr">
-              <a:defRPr sz="2200">
-                <a:solidFill>
-                  <a:srgbClr val="FFFFFF"/>
-                </a:solidFill>
-                <a:latin typeface="Calibri"/>
-              </a:defRPr>
-            </a:pPr>
-            <a:r>
-              <a:t>🔗</a:t>
-            </a:r>
-          </a:p>
-        </p:txBody>
-      </p:sp>
-      <p:sp>
-        <p:nvSpPr>
-          <p:cNvPr id="25" name="TextBox 24"/>
+          <p:cNvPr id="26" name="Parallelogram 25"/>
+          <p:cNvSpPr/>
+          <p:nvPr/>
+        </p:nvSpPr>
+        <p:spPr>
+          <a:xfrm>
+            <a:off x="6671919" y="3657600"/>
+            <a:ext cx="384048" cy="548640"/>
+          </a:xfrm>
+          <a:prstGeom prst="parallelogram">
+            <a:avLst/>
+          </a:prstGeom>
+          <a:solidFill>
+            <a:srgbClr val="FFFFFF"/>
+          </a:solidFill>
+          <a:ln>
+            <a:noFill/>
+          </a:ln>
+        </p:spPr>
+        <p:style>
+          <a:lnRef idx="1">
+            <a:schemeClr val="accent1"/>
+          </a:lnRef>
+          <a:fillRef idx="3">
+            <a:schemeClr val="accent1"/>
+          </a:fillRef>
+          <a:effectRef idx="2">
+            <a:schemeClr val="accent1"/>
+          </a:effectRef>
+          <a:fontRef idx="minor">
+            <a:schemeClr val="lt1"/>
+          </a:fontRef>
+        </p:style>
+        <p:txBody>
+          <a:bodyPr rtlCol="0" anchor="ctr"/>
+          <a:lstStyle/>
+          <a:p>
+            <a:pPr algn="ctr"/>
+          </a:p>
+        </p:txBody>
+      </p:sp>
+      <p:sp>
+        <p:nvSpPr>
+          <p:cNvPr id="27" name="TextBox 26"/>
           <p:cNvSpPr txBox="1"/>
           <p:nvPr/>
         </p:nvSpPr>
@@ -6028,7 +6197,7 @@
       </p:sp>
       <p:sp>
         <p:nvSpPr>
-          <p:cNvPr id="26" name="TextBox 25"/>
+          <p:cNvPr id="28" name="TextBox 27"/>
           <p:cNvSpPr txBox="1"/>
           <p:nvPr/>
         </p:nvSpPr>
@@ -6057,18 +6226,18 @@
               </a:defRPr>
             </a:pPr>
             <a:r>
-              <a:t>Sistem Penghubung Layanan Pemerintah</a:t>
+              <a:t>Sistem Penghubung Layanan</a:t>
             </a:r>
             <a:br/>
             <a:r>
-              <a:t>terintegrasi dengan Kemenkomdigi</a:t>
-            </a:r>
-          </a:p>
-        </p:txBody>
-      </p:sp>
-      <p:sp>
-        <p:nvSpPr>
-          <p:cNvPr id="27" name="Rectangle 26"/>
+              <a:t>Pemerintah — terintegrasi Kemenkomdigi</a:t>
+            </a:r>
+          </a:p>
+        </p:txBody>
+      </p:sp>
+      <p:sp>
+        <p:nvSpPr>
+          <p:cNvPr id="29" name="Rectangle 28"/>
           <p:cNvSpPr/>
           <p:nvPr/>
         </p:nvSpPr>
@@ -6111,7 +6280,7 @@
       </p:sp>
       <p:sp>
         <p:nvSpPr>
-          <p:cNvPr id="28" name="Rectangle 27"/>
+          <p:cNvPr id="30" name="Rectangle 29"/>
           <p:cNvSpPr/>
           <p:nvPr/>
         </p:nvSpPr>
@@ -6154,7 +6323,7 @@
       </p:sp>
       <p:sp>
         <p:nvSpPr>
-          <p:cNvPr id="29" name="TextBox 28"/>
+          <p:cNvPr id="31" name="TextBox 30"/>
           <p:cNvSpPr txBox="1"/>
           <p:nvPr/>
         </p:nvSpPr>
@@ -6190,7 +6359,7 @@
       </p:sp>
       <p:sp>
         <p:nvSpPr>
-          <p:cNvPr id="30" name="TextBox 29"/>
+          <p:cNvPr id="32" name="TextBox 31"/>
           <p:cNvSpPr txBox="1"/>
           <p:nvPr/>
         </p:nvSpPr>
@@ -6460,7 +6629,7 @@
         <p:spPr>
           <a:xfrm>
             <a:off x="548640" y="1371600"/>
-            <a:ext cx="91440" cy="4572000"/>
+            <a:ext cx="91440" cy="4754880"/>
           </a:xfrm>
           <a:prstGeom prst="rect">
             <a:avLst/>
@@ -6502,13 +6671,11 @@
         </p:nvSpPr>
         <p:spPr>
           <a:xfrm>
-            <a:off x="868680" y="1600200"/>
+            <a:off x="868680" y="1645920"/>
             <a:ext cx="457200" cy="457200"/>
           </a:xfrm>
           <a:prstGeom prst="roundRect">
-            <a:avLst>
-              <a:gd name="adj" fmla="val 15000"/>
-            </a:avLst>
+            <a:avLst/>
           </a:prstGeom>
           <a:solidFill>
             <a:srgbClr val="0A1628"/>
@@ -6541,56 +6708,20 @@
       </p:sp>
       <p:sp>
         <p:nvSpPr>
-          <p:cNvPr id="9" name="TextBox 8"/>
-          <p:cNvSpPr txBox="1"/>
-          <p:nvPr/>
-        </p:nvSpPr>
-        <p:spPr>
-          <a:xfrm>
-            <a:off x="868680" y="1668780"/>
-            <a:ext cx="457200" cy="320040"/>
-          </a:xfrm>
-          <a:prstGeom prst="rect">
-            <a:avLst/>
-          </a:prstGeom>
-          <a:noFill/>
-        </p:spPr>
-        <p:txBody>
-          <a:bodyPr wrap="square">
-            <a:spAutoFit/>
-          </a:bodyPr>
-          <a:lstStyle/>
-          <a:p>
-            <a:pPr algn="ctr">
-              <a:defRPr sz="1600">
-                <a:solidFill>
-                  <a:srgbClr val="FFFFFF"/>
-                </a:solidFill>
-                <a:latin typeface="Calibri"/>
-              </a:defRPr>
-            </a:pPr>
-            <a:r>
-              <a:t>✓</a:t>
-            </a:r>
-          </a:p>
-        </p:txBody>
-      </p:sp>
-      <p:sp>
-        <p:nvSpPr>
-          <p:cNvPr id="10" name="Rectangle 9"/>
-          <p:cNvSpPr/>
-          <p:nvPr/>
-        </p:nvSpPr>
-        <p:spPr>
-          <a:xfrm>
-            <a:off x="1078992" y="2103120"/>
-            <a:ext cx="17419320000" cy="502920"/>
-          </a:xfrm>
-          <a:prstGeom prst="rect">
-            <a:avLst/>
-          </a:prstGeom>
-          <a:solidFill>
-            <a:srgbClr val="E2E8F0"/>
+          <p:cNvPr id="9" name="Diamond 8"/>
+          <p:cNvSpPr/>
+          <p:nvPr/>
+        </p:nvSpPr>
+        <p:spPr>
+          <a:xfrm>
+            <a:off x="960120" y="1737360"/>
+            <a:ext cx="274320" cy="274320"/>
+          </a:xfrm>
+          <a:prstGeom prst="diamond">
+            <a:avLst/>
+          </a:prstGeom>
+          <a:solidFill>
+            <a:srgbClr val="FFFFFF"/>
           </a:solidFill>
           <a:ln>
             <a:noFill/>
@@ -6620,13 +6751,56 @@
       </p:sp>
       <p:sp>
         <p:nvSpPr>
+          <p:cNvPr id="10" name="Rectangle 9"/>
+          <p:cNvSpPr/>
+          <p:nvPr/>
+        </p:nvSpPr>
+        <p:spPr>
+          <a:xfrm>
+            <a:off x="1078992" y="2194560"/>
+            <a:ext cx="17419320000" cy="457200"/>
+          </a:xfrm>
+          <a:prstGeom prst="rect">
+            <a:avLst/>
+          </a:prstGeom>
+          <a:solidFill>
+            <a:srgbClr val="E2E8F0"/>
+          </a:solidFill>
+          <a:ln>
+            <a:noFill/>
+          </a:ln>
+        </p:spPr>
+        <p:style>
+          <a:lnRef idx="1">
+            <a:schemeClr val="accent1"/>
+          </a:lnRef>
+          <a:fillRef idx="3">
+            <a:schemeClr val="accent1"/>
+          </a:fillRef>
+          <a:effectRef idx="2">
+            <a:schemeClr val="accent1"/>
+          </a:effectRef>
+          <a:fontRef idx="minor">
+            <a:schemeClr val="lt1"/>
+          </a:fontRef>
+        </p:style>
+        <p:txBody>
+          <a:bodyPr rtlCol="0" anchor="ctr"/>
+          <a:lstStyle/>
+          <a:p>
+            <a:pPr algn="ctr"/>
+          </a:p>
+        </p:txBody>
+      </p:sp>
+      <p:sp>
+        <p:nvSpPr>
           <p:cNvPr id="11" name="TextBox 10"/>
           <p:cNvSpPr txBox="1"/>
           <p:nvPr/>
         </p:nvSpPr>
         <p:spPr>
           <a:xfrm>
-            <a:off x="1554480" y="1618488"/>
+            <a:off x="1554480" y="1682496"/>
             <a:ext cx="9814255" cy="731520"/>
           </a:xfrm>
           <a:prstGeom prst="rect">
@@ -6675,19 +6849,17 @@
       </p:sp>
       <p:sp>
         <p:nvSpPr>
-          <p:cNvPr id="12" name="Rounded Rectangle 11"/>
-          <p:cNvSpPr/>
-          <p:nvPr/>
-        </p:nvSpPr>
-        <p:spPr>
-          <a:xfrm>
-            <a:off x="868680" y="2651760"/>
-            <a:ext cx="457200" cy="457200"/>
-          </a:xfrm>
-          <a:prstGeom prst="roundRect">
-            <a:avLst>
-              <a:gd name="adj" fmla="val 15000"/>
-            </a:avLst>
+          <p:cNvPr id="12" name="Parallelogram 11"/>
+          <p:cNvSpPr/>
+          <p:nvPr/>
+        </p:nvSpPr>
+        <p:spPr>
+          <a:xfrm>
+            <a:off x="868680" y="2697480"/>
+            <a:ext cx="320040" cy="457200"/>
+          </a:xfrm>
+          <a:prstGeom prst="parallelogram">
+            <a:avLst/>
           </a:prstGeom>
           <a:solidFill>
             <a:srgbClr val="0A1628"/>
@@ -6720,56 +6892,20 @@
       </p:sp>
       <p:sp>
         <p:nvSpPr>
-          <p:cNvPr id="13" name="TextBox 12"/>
-          <p:cNvSpPr txBox="1"/>
-          <p:nvPr/>
-        </p:nvSpPr>
-        <p:spPr>
-          <a:xfrm>
-            <a:off x="868680" y="2720340"/>
-            <a:ext cx="457200" cy="320040"/>
-          </a:xfrm>
-          <a:prstGeom prst="rect">
-            <a:avLst/>
-          </a:prstGeom>
-          <a:noFill/>
-        </p:spPr>
-        <p:txBody>
-          <a:bodyPr wrap="square">
-            <a:spAutoFit/>
-          </a:bodyPr>
-          <a:lstStyle/>
-          <a:p>
-            <a:pPr algn="ctr">
-              <a:defRPr sz="1600">
-                <a:solidFill>
-                  <a:srgbClr val="FFFFFF"/>
-                </a:solidFill>
-                <a:latin typeface="Calibri"/>
-              </a:defRPr>
-            </a:pPr>
-            <a:r>
-              <a:t>🔗</a:t>
-            </a:r>
-          </a:p>
-        </p:txBody>
-      </p:sp>
-      <p:sp>
-        <p:nvSpPr>
-          <p:cNvPr id="14" name="Rectangle 13"/>
-          <p:cNvSpPr/>
-          <p:nvPr/>
-        </p:nvSpPr>
-        <p:spPr>
-          <a:xfrm>
-            <a:off x="1078992" y="3154680"/>
-            <a:ext cx="17419320000" cy="502920"/>
-          </a:xfrm>
-          <a:prstGeom prst="rect">
-            <a:avLst/>
-          </a:prstGeom>
-          <a:solidFill>
-            <a:srgbClr val="E2E8F0"/>
+          <p:cNvPr id="13" name="Parallelogram 12"/>
+          <p:cNvSpPr/>
+          <p:nvPr/>
+        </p:nvSpPr>
+        <p:spPr>
+          <a:xfrm>
+            <a:off x="1005839" y="2697480"/>
+            <a:ext cx="320040" cy="457200"/>
+          </a:xfrm>
+          <a:prstGeom prst="parallelogram">
+            <a:avLst/>
+          </a:prstGeom>
+          <a:solidFill>
+            <a:srgbClr val="FFFFFF"/>
           </a:solidFill>
           <a:ln>
             <a:noFill/>
@@ -6799,13 +6935,56 @@
       </p:sp>
       <p:sp>
         <p:nvSpPr>
+          <p:cNvPr id="14" name="Rectangle 13"/>
+          <p:cNvSpPr/>
+          <p:nvPr/>
+        </p:nvSpPr>
+        <p:spPr>
+          <a:xfrm>
+            <a:off x="1078992" y="3246120"/>
+            <a:ext cx="17419320000" cy="457200"/>
+          </a:xfrm>
+          <a:prstGeom prst="rect">
+            <a:avLst/>
+          </a:prstGeom>
+          <a:solidFill>
+            <a:srgbClr val="E2E8F0"/>
+          </a:solidFill>
+          <a:ln>
+            <a:noFill/>
+          </a:ln>
+        </p:spPr>
+        <p:style>
+          <a:lnRef idx="1">
+            <a:schemeClr val="accent1"/>
+          </a:lnRef>
+          <a:fillRef idx="3">
+            <a:schemeClr val="accent1"/>
+          </a:fillRef>
+          <a:effectRef idx="2">
+            <a:schemeClr val="accent1"/>
+          </a:effectRef>
+          <a:fontRef idx="minor">
+            <a:schemeClr val="lt1"/>
+          </a:fontRef>
+        </p:style>
+        <p:txBody>
+          <a:bodyPr rtlCol="0" anchor="ctr"/>
+          <a:lstStyle/>
+          <a:p>
+            <a:pPr algn="ctr"/>
+          </a:p>
+        </p:txBody>
+      </p:sp>
+      <p:sp>
+        <p:nvSpPr>
           <p:cNvPr id="15" name="TextBox 14"/>
           <p:cNvSpPr txBox="1"/>
           <p:nvPr/>
         </p:nvSpPr>
         <p:spPr>
           <a:xfrm>
-            <a:off x="1554480" y="2670048"/>
+            <a:off x="1554480" y="2734056"/>
             <a:ext cx="9814255" cy="731520"/>
           </a:xfrm>
           <a:prstGeom prst="rect">
@@ -6854,19 +7033,17 @@
       </p:sp>
       <p:sp>
         <p:nvSpPr>
-          <p:cNvPr id="16" name="Rounded Rectangle 15"/>
-          <p:cNvSpPr/>
-          <p:nvPr/>
-        </p:nvSpPr>
-        <p:spPr>
-          <a:xfrm>
-            <a:off x="868680" y="3703320"/>
+          <p:cNvPr id="16" name="Diamond 15"/>
+          <p:cNvSpPr/>
+          <p:nvPr/>
+        </p:nvSpPr>
+        <p:spPr>
+          <a:xfrm>
+            <a:off x="868680" y="3749039"/>
             <a:ext cx="457200" cy="457200"/>
           </a:xfrm>
-          <a:prstGeom prst="roundRect">
-            <a:avLst>
-              <a:gd name="adj" fmla="val 15000"/>
-            </a:avLst>
+          <a:prstGeom prst="diamond">
+            <a:avLst/>
           </a:prstGeom>
           <a:solidFill>
             <a:srgbClr val="0A1628"/>
@@ -6899,56 +7076,20 @@
       </p:sp>
       <p:sp>
         <p:nvSpPr>
-          <p:cNvPr id="17" name="TextBox 16"/>
-          <p:cNvSpPr txBox="1"/>
-          <p:nvPr/>
-        </p:nvSpPr>
-        <p:spPr>
-          <a:xfrm>
-            <a:off x="868680" y="3771900"/>
-            <a:ext cx="457200" cy="320040"/>
-          </a:xfrm>
-          <a:prstGeom prst="rect">
-            <a:avLst/>
-          </a:prstGeom>
-          <a:noFill/>
-        </p:spPr>
-        <p:txBody>
-          <a:bodyPr wrap="square">
-            <a:spAutoFit/>
-          </a:bodyPr>
-          <a:lstStyle/>
-          <a:p>
-            <a:pPr algn="ctr">
-              <a:defRPr sz="1600">
-                <a:solidFill>
-                  <a:srgbClr val="FFFFFF"/>
-                </a:solidFill>
-                <a:latin typeface="Calibri"/>
-              </a:defRPr>
-            </a:pPr>
-            <a:r>
-              <a:t>🌐</a:t>
-            </a:r>
-          </a:p>
-        </p:txBody>
-      </p:sp>
-      <p:sp>
-        <p:nvSpPr>
-          <p:cNvPr id="18" name="Rectangle 17"/>
-          <p:cNvSpPr/>
-          <p:nvPr/>
-        </p:nvSpPr>
-        <p:spPr>
-          <a:xfrm>
-            <a:off x="1078992" y="4206240"/>
-            <a:ext cx="17419320000" cy="502920"/>
-          </a:xfrm>
-          <a:prstGeom prst="rect">
-            <a:avLst/>
-          </a:prstGeom>
-          <a:solidFill>
-            <a:srgbClr val="E2E8F0"/>
+          <p:cNvPr id="17" name="Rectangle 16"/>
+          <p:cNvSpPr/>
+          <p:nvPr/>
+        </p:nvSpPr>
+        <p:spPr>
+          <a:xfrm>
+            <a:off x="868680" y="3941063"/>
+            <a:ext cx="457200" cy="73152"/>
+          </a:xfrm>
+          <a:prstGeom prst="rect">
+            <a:avLst/>
+          </a:prstGeom>
+          <a:solidFill>
+            <a:srgbClr val="FFFFFF"/>
           </a:solidFill>
           <a:ln>
             <a:noFill/>
@@ -6978,13 +7119,56 @@
       </p:sp>
       <p:sp>
         <p:nvSpPr>
+          <p:cNvPr id="18" name="Rectangle 17"/>
+          <p:cNvSpPr/>
+          <p:nvPr/>
+        </p:nvSpPr>
+        <p:spPr>
+          <a:xfrm>
+            <a:off x="1078992" y="4297679"/>
+            <a:ext cx="17419320000" cy="457200"/>
+          </a:xfrm>
+          <a:prstGeom prst="rect">
+            <a:avLst/>
+          </a:prstGeom>
+          <a:solidFill>
+            <a:srgbClr val="E2E8F0"/>
+          </a:solidFill>
+          <a:ln>
+            <a:noFill/>
+          </a:ln>
+        </p:spPr>
+        <p:style>
+          <a:lnRef idx="1">
+            <a:schemeClr val="accent1"/>
+          </a:lnRef>
+          <a:fillRef idx="3">
+            <a:schemeClr val="accent1"/>
+          </a:fillRef>
+          <a:effectRef idx="2">
+            <a:schemeClr val="accent1"/>
+          </a:effectRef>
+          <a:fontRef idx="minor">
+            <a:schemeClr val="lt1"/>
+          </a:fontRef>
+        </p:style>
+        <p:txBody>
+          <a:bodyPr rtlCol="0" anchor="ctr"/>
+          <a:lstStyle/>
+          <a:p>
+            <a:pPr algn="ctr"/>
+          </a:p>
+        </p:txBody>
+      </p:sp>
+      <p:sp>
+        <p:nvSpPr>
           <p:cNvPr id="19" name="TextBox 18"/>
           <p:cNvSpPr txBox="1"/>
           <p:nvPr/>
         </p:nvSpPr>
         <p:spPr>
           <a:xfrm>
-            <a:off x="1554480" y="3721607"/>
+            <a:off x="1554480" y="3785615"/>
             <a:ext cx="9814255" cy="731520"/>
           </a:xfrm>
           <a:prstGeom prst="rect">
@@ -7010,7 +7194,7 @@
               </a:defRPr>
             </a:pPr>
             <a:r>
-              <a:t>Pengelolaan domain dan subdomain</a:t>
+              <a:t>Pengelolaan domain &amp; subdomain</a:t>
             </a:r>
           </a:p>
           <a:p>
@@ -7033,19 +7217,17 @@
       </p:sp>
       <p:sp>
         <p:nvSpPr>
-          <p:cNvPr id="20" name="Rounded Rectangle 19"/>
-          <p:cNvSpPr/>
-          <p:nvPr/>
-        </p:nvSpPr>
-        <p:spPr>
-          <a:xfrm>
-            <a:off x="868680" y="4754879"/>
+          <p:cNvPr id="20" name="Pentagon 19"/>
+          <p:cNvSpPr/>
+          <p:nvPr/>
+        </p:nvSpPr>
+        <p:spPr>
+          <a:xfrm>
+            <a:off x="868680" y="4800600"/>
             <a:ext cx="457200" cy="457200"/>
           </a:xfrm>
-          <a:prstGeom prst="roundRect">
-            <a:avLst>
-              <a:gd name="adj" fmla="val 15000"/>
-            </a:avLst>
+          <a:prstGeom prst="homePlate">
+            <a:avLst/>
           </a:prstGeom>
           <a:solidFill>
             <a:srgbClr val="0A1628"/>
@@ -7078,37 +7260,44 @@
       </p:sp>
       <p:sp>
         <p:nvSpPr>
-          <p:cNvPr id="21" name="TextBox 20"/>
-          <p:cNvSpPr txBox="1"/>
-          <p:nvPr/>
-        </p:nvSpPr>
-        <p:spPr>
-          <a:xfrm>
-            <a:off x="868680" y="4823459"/>
-            <a:ext cx="457200" cy="320040"/>
-          </a:xfrm>
-          <a:prstGeom prst="rect">
-            <a:avLst/>
-          </a:prstGeom>
-          <a:noFill/>
-        </p:spPr>
-        <p:txBody>
-          <a:bodyPr wrap="square">
-            <a:spAutoFit/>
-          </a:bodyPr>
-          <a:lstStyle/>
-          <a:p>
-            <a:pPr algn="ctr">
-              <a:defRPr sz="1600">
-                <a:solidFill>
-                  <a:srgbClr val="FFFFFF"/>
-                </a:solidFill>
-                <a:latin typeface="Calibri"/>
-              </a:defRPr>
-            </a:pPr>
-            <a:r>
-              <a:t>⚙</a:t>
-            </a:r>
+          <p:cNvPr id="21" name="Rectangle 20"/>
+          <p:cNvSpPr/>
+          <p:nvPr/>
+        </p:nvSpPr>
+        <p:spPr>
+          <a:xfrm>
+            <a:off x="1005839" y="4937760"/>
+            <a:ext cx="182880" cy="182880"/>
+          </a:xfrm>
+          <a:prstGeom prst="rect">
+            <a:avLst/>
+          </a:prstGeom>
+          <a:solidFill>
+            <a:srgbClr val="FFFFFF"/>
+          </a:solidFill>
+          <a:ln>
+            <a:noFill/>
+          </a:ln>
+        </p:spPr>
+        <p:style>
+          <a:lnRef idx="1">
+            <a:schemeClr val="accent1"/>
+          </a:lnRef>
+          <a:fillRef idx="3">
+            <a:schemeClr val="accent1"/>
+          </a:fillRef>
+          <a:effectRef idx="2">
+            <a:schemeClr val="accent1"/>
+          </a:effectRef>
+          <a:fontRef idx="minor">
+            <a:schemeClr val="lt1"/>
+          </a:fontRef>
+        </p:style>
+        <p:txBody>
+          <a:bodyPr rtlCol="0" anchor="ctr"/>
+          <a:lstStyle/>
+          <a:p>
+            <a:pPr algn="ctr"/>
           </a:p>
         </p:txBody>
       </p:sp>
@@ -7120,7 +7309,7 @@
         </p:nvSpPr>
         <p:spPr>
           <a:xfrm>
-            <a:off x="1554480" y="4773167"/>
+            <a:off x="1554480" y="4837176"/>
             <a:ext cx="9814255" cy="731520"/>
           </a:xfrm>
           <a:prstGeom prst="rect">
@@ -7561,7 +7750,7 @@
         <p:spPr>
           <a:xfrm>
             <a:off x="548640" y="1371600"/>
-            <a:ext cx="91440" cy="4572000"/>
+            <a:ext cx="91440" cy="4754880"/>
           </a:xfrm>
           <a:prstGeom prst="rect">
             <a:avLst/>
@@ -7597,19 +7786,17 @@
       </p:sp>
       <p:sp>
         <p:nvSpPr>
-          <p:cNvPr id="8" name="Rounded Rectangle 7"/>
-          <p:cNvSpPr/>
-          <p:nvPr/>
-        </p:nvSpPr>
-        <p:spPr>
-          <a:xfrm>
-            <a:off x="868680" y="1600200"/>
+          <p:cNvPr id="8" name="Diamond 7"/>
+          <p:cNvSpPr/>
+          <p:nvPr/>
+        </p:nvSpPr>
+        <p:spPr>
+          <a:xfrm>
+            <a:off x="868680" y="1645920"/>
             <a:ext cx="457200" cy="457200"/>
           </a:xfrm>
-          <a:prstGeom prst="roundRect">
-            <a:avLst>
-              <a:gd name="adj" fmla="val 15000"/>
-            </a:avLst>
+          <a:prstGeom prst="diamond">
+            <a:avLst/>
           </a:prstGeom>
           <a:solidFill>
             <a:srgbClr val="0D9488"/>
@@ -7642,56 +7829,20 @@
       </p:sp>
       <p:sp>
         <p:nvSpPr>
-          <p:cNvPr id="9" name="TextBox 8"/>
-          <p:cNvSpPr txBox="1"/>
-          <p:nvPr/>
-        </p:nvSpPr>
-        <p:spPr>
-          <a:xfrm>
-            <a:off x="868680" y="1668780"/>
-            <a:ext cx="457200" cy="320040"/>
-          </a:xfrm>
-          <a:prstGeom prst="rect">
-            <a:avLst/>
-          </a:prstGeom>
-          <a:noFill/>
-        </p:spPr>
-        <p:txBody>
-          <a:bodyPr wrap="square">
-            <a:spAutoFit/>
-          </a:bodyPr>
-          <a:lstStyle/>
-          <a:p>
-            <a:pPr algn="ctr">
-              <a:defRPr sz="1600">
-                <a:solidFill>
-                  <a:srgbClr val="FFFFFF"/>
-                </a:solidFill>
-                <a:latin typeface="Calibri"/>
-              </a:defRPr>
-            </a:pPr>
-            <a:r>
-              <a:t>◆</a:t>
-            </a:r>
-          </a:p>
-        </p:txBody>
-      </p:sp>
-      <p:sp>
-        <p:nvSpPr>
-          <p:cNvPr id="10" name="Rectangle 9"/>
-          <p:cNvSpPr/>
-          <p:nvPr/>
-        </p:nvSpPr>
-        <p:spPr>
-          <a:xfrm>
-            <a:off x="1078992" y="2103120"/>
-            <a:ext cx="17419320000" cy="502920"/>
-          </a:xfrm>
-          <a:prstGeom prst="rect">
-            <a:avLst/>
-          </a:prstGeom>
-          <a:solidFill>
-            <a:srgbClr val="E2E8F0"/>
+          <p:cNvPr id="9" name="Diamond 8"/>
+          <p:cNvSpPr/>
+          <p:nvPr/>
+        </p:nvSpPr>
+        <p:spPr>
+          <a:xfrm>
+            <a:off x="937259" y="1714500"/>
+            <a:ext cx="320040" cy="320040"/>
+          </a:xfrm>
+          <a:prstGeom prst="diamond">
+            <a:avLst/>
+          </a:prstGeom>
+          <a:solidFill>
+            <a:srgbClr val="FFFFFF"/>
           </a:solidFill>
           <a:ln>
             <a:noFill/>
@@ -7721,13 +7872,56 @@
       </p:sp>
       <p:sp>
         <p:nvSpPr>
+          <p:cNvPr id="10" name="Rectangle 9"/>
+          <p:cNvSpPr/>
+          <p:nvPr/>
+        </p:nvSpPr>
+        <p:spPr>
+          <a:xfrm>
+            <a:off x="1078992" y="2194560"/>
+            <a:ext cx="17419320000" cy="457200"/>
+          </a:xfrm>
+          <a:prstGeom prst="rect">
+            <a:avLst/>
+          </a:prstGeom>
+          <a:solidFill>
+            <a:srgbClr val="E2E8F0"/>
+          </a:solidFill>
+          <a:ln>
+            <a:noFill/>
+          </a:ln>
+        </p:spPr>
+        <p:style>
+          <a:lnRef idx="1">
+            <a:schemeClr val="accent1"/>
+          </a:lnRef>
+          <a:fillRef idx="3">
+            <a:schemeClr val="accent1"/>
+          </a:fillRef>
+          <a:effectRef idx="2">
+            <a:schemeClr val="accent1"/>
+          </a:effectRef>
+          <a:fontRef idx="minor">
+            <a:schemeClr val="lt1"/>
+          </a:fontRef>
+        </p:style>
+        <p:txBody>
+          <a:bodyPr rtlCol="0" anchor="ctr"/>
+          <a:lstStyle/>
+          <a:p>
+            <a:pPr algn="ctr"/>
+          </a:p>
+        </p:txBody>
+      </p:sp>
+      <p:sp>
+        <p:nvSpPr>
           <p:cNvPr id="11" name="TextBox 10"/>
           <p:cNvSpPr txBox="1"/>
           <p:nvPr/>
         </p:nvSpPr>
         <p:spPr>
           <a:xfrm>
-            <a:off x="1554480" y="1618488"/>
+            <a:off x="1554480" y="1682496"/>
             <a:ext cx="9814255" cy="731520"/>
           </a:xfrm>
           <a:prstGeom prst="rect">
@@ -7776,19 +7970,17 @@
       </p:sp>
       <p:sp>
         <p:nvSpPr>
-          <p:cNvPr id="12" name="Rounded Rectangle 11"/>
-          <p:cNvSpPr/>
-          <p:nvPr/>
-        </p:nvSpPr>
-        <p:spPr>
-          <a:xfrm>
-            <a:off x="868680" y="2651760"/>
-            <a:ext cx="457200" cy="457200"/>
-          </a:xfrm>
-          <a:prstGeom prst="roundRect">
-            <a:avLst>
-              <a:gd name="adj" fmla="val 15000"/>
-            </a:avLst>
+          <p:cNvPr id="12" name="Rectangle 11"/>
+          <p:cNvSpPr/>
+          <p:nvPr/>
+        </p:nvSpPr>
+        <p:spPr>
+          <a:xfrm>
+            <a:off x="868680" y="2834640"/>
+            <a:ext cx="457200" cy="320040"/>
+          </a:xfrm>
+          <a:prstGeom prst="rect">
+            <a:avLst/>
           </a:prstGeom>
           <a:solidFill>
             <a:srgbClr val="0D9488"/>
@@ -7821,56 +8013,20 @@
       </p:sp>
       <p:sp>
         <p:nvSpPr>
-          <p:cNvPr id="13" name="TextBox 12"/>
-          <p:cNvSpPr txBox="1"/>
-          <p:nvPr/>
-        </p:nvSpPr>
-        <p:spPr>
-          <a:xfrm>
-            <a:off x="868680" y="2720340"/>
-            <a:ext cx="457200" cy="320040"/>
-          </a:xfrm>
-          <a:prstGeom prst="rect">
-            <a:avLst/>
-          </a:prstGeom>
-          <a:noFill/>
-        </p:spPr>
-        <p:txBody>
-          <a:bodyPr wrap="square">
-            <a:spAutoFit/>
-          </a:bodyPr>
-          <a:lstStyle/>
-          <a:p>
-            <a:pPr algn="ctr">
-              <a:defRPr sz="1600">
-                <a:solidFill>
-                  <a:srgbClr val="FFFFFF"/>
-                </a:solidFill>
-                <a:latin typeface="Calibri"/>
-              </a:defRPr>
-            </a:pPr>
-            <a:r>
-              <a:t>🏛</a:t>
-            </a:r>
-          </a:p>
-        </p:txBody>
-      </p:sp>
-      <p:sp>
-        <p:nvSpPr>
-          <p:cNvPr id="14" name="Rectangle 13"/>
-          <p:cNvSpPr/>
-          <p:nvPr/>
-        </p:nvSpPr>
-        <p:spPr>
-          <a:xfrm>
-            <a:off x="1078992" y="3154680"/>
-            <a:ext cx="17419320000" cy="502920"/>
-          </a:xfrm>
-          <a:prstGeom prst="rect">
-            <a:avLst/>
-          </a:prstGeom>
-          <a:solidFill>
-            <a:srgbClr val="E2E8F0"/>
+          <p:cNvPr id="13" name="Isosceles Triangle 12"/>
+          <p:cNvSpPr/>
+          <p:nvPr/>
+        </p:nvSpPr>
+        <p:spPr>
+          <a:xfrm>
+            <a:off x="868680" y="2697480"/>
+            <a:ext cx="457200" cy="228600"/>
+          </a:xfrm>
+          <a:prstGeom prst="triangle">
+            <a:avLst/>
+          </a:prstGeom>
+          <a:solidFill>
+            <a:srgbClr val="0D9488"/>
           </a:solidFill>
           <a:ln>
             <a:noFill/>
@@ -7900,13 +8056,99 @@
       </p:sp>
       <p:sp>
         <p:nvSpPr>
-          <p:cNvPr id="15" name="TextBox 14"/>
+          <p:cNvPr id="14" name="Rectangle 13"/>
+          <p:cNvSpPr/>
+          <p:nvPr/>
+        </p:nvSpPr>
+        <p:spPr>
+          <a:xfrm>
+            <a:off x="1005839" y="2926080"/>
+            <a:ext cx="68580" cy="68580"/>
+          </a:xfrm>
+          <a:prstGeom prst="rect">
+            <a:avLst/>
+          </a:prstGeom>
+          <a:solidFill>
+            <a:srgbClr val="FFFFFF"/>
+          </a:solidFill>
+          <a:ln>
+            <a:noFill/>
+          </a:ln>
+        </p:spPr>
+        <p:style>
+          <a:lnRef idx="1">
+            <a:schemeClr val="accent1"/>
+          </a:lnRef>
+          <a:fillRef idx="3">
+            <a:schemeClr val="accent1"/>
+          </a:fillRef>
+          <a:effectRef idx="2">
+            <a:schemeClr val="accent1"/>
+          </a:effectRef>
+          <a:fontRef idx="minor">
+            <a:schemeClr val="lt1"/>
+          </a:fontRef>
+        </p:style>
+        <p:txBody>
+          <a:bodyPr rtlCol="0" anchor="ctr"/>
+          <a:lstStyle/>
+          <a:p>
+            <a:pPr algn="ctr"/>
+          </a:p>
+        </p:txBody>
+      </p:sp>
+      <p:sp>
+        <p:nvSpPr>
+          <p:cNvPr id="15" name="Rectangle 14"/>
+          <p:cNvSpPr/>
+          <p:nvPr/>
+        </p:nvSpPr>
+        <p:spPr>
+          <a:xfrm>
+            <a:off x="1078992" y="3246120"/>
+            <a:ext cx="17419320000" cy="457200"/>
+          </a:xfrm>
+          <a:prstGeom prst="rect">
+            <a:avLst/>
+          </a:prstGeom>
+          <a:solidFill>
+            <a:srgbClr val="E2E8F0"/>
+          </a:solidFill>
+          <a:ln>
+            <a:noFill/>
+          </a:ln>
+        </p:spPr>
+        <p:style>
+          <a:lnRef idx="1">
+            <a:schemeClr val="accent1"/>
+          </a:lnRef>
+          <a:fillRef idx="3">
+            <a:schemeClr val="accent1"/>
+          </a:fillRef>
+          <a:effectRef idx="2">
+            <a:schemeClr val="accent1"/>
+          </a:effectRef>
+          <a:fontRef idx="minor">
+            <a:schemeClr val="lt1"/>
+          </a:fontRef>
+        </p:style>
+        <p:txBody>
+          <a:bodyPr rtlCol="0" anchor="ctr"/>
+          <a:lstStyle/>
+          <a:p>
+            <a:pPr algn="ctr"/>
+          </a:p>
+        </p:txBody>
+      </p:sp>
+      <p:sp>
+        <p:nvSpPr>
+          <p:cNvPr id="16" name="TextBox 15"/>
           <p:cNvSpPr txBox="1"/>
           <p:nvPr/>
         </p:nvSpPr>
         <p:spPr>
           <a:xfrm>
-            <a:off x="1554480" y="2670048"/>
+            <a:off x="1554480" y="2734056"/>
             <a:ext cx="9814255" cy="731520"/>
           </a:xfrm>
           <a:prstGeom prst="rect">
@@ -7955,19 +8197,17 @@
       </p:sp>
       <p:sp>
         <p:nvSpPr>
-          <p:cNvPr id="16" name="Rounded Rectangle 15"/>
-          <p:cNvSpPr/>
-          <p:nvPr/>
-        </p:nvSpPr>
-        <p:spPr>
-          <a:xfrm>
-            <a:off x="868680" y="3703320"/>
+          <p:cNvPr id="17" name="Rounded Rectangle 16"/>
+          <p:cNvSpPr/>
+          <p:nvPr/>
+        </p:nvSpPr>
+        <p:spPr>
+          <a:xfrm>
+            <a:off x="868680" y="3749039"/>
             <a:ext cx="457200" cy="457200"/>
           </a:xfrm>
           <a:prstGeom prst="roundRect">
-            <a:avLst>
-              <a:gd name="adj" fmla="val 15000"/>
-            </a:avLst>
+            <a:avLst/>
           </a:prstGeom>
           <a:solidFill>
             <a:srgbClr val="0D9488"/>
@@ -8000,56 +8240,20 @@
       </p:sp>
       <p:sp>
         <p:nvSpPr>
-          <p:cNvPr id="17" name="TextBox 16"/>
-          <p:cNvSpPr txBox="1"/>
-          <p:nvPr/>
-        </p:nvSpPr>
-        <p:spPr>
-          <a:xfrm>
-            <a:off x="868680" y="3771900"/>
-            <a:ext cx="457200" cy="320040"/>
-          </a:xfrm>
-          <a:prstGeom prst="rect">
-            <a:avLst/>
-          </a:prstGeom>
-          <a:noFill/>
-        </p:spPr>
-        <p:txBody>
-          <a:bodyPr wrap="square">
-            <a:spAutoFit/>
-          </a:bodyPr>
-          <a:lstStyle/>
-          <a:p>
-            <a:pPr algn="ctr">
-              <a:defRPr sz="1600">
-                <a:solidFill>
-                  <a:srgbClr val="FFFFFF"/>
-                </a:solidFill>
-                <a:latin typeface="Calibri"/>
-              </a:defRPr>
-            </a:pPr>
-            <a:r>
-              <a:t>▣</a:t>
-            </a:r>
-          </a:p>
-        </p:txBody>
-      </p:sp>
-      <p:sp>
-        <p:nvSpPr>
           <p:cNvPr id="18" name="Rectangle 17"/>
           <p:cNvSpPr/>
           <p:nvPr/>
         </p:nvSpPr>
         <p:spPr>
           <a:xfrm>
-            <a:off x="1078992" y="4206240"/>
-            <a:ext cx="17419320000" cy="502920"/>
-          </a:xfrm>
-          <a:prstGeom prst="rect">
-            <a:avLst/>
-          </a:prstGeom>
-          <a:solidFill>
-            <a:srgbClr val="E2E8F0"/>
+            <a:off x="1051560" y="3931920"/>
+            <a:ext cx="91439" cy="91439"/>
+          </a:xfrm>
+          <a:prstGeom prst="rect">
+            <a:avLst/>
+          </a:prstGeom>
+          <a:solidFill>
+            <a:srgbClr val="FFFFFF"/>
           </a:solidFill>
           <a:ln>
             <a:noFill/>
@@ -8079,13 +8283,99 @@
       </p:sp>
       <p:sp>
         <p:nvSpPr>
-          <p:cNvPr id="19" name="TextBox 18"/>
+          <p:cNvPr id="19" name="Rectangle 18"/>
+          <p:cNvSpPr/>
+          <p:nvPr/>
+        </p:nvSpPr>
+        <p:spPr>
+          <a:xfrm>
+            <a:off x="1028700" y="3909059"/>
+            <a:ext cx="137160" cy="137160"/>
+          </a:xfrm>
+          <a:prstGeom prst="rect">
+            <a:avLst/>
+          </a:prstGeom>
+          <a:solidFill>
+            <a:srgbClr val="0D9488"/>
+          </a:solidFill>
+          <a:ln>
+            <a:noFill/>
+          </a:ln>
+        </p:spPr>
+        <p:style>
+          <a:lnRef idx="1">
+            <a:schemeClr val="accent1"/>
+          </a:lnRef>
+          <a:fillRef idx="3">
+            <a:schemeClr val="accent1"/>
+          </a:fillRef>
+          <a:effectRef idx="2">
+            <a:schemeClr val="accent1"/>
+          </a:effectRef>
+          <a:fontRef idx="minor">
+            <a:schemeClr val="lt1"/>
+          </a:fontRef>
+        </p:style>
+        <p:txBody>
+          <a:bodyPr rtlCol="0" anchor="ctr"/>
+          <a:lstStyle/>
+          <a:p>
+            <a:pPr algn="ctr"/>
+          </a:p>
+        </p:txBody>
+      </p:sp>
+      <p:sp>
+        <p:nvSpPr>
+          <p:cNvPr id="20" name="Rectangle 19"/>
+          <p:cNvSpPr/>
+          <p:nvPr/>
+        </p:nvSpPr>
+        <p:spPr>
+          <a:xfrm>
+            <a:off x="1078992" y="4297679"/>
+            <a:ext cx="17419320000" cy="457200"/>
+          </a:xfrm>
+          <a:prstGeom prst="rect">
+            <a:avLst/>
+          </a:prstGeom>
+          <a:solidFill>
+            <a:srgbClr val="E2E8F0"/>
+          </a:solidFill>
+          <a:ln>
+            <a:noFill/>
+          </a:ln>
+        </p:spPr>
+        <p:style>
+          <a:lnRef idx="1">
+            <a:schemeClr val="accent1"/>
+          </a:lnRef>
+          <a:fillRef idx="3">
+            <a:schemeClr val="accent1"/>
+          </a:fillRef>
+          <a:effectRef idx="2">
+            <a:schemeClr val="accent1"/>
+          </a:effectRef>
+          <a:fontRef idx="minor">
+            <a:schemeClr val="lt1"/>
+          </a:fontRef>
+        </p:style>
+        <p:txBody>
+          <a:bodyPr rtlCol="0" anchor="ctr"/>
+          <a:lstStyle/>
+          <a:p>
+            <a:pPr algn="ctr"/>
+          </a:p>
+        </p:txBody>
+      </p:sp>
+      <p:sp>
+        <p:nvSpPr>
+          <p:cNvPr id="21" name="TextBox 20"/>
           <p:cNvSpPr txBox="1"/>
           <p:nvPr/>
         </p:nvSpPr>
         <p:spPr>
           <a:xfrm>
-            <a:off x="1554480" y="3721607"/>
+            <a:off x="1554480" y="3785615"/>
             <a:ext cx="9814255" cy="731520"/>
           </a:xfrm>
           <a:prstGeom prst="rect">
@@ -8134,19 +8424,17 @@
       </p:sp>
       <p:sp>
         <p:nvSpPr>
-          <p:cNvPr id="20" name="Rounded Rectangle 19"/>
-          <p:cNvSpPr/>
-          <p:nvPr/>
-        </p:nvSpPr>
-        <p:spPr>
-          <a:xfrm>
-            <a:off x="868680" y="4754879"/>
-            <a:ext cx="457200" cy="457200"/>
-          </a:xfrm>
-          <a:prstGeom prst="roundRect">
-            <a:avLst>
-              <a:gd name="adj" fmla="val 15000"/>
-            </a:avLst>
+          <p:cNvPr id="22" name="Parallelogram 21"/>
+          <p:cNvSpPr/>
+          <p:nvPr/>
+        </p:nvSpPr>
+        <p:spPr>
+          <a:xfrm>
+            <a:off x="868680" y="4800600"/>
+            <a:ext cx="320040" cy="457200"/>
+          </a:xfrm>
+          <a:prstGeom prst="parallelogram">
+            <a:avLst/>
           </a:prstGeom>
           <a:solidFill>
             <a:srgbClr val="0D9488"/>
@@ -8179,49 +8467,56 @@
       </p:sp>
       <p:sp>
         <p:nvSpPr>
-          <p:cNvPr id="21" name="TextBox 20"/>
+          <p:cNvPr id="23" name="Parallelogram 22"/>
+          <p:cNvSpPr/>
+          <p:nvPr/>
+        </p:nvSpPr>
+        <p:spPr>
+          <a:xfrm>
+            <a:off x="1005839" y="4800600"/>
+            <a:ext cx="320040" cy="457200"/>
+          </a:xfrm>
+          <a:prstGeom prst="parallelogram">
+            <a:avLst/>
+          </a:prstGeom>
+          <a:solidFill>
+            <a:srgbClr val="FFFFFF"/>
+          </a:solidFill>
+          <a:ln>
+            <a:noFill/>
+          </a:ln>
+        </p:spPr>
+        <p:style>
+          <a:lnRef idx="1">
+            <a:schemeClr val="accent1"/>
+          </a:lnRef>
+          <a:fillRef idx="3">
+            <a:schemeClr val="accent1"/>
+          </a:fillRef>
+          <a:effectRef idx="2">
+            <a:schemeClr val="accent1"/>
+          </a:effectRef>
+          <a:fontRef idx="minor">
+            <a:schemeClr val="lt1"/>
+          </a:fontRef>
+        </p:style>
+        <p:txBody>
+          <a:bodyPr rtlCol="0" anchor="ctr"/>
+          <a:lstStyle/>
+          <a:p>
+            <a:pPr algn="ctr"/>
+          </a:p>
+        </p:txBody>
+      </p:sp>
+      <p:sp>
+        <p:nvSpPr>
+          <p:cNvPr id="24" name="TextBox 23"/>
           <p:cNvSpPr txBox="1"/>
           <p:nvPr/>
         </p:nvSpPr>
         <p:spPr>
           <a:xfrm>
-            <a:off x="868680" y="4823459"/>
-            <a:ext cx="457200" cy="320040"/>
-          </a:xfrm>
-          <a:prstGeom prst="rect">
-            <a:avLst/>
-          </a:prstGeom>
-          <a:noFill/>
-        </p:spPr>
-        <p:txBody>
-          <a:bodyPr wrap="square">
-            <a:spAutoFit/>
-          </a:bodyPr>
-          <a:lstStyle/>
-          <a:p>
-            <a:pPr algn="ctr">
-              <a:defRPr sz="1600">
-                <a:solidFill>
-                  <a:srgbClr val="FFFFFF"/>
-                </a:solidFill>
-                <a:latin typeface="Calibri"/>
-              </a:defRPr>
-            </a:pPr>
-            <a:r>
-              <a:t>🔗</a:t>
-            </a:r>
-          </a:p>
-        </p:txBody>
-      </p:sp>
-      <p:sp>
-        <p:nvSpPr>
-          <p:cNvPr id="22" name="TextBox 21"/>
-          <p:cNvSpPr txBox="1"/>
-          <p:nvPr/>
-        </p:nvSpPr>
-        <p:spPr>
-          <a:xfrm>
-            <a:off x="1554480" y="4773167"/>
+            <a:off x="1554480" y="4837176"/>
             <a:ext cx="9814255" cy="731520"/>
           </a:xfrm>
           <a:prstGeom prst="rect">
@@ -8270,7 +8565,7 @@
       </p:sp>
       <p:sp>
         <p:nvSpPr>
-          <p:cNvPr id="23" name="Rectangle 22"/>
+          <p:cNvPr id="25" name="Rectangle 24"/>
           <p:cNvSpPr/>
           <p:nvPr/>
         </p:nvSpPr>
@@ -8313,7 +8608,7 @@
       </p:sp>
       <p:sp>
         <p:nvSpPr>
-          <p:cNvPr id="24" name="Rectangle 23"/>
+          <p:cNvPr id="26" name="Rectangle 25"/>
           <p:cNvSpPr/>
           <p:nvPr/>
         </p:nvSpPr>
@@ -8356,7 +8651,7 @@
       </p:sp>
       <p:sp>
         <p:nvSpPr>
-          <p:cNvPr id="25" name="TextBox 24"/>
+          <p:cNvPr id="27" name="TextBox 26"/>
           <p:cNvSpPr txBox="1"/>
           <p:nvPr/>
         </p:nvSpPr>
@@ -8392,7 +8687,7 @@
       </p:sp>
       <p:sp>
         <p:nvSpPr>
-          <p:cNvPr id="26" name="TextBox 25"/>
+          <p:cNvPr id="28" name="TextBox 27"/>
           <p:cNvSpPr txBox="1"/>
           <p:nvPr/>
         </p:nvSpPr>
@@ -8648,7 +8943,7 @@
               </a:defRPr>
             </a:pPr>
             <a:r>
-              <a:t>Kerangka kerja menuju Sistem Pemerintahan Berbasis Elektronik yang matang</a:t>
+              <a:t>Kerangka kerja menuju SPBE yang matang</a:t>
             </a:r>
           </a:p>
         </p:txBody>
@@ -8662,7 +8957,7 @@
         <p:spPr>
           <a:xfrm>
             <a:off x="548640" y="1371600"/>
-            <a:ext cx="91440" cy="4572000"/>
+            <a:ext cx="91440" cy="4754880"/>
           </a:xfrm>
           <a:prstGeom prst="rect">
             <a:avLst/>
@@ -8698,19 +8993,17 @@
       </p:sp>
       <p:sp>
         <p:nvSpPr>
-          <p:cNvPr id="8" name="Rounded Rectangle 7"/>
-          <p:cNvSpPr/>
-          <p:nvPr/>
-        </p:nvSpPr>
-        <p:spPr>
-          <a:xfrm>
-            <a:off x="868680" y="1600200"/>
+          <p:cNvPr id="8" name="Pentagon 7"/>
+          <p:cNvSpPr/>
+          <p:nvPr/>
+        </p:nvSpPr>
+        <p:spPr>
+          <a:xfrm>
+            <a:off x="868680" y="1645920"/>
             <a:ext cx="457200" cy="457200"/>
           </a:xfrm>
-          <a:prstGeom prst="roundRect">
-            <a:avLst>
-              <a:gd name="adj" fmla="val 15000"/>
-            </a:avLst>
+          <a:prstGeom prst="homePlate">
+            <a:avLst/>
           </a:prstGeom>
           <a:solidFill>
             <a:srgbClr val="1A5676"/>
@@ -8743,56 +9036,20 @@
       </p:sp>
       <p:sp>
         <p:nvSpPr>
-          <p:cNvPr id="9" name="TextBox 8"/>
-          <p:cNvSpPr txBox="1"/>
-          <p:nvPr/>
-        </p:nvSpPr>
-        <p:spPr>
-          <a:xfrm>
-            <a:off x="868680" y="1668780"/>
-            <a:ext cx="457200" cy="320040"/>
-          </a:xfrm>
-          <a:prstGeom prst="rect">
-            <a:avLst/>
-          </a:prstGeom>
-          <a:noFill/>
-        </p:spPr>
-        <p:txBody>
-          <a:bodyPr wrap="square">
-            <a:spAutoFit/>
-          </a:bodyPr>
-          <a:lstStyle/>
-          <a:p>
-            <a:pPr algn="ctr">
-              <a:defRPr sz="1600">
-                <a:solidFill>
-                  <a:srgbClr val="FFFFFF"/>
-                </a:solidFill>
-                <a:latin typeface="Calibri"/>
-              </a:defRPr>
-            </a:pPr>
-            <a:r>
-              <a:t>⚙</a:t>
-            </a:r>
-          </a:p>
-        </p:txBody>
-      </p:sp>
-      <p:sp>
-        <p:nvSpPr>
-          <p:cNvPr id="10" name="Rectangle 9"/>
-          <p:cNvSpPr/>
-          <p:nvPr/>
-        </p:nvSpPr>
-        <p:spPr>
-          <a:xfrm>
-            <a:off x="1078992" y="2103120"/>
-            <a:ext cx="17419320000" cy="502920"/>
-          </a:xfrm>
-          <a:prstGeom prst="rect">
-            <a:avLst/>
-          </a:prstGeom>
-          <a:solidFill>
-            <a:srgbClr val="E2E8F0"/>
+          <p:cNvPr id="9" name="Rectangle 8"/>
+          <p:cNvSpPr/>
+          <p:nvPr/>
+        </p:nvSpPr>
+        <p:spPr>
+          <a:xfrm>
+            <a:off x="1005839" y="1783080"/>
+            <a:ext cx="182880" cy="182880"/>
+          </a:xfrm>
+          <a:prstGeom prst="rect">
+            <a:avLst/>
+          </a:prstGeom>
+          <a:solidFill>
+            <a:srgbClr val="FFFFFF"/>
           </a:solidFill>
           <a:ln>
             <a:noFill/>
@@ -8822,13 +9079,56 @@
       </p:sp>
       <p:sp>
         <p:nvSpPr>
+          <p:cNvPr id="10" name="Rectangle 9"/>
+          <p:cNvSpPr/>
+          <p:nvPr/>
+        </p:nvSpPr>
+        <p:spPr>
+          <a:xfrm>
+            <a:off x="1078992" y="2194560"/>
+            <a:ext cx="17419320000" cy="457200"/>
+          </a:xfrm>
+          <a:prstGeom prst="rect">
+            <a:avLst/>
+          </a:prstGeom>
+          <a:solidFill>
+            <a:srgbClr val="E2E8F0"/>
+          </a:solidFill>
+          <a:ln>
+            <a:noFill/>
+          </a:ln>
+        </p:spPr>
+        <p:style>
+          <a:lnRef idx="1">
+            <a:schemeClr val="accent1"/>
+          </a:lnRef>
+          <a:fillRef idx="3">
+            <a:schemeClr val="accent1"/>
+          </a:fillRef>
+          <a:effectRef idx="2">
+            <a:schemeClr val="accent1"/>
+          </a:effectRef>
+          <a:fontRef idx="minor">
+            <a:schemeClr val="lt1"/>
+          </a:fontRef>
+        </p:style>
+        <p:txBody>
+          <a:bodyPr rtlCol="0" anchor="ctr"/>
+          <a:lstStyle/>
+          <a:p>
+            <a:pPr algn="ctr"/>
+          </a:p>
+        </p:txBody>
+      </p:sp>
+      <p:sp>
+        <p:nvSpPr>
           <p:cNvPr id="11" name="TextBox 10"/>
           <p:cNvSpPr txBox="1"/>
           <p:nvPr/>
         </p:nvSpPr>
         <p:spPr>
           <a:xfrm>
-            <a:off x="1554480" y="1618488"/>
+            <a:off x="1554480" y="1682496"/>
             <a:ext cx="9814255" cy="731520"/>
           </a:xfrm>
           <a:prstGeom prst="rect">
@@ -8877,19 +9177,17 @@
       </p:sp>
       <p:sp>
         <p:nvSpPr>
-          <p:cNvPr id="12" name="Rounded Rectangle 11"/>
-          <p:cNvSpPr/>
-          <p:nvPr/>
-        </p:nvSpPr>
-        <p:spPr>
-          <a:xfrm>
-            <a:off x="868680" y="2651760"/>
+          <p:cNvPr id="12" name="Right Arrow 11"/>
+          <p:cNvSpPr/>
+          <p:nvPr/>
+        </p:nvSpPr>
+        <p:spPr>
+          <a:xfrm>
+            <a:off x="868680" y="2697480"/>
             <a:ext cx="457200" cy="457200"/>
           </a:xfrm>
-          <a:prstGeom prst="roundRect">
-            <a:avLst>
-              <a:gd name="adj" fmla="val 15000"/>
-            </a:avLst>
+          <a:prstGeom prst="rightArrow">
+            <a:avLst/>
           </a:prstGeom>
           <a:solidFill>
             <a:srgbClr val="1A5676"/>
@@ -8922,50 +9220,14 @@
       </p:sp>
       <p:sp>
         <p:nvSpPr>
-          <p:cNvPr id="13" name="TextBox 12"/>
-          <p:cNvSpPr txBox="1"/>
-          <p:nvPr/>
-        </p:nvSpPr>
-        <p:spPr>
-          <a:xfrm>
-            <a:off x="868680" y="2720340"/>
-            <a:ext cx="457200" cy="320040"/>
-          </a:xfrm>
-          <a:prstGeom prst="rect">
-            <a:avLst/>
-          </a:prstGeom>
-          <a:noFill/>
-        </p:spPr>
-        <p:txBody>
-          <a:bodyPr wrap="square">
-            <a:spAutoFit/>
-          </a:bodyPr>
-          <a:lstStyle/>
-          <a:p>
-            <a:pPr algn="ctr">
-              <a:defRPr sz="1600">
-                <a:solidFill>
-                  <a:srgbClr val="FFFFFF"/>
-                </a:solidFill>
-                <a:latin typeface="Calibri"/>
-              </a:defRPr>
-            </a:pPr>
-            <a:r>
-              <a:t>▸</a:t>
-            </a:r>
-          </a:p>
-        </p:txBody>
-      </p:sp>
-      <p:sp>
-        <p:nvSpPr>
-          <p:cNvPr id="14" name="Rectangle 13"/>
-          <p:cNvSpPr/>
-          <p:nvPr/>
-        </p:nvSpPr>
-        <p:spPr>
-          <a:xfrm>
-            <a:off x="1078992" y="3154680"/>
-            <a:ext cx="17419320000" cy="502920"/>
+          <p:cNvPr id="13" name="Rectangle 12"/>
+          <p:cNvSpPr/>
+          <p:nvPr/>
+        </p:nvSpPr>
+        <p:spPr>
+          <a:xfrm>
+            <a:off x="1078992" y="3246120"/>
+            <a:ext cx="17419320000" cy="457200"/>
           </a:xfrm>
           <a:prstGeom prst="rect">
             <a:avLst/>
@@ -9001,13 +9263,13 @@
       </p:sp>
       <p:sp>
         <p:nvSpPr>
-          <p:cNvPr id="15" name="TextBox 14"/>
+          <p:cNvPr id="14" name="TextBox 13"/>
           <p:cNvSpPr txBox="1"/>
           <p:nvPr/>
         </p:nvSpPr>
         <p:spPr>
           <a:xfrm>
-            <a:off x="1554480" y="2670048"/>
+            <a:off x="1554480" y="2734056"/>
             <a:ext cx="9814255" cy="731520"/>
           </a:xfrm>
           <a:prstGeom prst="rect">
@@ -9056,19 +9318,17 @@
       </p:sp>
       <p:sp>
         <p:nvSpPr>
-          <p:cNvPr id="16" name="Rounded Rectangle 15"/>
-          <p:cNvSpPr/>
-          <p:nvPr/>
-        </p:nvSpPr>
-        <p:spPr>
-          <a:xfrm>
-            <a:off x="868680" y="3703320"/>
+          <p:cNvPr id="15" name="Rounded Rectangle 14"/>
+          <p:cNvSpPr/>
+          <p:nvPr/>
+        </p:nvSpPr>
+        <p:spPr>
+          <a:xfrm>
+            <a:off x="868680" y="3749039"/>
             <a:ext cx="457200" cy="457200"/>
           </a:xfrm>
           <a:prstGeom prst="roundRect">
-            <a:avLst>
-              <a:gd name="adj" fmla="val 15000"/>
-            </a:avLst>
+            <a:avLst/>
           </a:prstGeom>
           <a:solidFill>
             <a:srgbClr val="1A5676"/>
@@ -9101,56 +9361,20 @@
       </p:sp>
       <p:sp>
         <p:nvSpPr>
-          <p:cNvPr id="17" name="TextBox 16"/>
-          <p:cNvSpPr txBox="1"/>
-          <p:nvPr/>
-        </p:nvSpPr>
-        <p:spPr>
-          <a:xfrm>
-            <a:off x="868680" y="3771900"/>
-            <a:ext cx="457200" cy="320040"/>
-          </a:xfrm>
-          <a:prstGeom prst="rect">
-            <a:avLst/>
-          </a:prstGeom>
-          <a:noFill/>
-        </p:spPr>
-        <p:txBody>
-          <a:bodyPr wrap="square">
-            <a:spAutoFit/>
-          </a:bodyPr>
-          <a:lstStyle/>
-          <a:p>
-            <a:pPr algn="ctr">
-              <a:defRPr sz="1600">
-                <a:solidFill>
-                  <a:srgbClr val="FFFFFF"/>
-                </a:solidFill>
-                <a:latin typeface="Calibri"/>
-              </a:defRPr>
-            </a:pPr>
-            <a:r>
-              <a:t>▣</a:t>
-            </a:r>
-          </a:p>
-        </p:txBody>
-      </p:sp>
-      <p:sp>
-        <p:nvSpPr>
-          <p:cNvPr id="18" name="Rectangle 17"/>
-          <p:cNvSpPr/>
-          <p:nvPr/>
-        </p:nvSpPr>
-        <p:spPr>
-          <a:xfrm>
-            <a:off x="1078992" y="4206240"/>
-            <a:ext cx="17419320000" cy="502920"/>
-          </a:xfrm>
-          <a:prstGeom prst="rect">
-            <a:avLst/>
-          </a:prstGeom>
-          <a:solidFill>
-            <a:srgbClr val="E2E8F0"/>
+          <p:cNvPr id="16" name="Rectangle 15"/>
+          <p:cNvSpPr/>
+          <p:nvPr/>
+        </p:nvSpPr>
+        <p:spPr>
+          <a:xfrm>
+            <a:off x="1051560" y="3931920"/>
+            <a:ext cx="91439" cy="91439"/>
+          </a:xfrm>
+          <a:prstGeom prst="rect">
+            <a:avLst/>
+          </a:prstGeom>
+          <a:solidFill>
+            <a:srgbClr val="FFFFFF"/>
           </a:solidFill>
           <a:ln>
             <a:noFill/>
@@ -9180,13 +9404,99 @@
       </p:sp>
       <p:sp>
         <p:nvSpPr>
+          <p:cNvPr id="17" name="Rectangle 16"/>
+          <p:cNvSpPr/>
+          <p:nvPr/>
+        </p:nvSpPr>
+        <p:spPr>
+          <a:xfrm>
+            <a:off x="1028700" y="3909059"/>
+            <a:ext cx="137160" cy="137160"/>
+          </a:xfrm>
+          <a:prstGeom prst="rect">
+            <a:avLst/>
+          </a:prstGeom>
+          <a:solidFill>
+            <a:srgbClr val="1A5676"/>
+          </a:solidFill>
+          <a:ln>
+            <a:noFill/>
+          </a:ln>
+        </p:spPr>
+        <p:style>
+          <a:lnRef idx="1">
+            <a:schemeClr val="accent1"/>
+          </a:lnRef>
+          <a:fillRef idx="3">
+            <a:schemeClr val="accent1"/>
+          </a:fillRef>
+          <a:effectRef idx="2">
+            <a:schemeClr val="accent1"/>
+          </a:effectRef>
+          <a:fontRef idx="minor">
+            <a:schemeClr val="lt1"/>
+          </a:fontRef>
+        </p:style>
+        <p:txBody>
+          <a:bodyPr rtlCol="0" anchor="ctr"/>
+          <a:lstStyle/>
+          <a:p>
+            <a:pPr algn="ctr"/>
+          </a:p>
+        </p:txBody>
+      </p:sp>
+      <p:sp>
+        <p:nvSpPr>
+          <p:cNvPr id="18" name="Rectangle 17"/>
+          <p:cNvSpPr/>
+          <p:nvPr/>
+        </p:nvSpPr>
+        <p:spPr>
+          <a:xfrm>
+            <a:off x="1078992" y="4297679"/>
+            <a:ext cx="17419320000" cy="457200"/>
+          </a:xfrm>
+          <a:prstGeom prst="rect">
+            <a:avLst/>
+          </a:prstGeom>
+          <a:solidFill>
+            <a:srgbClr val="E2E8F0"/>
+          </a:solidFill>
+          <a:ln>
+            <a:noFill/>
+          </a:ln>
+        </p:spPr>
+        <p:style>
+          <a:lnRef idx="1">
+            <a:schemeClr val="accent1"/>
+          </a:lnRef>
+          <a:fillRef idx="3">
+            <a:schemeClr val="accent1"/>
+          </a:fillRef>
+          <a:effectRef idx="2">
+            <a:schemeClr val="accent1"/>
+          </a:effectRef>
+          <a:fontRef idx="minor">
+            <a:schemeClr val="lt1"/>
+          </a:fontRef>
+        </p:style>
+        <p:txBody>
+          <a:bodyPr rtlCol="0" anchor="ctr"/>
+          <a:lstStyle/>
+          <a:p>
+            <a:pPr algn="ctr"/>
+          </a:p>
+        </p:txBody>
+      </p:sp>
+      <p:sp>
+        <p:nvSpPr>
           <p:cNvPr id="19" name="TextBox 18"/>
           <p:cNvSpPr txBox="1"/>
           <p:nvPr/>
         </p:nvSpPr>
         <p:spPr>
           <a:xfrm>
-            <a:off x="1554480" y="3721607"/>
+            <a:off x="1554480" y="3785615"/>
             <a:ext cx="9814255" cy="731520"/>
           </a:xfrm>
           <a:prstGeom prst="rect">
@@ -9235,19 +9545,17 @@
       </p:sp>
       <p:sp>
         <p:nvSpPr>
-          <p:cNvPr id="20" name="Rounded Rectangle 19"/>
-          <p:cNvSpPr/>
-          <p:nvPr/>
-        </p:nvSpPr>
-        <p:spPr>
-          <a:xfrm>
-            <a:off x="868680" y="4754879"/>
+          <p:cNvPr id="20" name="Diamond 19"/>
+          <p:cNvSpPr/>
+          <p:nvPr/>
+        </p:nvSpPr>
+        <p:spPr>
+          <a:xfrm>
+            <a:off x="868680" y="4800600"/>
             <a:ext cx="457200" cy="457200"/>
           </a:xfrm>
-          <a:prstGeom prst="roundRect">
-            <a:avLst>
-              <a:gd name="adj" fmla="val 15000"/>
-            </a:avLst>
+          <a:prstGeom prst="diamond">
+            <a:avLst/>
           </a:prstGeom>
           <a:solidFill>
             <a:srgbClr val="1A5676"/>
@@ -9280,37 +9588,44 @@
       </p:sp>
       <p:sp>
         <p:nvSpPr>
-          <p:cNvPr id="21" name="TextBox 20"/>
-          <p:cNvSpPr txBox="1"/>
-          <p:nvPr/>
-        </p:nvSpPr>
-        <p:spPr>
-          <a:xfrm>
-            <a:off x="868680" y="4823459"/>
-            <a:ext cx="457200" cy="320040"/>
-          </a:xfrm>
-          <a:prstGeom prst="rect">
-            <a:avLst/>
-          </a:prstGeom>
-          <a:noFill/>
-        </p:spPr>
-        <p:txBody>
-          <a:bodyPr wrap="square">
-            <a:spAutoFit/>
-          </a:bodyPr>
-          <a:lstStyle/>
-          <a:p>
-            <a:pPr algn="ctr">
-              <a:defRPr sz="1600">
-                <a:solidFill>
-                  <a:srgbClr val="FFFFFF"/>
-                </a:solidFill>
-                <a:latin typeface="Calibri"/>
-              </a:defRPr>
-            </a:pPr>
-            <a:r>
-              <a:t>◆</a:t>
-            </a:r>
+          <p:cNvPr id="21" name="Diamond 20"/>
+          <p:cNvSpPr/>
+          <p:nvPr/>
+        </p:nvSpPr>
+        <p:spPr>
+          <a:xfrm>
+            <a:off x="937259" y="4869180"/>
+            <a:ext cx="320040" cy="320040"/>
+          </a:xfrm>
+          <a:prstGeom prst="diamond">
+            <a:avLst/>
+          </a:prstGeom>
+          <a:solidFill>
+            <a:srgbClr val="FFFFFF"/>
+          </a:solidFill>
+          <a:ln>
+            <a:noFill/>
+          </a:ln>
+        </p:spPr>
+        <p:style>
+          <a:lnRef idx="1">
+            <a:schemeClr val="accent1"/>
+          </a:lnRef>
+          <a:fillRef idx="3">
+            <a:schemeClr val="accent1"/>
+          </a:fillRef>
+          <a:effectRef idx="2">
+            <a:schemeClr val="accent1"/>
+          </a:effectRef>
+          <a:fontRef idx="minor">
+            <a:schemeClr val="lt1"/>
+          </a:fontRef>
+        </p:style>
+        <p:txBody>
+          <a:bodyPr rtlCol="0" anchor="ctr"/>
+          <a:lstStyle/>
+          <a:p>
+            <a:pPr algn="ctr"/>
           </a:p>
         </p:txBody>
       </p:sp>
@@ -9322,7 +9637,7 @@
         </p:nvSpPr>
         <p:spPr>
           <a:xfrm>
-            <a:off x="1554480" y="4773167"/>
+            <a:off x="1554480" y="4837176"/>
             <a:ext cx="9814255" cy="731520"/>
           </a:xfrm>
           <a:prstGeom prst="rect">
@@ -9647,14 +9962,14 @@
         </p:nvSpPr>
         <p:spPr>
           <a:xfrm>
-            <a:off x="9265615" y="3657600"/>
-            <a:ext cx="3657600" cy="3657600"/>
-          </a:xfrm>
-          <a:prstGeom prst="rect">
-            <a:avLst/>
-          </a:prstGeom>
-          <a:solidFill>
-            <a:srgbClr val="0F2A4A"/>
+            <a:off x="0" y="6601968"/>
+            <a:ext cx="12191695" cy="256032"/>
+          </a:xfrm>
+          <a:prstGeom prst="rect">
+            <a:avLst/>
+          </a:prstGeom>
+          <a:solidFill>
+            <a:srgbClr val="0D9488"/>
           </a:solidFill>
           <a:ln>
             <a:noFill/>
@@ -9684,16 +9999,16 @@
       </p:sp>
       <p:sp>
         <p:nvSpPr>
-          <p:cNvPr id="5" name="Rectangle 4"/>
-          <p:cNvSpPr/>
-          <p:nvPr/>
-        </p:nvSpPr>
-        <p:spPr>
-          <a:xfrm>
-            <a:off x="0" y="6601968"/>
-            <a:ext cx="12191695" cy="256032"/>
-          </a:xfrm>
-          <a:prstGeom prst="rect">
+          <p:cNvPr id="5" name="Diamond 4"/>
+          <p:cNvSpPr/>
+          <p:nvPr/>
+        </p:nvSpPr>
+        <p:spPr>
+          <a:xfrm>
+            <a:off x="5730087" y="1097280"/>
+            <a:ext cx="731520" cy="731520"/>
+          </a:xfrm>
+          <a:prstGeom prst="diamond">
             <a:avLst/>
           </a:prstGeom>
           <a:solidFill>
@@ -9727,22 +10042,20 @@
       </p:sp>
       <p:sp>
         <p:nvSpPr>
-          <p:cNvPr id="6" name="Rounded Rectangle 5"/>
-          <p:cNvSpPr/>
-          <p:nvPr/>
-        </p:nvSpPr>
-        <p:spPr>
-          <a:xfrm>
-            <a:off x="5684367" y="1188720"/>
-            <a:ext cx="822960" cy="822960"/>
-          </a:xfrm>
-          <a:prstGeom prst="roundRect">
-            <a:avLst>
-              <a:gd name="adj" fmla="val 15000"/>
-            </a:avLst>
-          </a:prstGeom>
-          <a:solidFill>
-            <a:srgbClr val="0D9488"/>
+          <p:cNvPr id="6" name="Diamond 5"/>
+          <p:cNvSpPr/>
+          <p:nvPr/>
+        </p:nvSpPr>
+        <p:spPr>
+          <a:xfrm>
+            <a:off x="5839815" y="1207007"/>
+            <a:ext cx="512063" cy="512063"/>
+          </a:xfrm>
+          <a:prstGeom prst="diamond">
+            <a:avLst/>
+          </a:prstGeom>
+          <a:solidFill>
+            <a:srgbClr val="FFFFFF"/>
           </a:solidFill>
           <a:ln>
             <a:noFill/>
@@ -9773,42 +10086,6 @@
       <p:sp>
         <p:nvSpPr>
           <p:cNvPr id="7" name="TextBox 6"/>
-          <p:cNvSpPr txBox="1"/>
-          <p:nvPr/>
-        </p:nvSpPr>
-        <p:spPr>
-          <a:xfrm>
-            <a:off x="5684367" y="1312164"/>
-            <a:ext cx="822960" cy="576072"/>
-          </a:xfrm>
-          <a:prstGeom prst="rect">
-            <a:avLst/>
-          </a:prstGeom>
-          <a:noFill/>
-        </p:spPr>
-        <p:txBody>
-          <a:bodyPr wrap="square">
-            <a:spAutoFit/>
-          </a:bodyPr>
-          <a:lstStyle/>
-          <a:p>
-            <a:pPr algn="ctr">
-              <a:defRPr sz="3000">
-                <a:solidFill>
-                  <a:srgbClr val="FFFFFF"/>
-                </a:solidFill>
-                <a:latin typeface="Calibri"/>
-              </a:defRPr>
-            </a:pPr>
-            <a:r>
-              <a:t>◆</a:t>
-            </a:r>
-          </a:p>
-        </p:txBody>
-      </p:sp>
-      <p:sp>
-        <p:nvSpPr>
-          <p:cNvPr id="8" name="TextBox 7"/>
           <p:cNvSpPr txBox="1"/>
           <p:nvPr/>
         </p:nvSpPr>
@@ -9844,7 +10121,7 @@
       </p:sp>
       <p:sp>
         <p:nvSpPr>
-          <p:cNvPr id="9" name="TextBox 8"/>
+          <p:cNvPr id="8" name="TextBox 7"/>
           <p:cNvSpPr txBox="1"/>
           <p:nvPr/>
         </p:nvSpPr>
@@ -9880,7 +10157,7 @@
       </p:sp>
       <p:sp>
         <p:nvSpPr>
-          <p:cNvPr id="10" name="Rectangle 9"/>
+          <p:cNvPr id="9" name="Rectangle 8"/>
           <p:cNvSpPr/>
           <p:nvPr/>
         </p:nvSpPr>
@@ -9923,7 +10200,7 @@
       </p:sp>
       <p:sp>
         <p:nvSpPr>
-          <p:cNvPr id="11" name="TextBox 10"/>
+          <p:cNvPr id="10" name="TextBox 9"/>
           <p:cNvSpPr txBox="1"/>
           <p:nvPr/>
         </p:nvSpPr>

</xml_diff>

<commit_message>
feat: icon pake EMOJI — colorful & simple
- Semua icon ganti pake emoji: 📊 💻 ⚙️ 🌆 🌐 📱 🔗 ✅ ⭐ 👥 📋 📝
- Background square biar keliatan rapi & konsisten
- No shape icons (too complex), no circles/ovals
- Perkataan tetap improved & strategis
- 7 slide — total 137 shapes
</commit_message>
<xml_diff>
--- a/RESUME_TUPOKSI_egov.pptx
+++ b/RESUME_TUPOKSI_egov.pptx
@@ -3319,93 +3319,43 @@
       </p:sp>
       <p:sp>
         <p:nvSpPr>
-          <p:cNvPr id="7" name="Rectangle 6"/>
-          <p:cNvSpPr/>
-          <p:nvPr/>
-        </p:nvSpPr>
-        <p:spPr>
-          <a:xfrm>
-            <a:off x="1005839" y="1554480"/>
-            <a:ext cx="365760" cy="365760"/>
-          </a:xfrm>
-          <a:prstGeom prst="rect">
-            <a:avLst/>
-          </a:prstGeom>
-          <a:solidFill>
-            <a:srgbClr val="FFFFFF"/>
-          </a:solidFill>
-          <a:ln>
-            <a:noFill/>
-          </a:ln>
-        </p:spPr>
-        <p:style>
-          <a:lnRef idx="1">
-            <a:schemeClr val="accent1"/>
-          </a:lnRef>
-          <a:fillRef idx="3">
-            <a:schemeClr val="accent1"/>
-          </a:fillRef>
-          <a:effectRef idx="2">
-            <a:schemeClr val="accent1"/>
-          </a:effectRef>
-          <a:fontRef idx="minor">
-            <a:schemeClr val="lt1"/>
-          </a:fontRef>
-        </p:style>
-        <p:txBody>
-          <a:bodyPr rtlCol="0" anchor="ctr"/>
-          <a:lstStyle/>
-          <a:p>
-            <a:pPr algn="ctr"/>
-          </a:p>
-        </p:txBody>
-      </p:sp>
-      <p:sp>
-        <p:nvSpPr>
-          <p:cNvPr id="8" name="Rectangle 7"/>
-          <p:cNvSpPr/>
-          <p:nvPr/>
-        </p:nvSpPr>
-        <p:spPr>
-          <a:xfrm>
-            <a:off x="1120139" y="1668780"/>
-            <a:ext cx="137160" cy="137160"/>
-          </a:xfrm>
-          <a:prstGeom prst="rect">
-            <a:avLst/>
-          </a:prstGeom>
-          <a:solidFill>
-            <a:srgbClr val="0D9488"/>
-          </a:solidFill>
-          <a:ln>
-            <a:noFill/>
-          </a:ln>
-        </p:spPr>
-        <p:style>
-          <a:lnRef idx="1">
-            <a:schemeClr val="accent1"/>
-          </a:lnRef>
-          <a:fillRef idx="3">
-            <a:schemeClr val="accent1"/>
-          </a:fillRef>
-          <a:effectRef idx="2">
-            <a:schemeClr val="accent1"/>
-          </a:effectRef>
-          <a:fontRef idx="minor">
-            <a:schemeClr val="lt1"/>
-          </a:fontRef>
-        </p:style>
-        <p:txBody>
-          <a:bodyPr rtlCol="0" anchor="ctr"/>
-          <a:lstStyle/>
-          <a:p>
-            <a:pPr algn="ctr"/>
-          </a:p>
-        </p:txBody>
-      </p:sp>
-      <p:sp>
-        <p:nvSpPr>
-          <p:cNvPr id="9" name="TextBox 8"/>
+          <p:cNvPr id="7" name="TextBox 6"/>
+          <p:cNvSpPr txBox="1"/>
+          <p:nvPr/>
+        </p:nvSpPr>
+        <p:spPr>
+          <a:xfrm>
+            <a:off x="822959" y="1430121"/>
+            <a:ext cx="731520" cy="621792"/>
+          </a:xfrm>
+          <a:prstGeom prst="rect">
+            <a:avLst/>
+          </a:prstGeom>
+          <a:noFill/>
+        </p:spPr>
+        <p:txBody>
+          <a:bodyPr wrap="none">
+            <a:spAutoFit/>
+          </a:bodyPr>
+          <a:lstStyle/>
+          <a:p>
+            <a:pPr algn="ctr">
+              <a:defRPr sz="2800">
+                <a:solidFill>
+                  <a:srgbClr val="FFFFFF"/>
+                </a:solidFill>
+                <a:latin typeface="Segoe UI Emoji"/>
+              </a:defRPr>
+            </a:pPr>
+            <a:r>
+              <a:t>📊</a:t>
+            </a:r>
+          </a:p>
+        </p:txBody>
+      </p:sp>
+      <p:sp>
+        <p:nvSpPr>
+          <p:cNvPr id="8" name="TextBox 7"/>
           <p:cNvSpPr txBox="1"/>
           <p:nvPr/>
         </p:nvSpPr>
@@ -3441,7 +3391,7 @@
       </p:sp>
       <p:sp>
         <p:nvSpPr>
-          <p:cNvPr id="10" name="TextBox 9"/>
+          <p:cNvPr id="9" name="TextBox 8"/>
           <p:cNvSpPr txBox="1"/>
           <p:nvPr/>
         </p:nvSpPr>
@@ -3477,7 +3427,7 @@
       </p:sp>
       <p:sp>
         <p:nvSpPr>
-          <p:cNvPr id="11" name="TextBox 10"/>
+          <p:cNvPr id="10" name="TextBox 9"/>
           <p:cNvSpPr txBox="1"/>
           <p:nvPr/>
         </p:nvSpPr>
@@ -3513,7 +3463,7 @@
       </p:sp>
       <p:sp>
         <p:nvSpPr>
-          <p:cNvPr id="12" name="Rectangle 11"/>
+          <p:cNvPr id="11" name="Rectangle 10"/>
           <p:cNvSpPr/>
           <p:nvPr/>
         </p:nvSpPr>
@@ -3556,7 +3506,7 @@
       </p:sp>
       <p:sp>
         <p:nvSpPr>
-          <p:cNvPr id="13" name="TextBox 12"/>
+          <p:cNvPr id="12" name="TextBox 11"/>
           <p:cNvSpPr txBox="1"/>
           <p:nvPr/>
         </p:nvSpPr>
@@ -3825,8 +3775,8 @@
         </p:nvSpPr>
         <p:spPr>
           <a:xfrm>
-            <a:off x="548639" y="1371600"/>
-            <a:ext cx="3484778" cy="3840480"/>
+            <a:off x="548639" y="1417320"/>
+            <a:ext cx="3484778" cy="3657600"/>
           </a:xfrm>
           <a:prstGeom prst="roundRect">
             <a:avLst>
@@ -3872,7 +3822,7 @@
         </p:nvSpPr>
         <p:spPr>
           <a:xfrm>
-            <a:off x="548639" y="1371600"/>
+            <a:off x="548639" y="1417320"/>
             <a:ext cx="3484778" cy="73152"/>
           </a:xfrm>
           <a:prstGeom prst="rect">
@@ -3915,7 +3865,7 @@
         </p:nvSpPr>
         <p:spPr>
           <a:xfrm>
-            <a:off x="777239" y="1645920"/>
+            <a:off x="777239" y="1691640"/>
             <a:ext cx="502920" cy="502920"/>
           </a:xfrm>
           <a:prstGeom prst="roundRect">
@@ -3952,99 +3902,49 @@
       </p:sp>
       <p:sp>
         <p:nvSpPr>
-          <p:cNvPr id="10" name="Rectangle 9"/>
-          <p:cNvSpPr/>
-          <p:nvPr/>
-        </p:nvSpPr>
-        <p:spPr>
-          <a:xfrm>
-            <a:off x="960119" y="1828800"/>
-            <a:ext cx="137160" cy="137160"/>
-          </a:xfrm>
-          <a:prstGeom prst="rect">
-            <a:avLst/>
-          </a:prstGeom>
-          <a:solidFill>
-            <a:srgbClr val="FFFFFF"/>
-          </a:solidFill>
-          <a:ln>
-            <a:noFill/>
-          </a:ln>
-        </p:spPr>
-        <p:style>
-          <a:lnRef idx="1">
-            <a:schemeClr val="accent1"/>
-          </a:lnRef>
-          <a:fillRef idx="3">
-            <a:schemeClr val="accent1"/>
-          </a:fillRef>
-          <a:effectRef idx="2">
-            <a:schemeClr val="accent1"/>
-          </a:effectRef>
-          <a:fontRef idx="minor">
-            <a:schemeClr val="lt1"/>
-          </a:fontRef>
-        </p:style>
-        <p:txBody>
-          <a:bodyPr rtlCol="0" anchor="ctr"/>
-          <a:lstStyle/>
-          <a:p>
-            <a:pPr algn="ctr"/>
-          </a:p>
-        </p:txBody>
-      </p:sp>
-      <p:sp>
-        <p:nvSpPr>
-          <p:cNvPr id="11" name="Rectangle 10"/>
-          <p:cNvSpPr/>
-          <p:nvPr/>
-        </p:nvSpPr>
-        <p:spPr>
-          <a:xfrm>
-            <a:off x="960119" y="1828800"/>
-            <a:ext cx="137160" cy="137160"/>
-          </a:xfrm>
-          <a:prstGeom prst="rect">
-            <a:avLst/>
-          </a:prstGeom>
-          <a:solidFill>
-            <a:srgbClr val="0A1628"/>
-          </a:solidFill>
-          <a:ln>
-            <a:noFill/>
-          </a:ln>
-        </p:spPr>
-        <p:style>
-          <a:lnRef idx="1">
-            <a:schemeClr val="accent1"/>
-          </a:lnRef>
-          <a:fillRef idx="3">
-            <a:schemeClr val="accent1"/>
-          </a:fillRef>
-          <a:effectRef idx="2">
-            <a:schemeClr val="accent1"/>
-          </a:effectRef>
-          <a:fontRef idx="minor">
-            <a:schemeClr val="lt1"/>
-          </a:fontRef>
-        </p:style>
-        <p:txBody>
-          <a:bodyPr rtlCol="0" anchor="ctr"/>
-          <a:lstStyle/>
-          <a:p>
-            <a:pPr algn="ctr"/>
-          </a:p>
-        </p:txBody>
-      </p:sp>
-      <p:sp>
-        <p:nvSpPr>
-          <p:cNvPr id="12" name="TextBox 11"/>
+          <p:cNvPr id="10" name="TextBox 9"/>
           <p:cNvSpPr txBox="1"/>
           <p:nvPr/>
         </p:nvSpPr>
         <p:spPr>
           <a:xfrm>
-            <a:off x="1417319" y="1719072"/>
+            <a:off x="777239" y="1731873"/>
+            <a:ext cx="502920" cy="427482"/>
+          </a:xfrm>
+          <a:prstGeom prst="rect">
+            <a:avLst/>
+          </a:prstGeom>
+          <a:noFill/>
+        </p:spPr>
+        <p:txBody>
+          <a:bodyPr wrap="none">
+            <a:spAutoFit/>
+          </a:bodyPr>
+          <a:lstStyle/>
+          <a:p>
+            <a:pPr algn="ctr">
+              <a:defRPr sz="1900">
+                <a:solidFill>
+                  <a:srgbClr val="FFFFFF"/>
+                </a:solidFill>
+                <a:latin typeface="Segoe UI Emoji"/>
+              </a:defRPr>
+            </a:pPr>
+            <a:r>
+              <a:t>💻</a:t>
+            </a:r>
+          </a:p>
+        </p:txBody>
+      </p:sp>
+      <p:sp>
+        <p:nvSpPr>
+          <p:cNvPr id="11" name="TextBox 10"/>
+          <p:cNvSpPr txBox="1"/>
+          <p:nvPr/>
+        </p:nvSpPr>
+        <p:spPr>
+          <a:xfrm>
+            <a:off x="1417319" y="1764792"/>
             <a:ext cx="457200" cy="274320"/>
           </a:xfrm>
           <a:prstGeom prst="rect">
@@ -4074,7 +3974,7 @@
       </p:sp>
       <p:sp>
         <p:nvSpPr>
-          <p:cNvPr id="13" name="TextBox 12"/>
+          <p:cNvPr id="12" name="TextBox 11"/>
           <p:cNvSpPr txBox="1"/>
           <p:nvPr/>
         </p:nvSpPr>
@@ -4114,13 +4014,13 @@
       </p:sp>
       <p:sp>
         <p:nvSpPr>
-          <p:cNvPr id="14" name="Rectangle 13"/>
+          <p:cNvPr id="13" name="Rectangle 12"/>
           <p:cNvSpPr/>
           <p:nvPr/>
         </p:nvSpPr>
         <p:spPr>
           <a:xfrm>
-            <a:off x="777239" y="3291840"/>
+            <a:off x="777239" y="3291839"/>
             <a:ext cx="3027578" cy="17419320000"/>
           </a:xfrm>
           <a:prstGeom prst="rect">
@@ -4157,14 +4057,14 @@
       </p:sp>
       <p:sp>
         <p:nvSpPr>
-          <p:cNvPr id="15" name="TextBox 14"/>
+          <p:cNvPr id="14" name="TextBox 13"/>
           <p:cNvSpPr txBox="1"/>
           <p:nvPr/>
         </p:nvSpPr>
         <p:spPr>
           <a:xfrm>
             <a:off x="777239" y="3474720"/>
-            <a:ext cx="3027578" cy="1463040"/>
+            <a:ext cx="3027578" cy="1371600"/>
           </a:xfrm>
           <a:prstGeom prst="rect">
             <a:avLst/>
@@ -4205,14 +4105,14 @@
       </p:sp>
       <p:sp>
         <p:nvSpPr>
-          <p:cNvPr id="16" name="Rounded Rectangle 15"/>
+          <p:cNvPr id="15" name="Rounded Rectangle 14"/>
           <p:cNvSpPr/>
           <p:nvPr/>
         </p:nvSpPr>
         <p:spPr>
           <a:xfrm>
-            <a:off x="4353458" y="1371600"/>
-            <a:ext cx="3484778" cy="3840480"/>
+            <a:off x="4353458" y="1417320"/>
+            <a:ext cx="3484778" cy="3657600"/>
           </a:xfrm>
           <a:prstGeom prst="roundRect">
             <a:avLst>
@@ -4252,13 +4152,13 @@
       </p:sp>
       <p:sp>
         <p:nvSpPr>
-          <p:cNvPr id="17" name="Rectangle 16"/>
+          <p:cNvPr id="16" name="Rectangle 15"/>
           <p:cNvSpPr/>
           <p:nvPr/>
         </p:nvSpPr>
         <p:spPr>
           <a:xfrm>
-            <a:off x="4353458" y="1371600"/>
+            <a:off x="4353458" y="1417320"/>
             <a:ext cx="3484778" cy="73152"/>
           </a:xfrm>
           <a:prstGeom prst="rect">
@@ -4295,16 +4195,16 @@
       </p:sp>
       <p:sp>
         <p:nvSpPr>
-          <p:cNvPr id="18" name="Pentagon 17"/>
+          <p:cNvPr id="17" name="Rounded Rectangle 16"/>
           <p:cNvSpPr/>
           <p:nvPr/>
         </p:nvSpPr>
         <p:spPr>
           <a:xfrm>
-            <a:off x="4582058" y="1645920"/>
+            <a:off x="4582058" y="1691640"/>
             <a:ext cx="502920" cy="502920"/>
           </a:xfrm>
-          <a:prstGeom prst="homePlate">
+          <a:prstGeom prst="roundRect">
             <a:avLst/>
           </a:prstGeom>
           <a:solidFill>
@@ -4338,56 +4238,49 @@
       </p:sp>
       <p:sp>
         <p:nvSpPr>
-          <p:cNvPr id="19" name="Rectangle 18"/>
-          <p:cNvSpPr/>
-          <p:nvPr/>
-        </p:nvSpPr>
-        <p:spPr>
-          <a:xfrm>
-            <a:off x="4732934" y="1796796"/>
-            <a:ext cx="201168" cy="201168"/>
-          </a:xfrm>
-          <a:prstGeom prst="rect">
-            <a:avLst/>
-          </a:prstGeom>
-          <a:solidFill>
-            <a:srgbClr val="FFFFFF"/>
-          </a:solidFill>
-          <a:ln>
-            <a:noFill/>
-          </a:ln>
-        </p:spPr>
-        <p:style>
-          <a:lnRef idx="1">
-            <a:schemeClr val="accent1"/>
-          </a:lnRef>
-          <a:fillRef idx="3">
-            <a:schemeClr val="accent1"/>
-          </a:fillRef>
-          <a:effectRef idx="2">
-            <a:schemeClr val="accent1"/>
-          </a:effectRef>
-          <a:fontRef idx="minor">
-            <a:schemeClr val="lt1"/>
-          </a:fontRef>
-        </p:style>
-        <p:txBody>
-          <a:bodyPr rtlCol="0" anchor="ctr"/>
-          <a:lstStyle/>
-          <a:p>
-            <a:pPr algn="ctr"/>
-          </a:p>
-        </p:txBody>
-      </p:sp>
-      <p:sp>
-        <p:nvSpPr>
-          <p:cNvPr id="20" name="TextBox 19"/>
+          <p:cNvPr id="18" name="TextBox 17"/>
           <p:cNvSpPr txBox="1"/>
           <p:nvPr/>
         </p:nvSpPr>
         <p:spPr>
           <a:xfrm>
-            <a:off x="5222138" y="1719072"/>
+            <a:off x="4582058" y="1731873"/>
+            <a:ext cx="502920" cy="427482"/>
+          </a:xfrm>
+          <a:prstGeom prst="rect">
+            <a:avLst/>
+          </a:prstGeom>
+          <a:noFill/>
+        </p:spPr>
+        <p:txBody>
+          <a:bodyPr wrap="none">
+            <a:spAutoFit/>
+          </a:bodyPr>
+          <a:lstStyle/>
+          <a:p>
+            <a:pPr algn="ctr">
+              <a:defRPr sz="1900">
+                <a:solidFill>
+                  <a:srgbClr val="FFFFFF"/>
+                </a:solidFill>
+                <a:latin typeface="Segoe UI Emoji"/>
+              </a:defRPr>
+            </a:pPr>
+            <a:r>
+              <a:t>⚙️</a:t>
+            </a:r>
+          </a:p>
+        </p:txBody>
+      </p:sp>
+      <p:sp>
+        <p:nvSpPr>
+          <p:cNvPr id="19" name="TextBox 18"/>
+          <p:cNvSpPr txBox="1"/>
+          <p:nvPr/>
+        </p:nvSpPr>
+        <p:spPr>
+          <a:xfrm>
+            <a:off x="5222138" y="1764792"/>
             <a:ext cx="457200" cy="274320"/>
           </a:xfrm>
           <a:prstGeom prst="rect">
@@ -4417,7 +4310,7 @@
       </p:sp>
       <p:sp>
         <p:nvSpPr>
-          <p:cNvPr id="21" name="TextBox 20"/>
+          <p:cNvPr id="20" name="TextBox 19"/>
           <p:cNvSpPr txBox="1"/>
           <p:nvPr/>
         </p:nvSpPr>
@@ -4453,13 +4346,13 @@
       </p:sp>
       <p:sp>
         <p:nvSpPr>
-          <p:cNvPr id="22" name="Rectangle 21"/>
+          <p:cNvPr id="21" name="Rectangle 20"/>
           <p:cNvSpPr/>
           <p:nvPr/>
         </p:nvSpPr>
         <p:spPr>
           <a:xfrm>
-            <a:off x="4582058" y="3291840"/>
+            <a:off x="4582058" y="3291839"/>
             <a:ext cx="3027578" cy="17419320000"/>
           </a:xfrm>
           <a:prstGeom prst="rect">
@@ -4496,14 +4389,14 @@
       </p:sp>
       <p:sp>
         <p:nvSpPr>
-          <p:cNvPr id="23" name="TextBox 22"/>
+          <p:cNvPr id="22" name="TextBox 21"/>
           <p:cNvSpPr txBox="1"/>
           <p:nvPr/>
         </p:nvSpPr>
         <p:spPr>
           <a:xfrm>
             <a:off x="4582058" y="3474720"/>
-            <a:ext cx="3027578" cy="1463040"/>
+            <a:ext cx="3027578" cy="1371600"/>
           </a:xfrm>
           <a:prstGeom prst="rect">
             <a:avLst/>
@@ -4544,14 +4437,14 @@
       </p:sp>
       <p:sp>
         <p:nvSpPr>
-          <p:cNvPr id="24" name="Rounded Rectangle 23"/>
+          <p:cNvPr id="23" name="Rounded Rectangle 22"/>
           <p:cNvSpPr/>
           <p:nvPr/>
         </p:nvSpPr>
         <p:spPr>
           <a:xfrm>
-            <a:off x="8158276" y="1371600"/>
-            <a:ext cx="3484778" cy="3840480"/>
+            <a:off x="8158276" y="1417320"/>
+            <a:ext cx="3484778" cy="3657600"/>
           </a:xfrm>
           <a:prstGeom prst="roundRect">
             <a:avLst>
@@ -4591,13 +4484,13 @@
       </p:sp>
       <p:sp>
         <p:nvSpPr>
-          <p:cNvPr id="25" name="Rectangle 24"/>
+          <p:cNvPr id="24" name="Rectangle 23"/>
           <p:cNvSpPr/>
           <p:nvPr/>
         </p:nvSpPr>
         <p:spPr>
           <a:xfrm>
-            <a:off x="8158276" y="1371600"/>
+            <a:off x="8158276" y="1417320"/>
             <a:ext cx="3484778" cy="73152"/>
           </a:xfrm>
           <a:prstGeom prst="rect">
@@ -4634,16 +4527,16 @@
       </p:sp>
       <p:sp>
         <p:nvSpPr>
-          <p:cNvPr id="26" name="Rectangle 25"/>
+          <p:cNvPr id="25" name="Rounded Rectangle 24"/>
           <p:cNvSpPr/>
           <p:nvPr/>
         </p:nvSpPr>
         <p:spPr>
           <a:xfrm>
-            <a:off x="8386876" y="1796796"/>
-            <a:ext cx="502920" cy="352044"/>
-          </a:xfrm>
-          <a:prstGeom prst="rect">
+            <a:off x="8386876" y="1691640"/>
+            <a:ext cx="502920" cy="502920"/>
+          </a:xfrm>
+          <a:prstGeom prst="roundRect">
             <a:avLst/>
           </a:prstGeom>
           <a:solidFill>
@@ -4677,99 +4570,49 @@
       </p:sp>
       <p:sp>
         <p:nvSpPr>
-          <p:cNvPr id="27" name="Isosceles Triangle 26"/>
-          <p:cNvSpPr/>
-          <p:nvPr/>
-        </p:nvSpPr>
-        <p:spPr>
-          <a:xfrm>
-            <a:off x="8386876" y="1645920"/>
-            <a:ext cx="502920" cy="251460"/>
-          </a:xfrm>
-          <a:prstGeom prst="triangle">
-            <a:avLst/>
-          </a:prstGeom>
-          <a:solidFill>
-            <a:srgbClr val="0D9488"/>
-          </a:solidFill>
-          <a:ln>
-            <a:noFill/>
-          </a:ln>
-        </p:spPr>
-        <p:style>
-          <a:lnRef idx="1">
-            <a:schemeClr val="accent1"/>
-          </a:lnRef>
-          <a:fillRef idx="3">
-            <a:schemeClr val="accent1"/>
-          </a:fillRef>
-          <a:effectRef idx="2">
-            <a:schemeClr val="accent1"/>
-          </a:effectRef>
-          <a:fontRef idx="minor">
-            <a:schemeClr val="lt1"/>
-          </a:fontRef>
-        </p:style>
-        <p:txBody>
-          <a:bodyPr rtlCol="0" anchor="ctr"/>
-          <a:lstStyle/>
-          <a:p>
-            <a:pPr algn="ctr"/>
-          </a:p>
-        </p:txBody>
-      </p:sp>
-      <p:sp>
-        <p:nvSpPr>
-          <p:cNvPr id="28" name="Rectangle 27"/>
-          <p:cNvSpPr/>
-          <p:nvPr/>
-        </p:nvSpPr>
-        <p:spPr>
-          <a:xfrm>
-            <a:off x="8537752" y="1897380"/>
-            <a:ext cx="75438" cy="75438"/>
-          </a:xfrm>
-          <a:prstGeom prst="rect">
-            <a:avLst/>
-          </a:prstGeom>
-          <a:solidFill>
-            <a:srgbClr val="FFFFFF"/>
-          </a:solidFill>
-          <a:ln>
-            <a:noFill/>
-          </a:ln>
-        </p:spPr>
-        <p:style>
-          <a:lnRef idx="1">
-            <a:schemeClr val="accent1"/>
-          </a:lnRef>
-          <a:fillRef idx="3">
-            <a:schemeClr val="accent1"/>
-          </a:fillRef>
-          <a:effectRef idx="2">
-            <a:schemeClr val="accent1"/>
-          </a:effectRef>
-          <a:fontRef idx="minor">
-            <a:schemeClr val="lt1"/>
-          </a:fontRef>
-        </p:style>
-        <p:txBody>
-          <a:bodyPr rtlCol="0" anchor="ctr"/>
-          <a:lstStyle/>
-          <a:p>
-            <a:pPr algn="ctr"/>
-          </a:p>
-        </p:txBody>
-      </p:sp>
-      <p:sp>
-        <p:nvSpPr>
-          <p:cNvPr id="29" name="TextBox 28"/>
+          <p:cNvPr id="26" name="TextBox 25"/>
           <p:cNvSpPr txBox="1"/>
           <p:nvPr/>
         </p:nvSpPr>
         <p:spPr>
           <a:xfrm>
-            <a:off x="9026956" y="1719072"/>
+            <a:off x="8386876" y="1731873"/>
+            <a:ext cx="502920" cy="427482"/>
+          </a:xfrm>
+          <a:prstGeom prst="rect">
+            <a:avLst/>
+          </a:prstGeom>
+          <a:noFill/>
+        </p:spPr>
+        <p:txBody>
+          <a:bodyPr wrap="none">
+            <a:spAutoFit/>
+          </a:bodyPr>
+          <a:lstStyle/>
+          <a:p>
+            <a:pPr algn="ctr">
+              <a:defRPr sz="1900">
+                <a:solidFill>
+                  <a:srgbClr val="FFFFFF"/>
+                </a:solidFill>
+                <a:latin typeface="Segoe UI Emoji"/>
+              </a:defRPr>
+            </a:pPr>
+            <a:r>
+              <a:t>🌆</a:t>
+            </a:r>
+          </a:p>
+        </p:txBody>
+      </p:sp>
+      <p:sp>
+        <p:nvSpPr>
+          <p:cNvPr id="27" name="TextBox 26"/>
+          <p:cNvSpPr txBox="1"/>
+          <p:nvPr/>
+        </p:nvSpPr>
+        <p:spPr>
+          <a:xfrm>
+            <a:off x="9026956" y="1764792"/>
             <a:ext cx="457200" cy="274320"/>
           </a:xfrm>
           <a:prstGeom prst="rect">
@@ -4799,7 +4642,7 @@
       </p:sp>
       <p:sp>
         <p:nvSpPr>
-          <p:cNvPr id="30" name="TextBox 29"/>
+          <p:cNvPr id="28" name="TextBox 27"/>
           <p:cNvSpPr txBox="1"/>
           <p:nvPr/>
         </p:nvSpPr>
@@ -4839,13 +4682,13 @@
       </p:sp>
       <p:sp>
         <p:nvSpPr>
-          <p:cNvPr id="31" name="Rectangle 30"/>
+          <p:cNvPr id="29" name="Rectangle 28"/>
           <p:cNvSpPr/>
           <p:nvPr/>
         </p:nvSpPr>
         <p:spPr>
           <a:xfrm>
-            <a:off x="8386876" y="3291840"/>
+            <a:off x="8386876" y="3291839"/>
             <a:ext cx="3027578" cy="17419320000"/>
           </a:xfrm>
           <a:prstGeom prst="rect">
@@ -4882,14 +4725,14 @@
       </p:sp>
       <p:sp>
         <p:nvSpPr>
-          <p:cNvPr id="32" name="TextBox 31"/>
+          <p:cNvPr id="30" name="TextBox 29"/>
           <p:cNvSpPr txBox="1"/>
           <p:nvPr/>
         </p:nvSpPr>
         <p:spPr>
           <a:xfrm>
             <a:off x="8386876" y="3474720"/>
-            <a:ext cx="3027578" cy="1463040"/>
+            <a:ext cx="3027578" cy="1371600"/>
           </a:xfrm>
           <a:prstGeom prst="rect">
             <a:avLst/>
@@ -4930,7 +4773,7 @@
       </p:sp>
       <p:sp>
         <p:nvSpPr>
-          <p:cNvPr id="33" name="Rectangle 32"/>
+          <p:cNvPr id="31" name="Rectangle 30"/>
           <p:cNvSpPr/>
           <p:nvPr/>
         </p:nvSpPr>
@@ -4973,7 +4816,7 @@
       </p:sp>
       <p:sp>
         <p:nvSpPr>
-          <p:cNvPr id="34" name="Rectangle 33"/>
+          <p:cNvPr id="32" name="Rectangle 31"/>
           <p:cNvSpPr/>
           <p:nvPr/>
         </p:nvSpPr>
@@ -5016,7 +4859,7 @@
       </p:sp>
       <p:sp>
         <p:nvSpPr>
-          <p:cNvPr id="35" name="TextBox 34"/>
+          <p:cNvPr id="33" name="TextBox 32"/>
           <p:cNvSpPr txBox="1"/>
           <p:nvPr/>
         </p:nvSpPr>
@@ -5052,7 +4895,7 @@
       </p:sp>
       <p:sp>
         <p:nvSpPr>
-          <p:cNvPr id="36" name="TextBox 35"/>
+          <p:cNvPr id="34" name="TextBox 33"/>
           <p:cNvSpPr txBox="1"/>
           <p:nvPr/>
         </p:nvSpPr>
@@ -5362,16 +5205,16 @@
       </p:sp>
       <p:sp>
         <p:nvSpPr>
-          <p:cNvPr id="8" name="Diamond 7"/>
+          <p:cNvPr id="8" name="Rounded Rectangle 7"/>
           <p:cNvSpPr/>
           <p:nvPr/>
         </p:nvSpPr>
         <p:spPr>
           <a:xfrm>
             <a:off x="777239" y="1691640"/>
-            <a:ext cx="548640" cy="548640"/>
-          </a:xfrm>
-          <a:prstGeom prst="diamond">
+            <a:ext cx="594360" cy="594360"/>
+          </a:xfrm>
+          <a:prstGeom prst="roundRect">
             <a:avLst/>
           </a:prstGeom>
           <a:solidFill>
@@ -5405,44 +5248,37 @@
       </p:sp>
       <p:sp>
         <p:nvSpPr>
-          <p:cNvPr id="9" name="Rectangle 8"/>
-          <p:cNvSpPr/>
-          <p:nvPr/>
-        </p:nvSpPr>
-        <p:spPr>
-          <a:xfrm>
-            <a:off x="777239" y="1922068"/>
-            <a:ext cx="548640" cy="87782"/>
-          </a:xfrm>
-          <a:prstGeom prst="rect">
-            <a:avLst/>
-          </a:prstGeom>
-          <a:solidFill>
-            <a:srgbClr val="FFFFFF"/>
-          </a:solidFill>
-          <a:ln>
-            <a:noFill/>
-          </a:ln>
-        </p:spPr>
-        <p:style>
-          <a:lnRef idx="1">
-            <a:schemeClr val="accent1"/>
-          </a:lnRef>
-          <a:fillRef idx="3">
-            <a:schemeClr val="accent1"/>
-          </a:fillRef>
-          <a:effectRef idx="2">
-            <a:schemeClr val="accent1"/>
-          </a:effectRef>
-          <a:fontRef idx="minor">
-            <a:schemeClr val="lt1"/>
-          </a:fontRef>
-        </p:style>
-        <p:txBody>
-          <a:bodyPr rtlCol="0" anchor="ctr"/>
-          <a:lstStyle/>
-          <a:p>
-            <a:pPr algn="ctr"/>
+          <p:cNvPr id="9" name="TextBox 8"/>
+          <p:cNvSpPr txBox="1"/>
+          <p:nvPr/>
+        </p:nvSpPr>
+        <p:spPr>
+          <a:xfrm>
+            <a:off x="777239" y="1739188"/>
+            <a:ext cx="594360" cy="505206"/>
+          </a:xfrm>
+          <a:prstGeom prst="rect">
+            <a:avLst/>
+          </a:prstGeom>
+          <a:noFill/>
+        </p:spPr>
+        <p:txBody>
+          <a:bodyPr wrap="none">
+            <a:spAutoFit/>
+          </a:bodyPr>
+          <a:lstStyle/>
+          <a:p>
+            <a:pPr algn="ctr">
+              <a:defRPr sz="2300">
+                <a:solidFill>
+                  <a:srgbClr val="FFFFFF"/>
+                </a:solidFill>
+                <a:latin typeface="Segoe UI Emoji"/>
+              </a:defRPr>
+            </a:pPr>
+            <a:r>
+              <a:t>🌐</a:t>
+            </a:r>
           </a:p>
         </p:txBody>
       </p:sp>
@@ -5454,8 +5290,8 @@
         </p:nvSpPr>
         <p:spPr>
           <a:xfrm>
-            <a:off x="1554479" y="1691640"/>
-            <a:ext cx="4084167" cy="411480"/>
+            <a:off x="1600199" y="1691640"/>
+            <a:ext cx="3992727" cy="411480"/>
           </a:xfrm>
           <a:prstGeom prst="rect">
             <a:avLst/>
@@ -5490,8 +5326,8 @@
         </p:nvSpPr>
         <p:spPr>
           <a:xfrm>
-            <a:off x="1554479" y="2194560"/>
-            <a:ext cx="4084167" cy="640080"/>
+            <a:off x="1600199" y="2194560"/>
+            <a:ext cx="3992727" cy="640080"/>
           </a:xfrm>
           <a:prstGeom prst="rect">
             <a:avLst/>
@@ -5577,8 +5413,8 @@
         </p:nvSpPr>
         <p:spPr>
           <a:xfrm>
-            <a:off x="6630771" y="1691640"/>
-            <a:ext cx="301752" cy="548640"/>
+            <a:off x="6507327" y="1691640"/>
+            <a:ext cx="594360" cy="594360"/>
           </a:xfrm>
           <a:prstGeom prst="roundRect">
             <a:avLst/>
@@ -5614,100 +5450,50 @@
       </p:sp>
       <p:sp>
         <p:nvSpPr>
-          <p:cNvPr id="14" name="Rectangle 13"/>
-          <p:cNvSpPr/>
-          <p:nvPr/>
-        </p:nvSpPr>
-        <p:spPr>
-          <a:xfrm>
-            <a:off x="6740499" y="1911095"/>
-            <a:ext cx="82296" cy="164592"/>
-          </a:xfrm>
-          <a:prstGeom prst="rect">
-            <a:avLst/>
-          </a:prstGeom>
-          <a:solidFill>
-            <a:srgbClr val="FFFFFF"/>
-          </a:solidFill>
-          <a:ln>
-            <a:noFill/>
-          </a:ln>
-        </p:spPr>
-        <p:style>
-          <a:lnRef idx="1">
-            <a:schemeClr val="accent1"/>
-          </a:lnRef>
-          <a:fillRef idx="3">
-            <a:schemeClr val="accent1"/>
-          </a:fillRef>
-          <a:effectRef idx="2">
-            <a:schemeClr val="accent1"/>
-          </a:effectRef>
-          <a:fontRef idx="minor">
-            <a:schemeClr val="lt1"/>
-          </a:fontRef>
-        </p:style>
-        <p:txBody>
-          <a:bodyPr rtlCol="0" anchor="ctr"/>
-          <a:lstStyle/>
-          <a:p>
-            <a:pPr algn="ctr"/>
-          </a:p>
-        </p:txBody>
-      </p:sp>
-      <p:sp>
-        <p:nvSpPr>
-          <p:cNvPr id="15" name="Rectangle 14"/>
-          <p:cNvSpPr/>
-          <p:nvPr/>
-        </p:nvSpPr>
-        <p:spPr>
-          <a:xfrm>
-            <a:off x="6721297" y="2130552"/>
-            <a:ext cx="120700" cy="87782"/>
-          </a:xfrm>
-          <a:prstGeom prst="rect">
-            <a:avLst/>
-          </a:prstGeom>
-          <a:solidFill>
-            <a:srgbClr val="FFFFFF"/>
-          </a:solidFill>
-          <a:ln>
-            <a:noFill/>
-          </a:ln>
-        </p:spPr>
-        <p:style>
-          <a:lnRef idx="1">
-            <a:schemeClr val="accent1"/>
-          </a:lnRef>
-          <a:fillRef idx="3">
-            <a:schemeClr val="accent1"/>
-          </a:fillRef>
-          <a:effectRef idx="2">
-            <a:schemeClr val="accent1"/>
-          </a:effectRef>
-          <a:fontRef idx="minor">
-            <a:schemeClr val="lt1"/>
-          </a:fontRef>
-        </p:style>
-        <p:txBody>
-          <a:bodyPr rtlCol="0" anchor="ctr"/>
-          <a:lstStyle/>
-          <a:p>
-            <a:pPr algn="ctr"/>
-          </a:p>
-        </p:txBody>
-      </p:sp>
-      <p:sp>
-        <p:nvSpPr>
-          <p:cNvPr id="16" name="TextBox 15"/>
+          <p:cNvPr id="14" name="TextBox 13"/>
           <p:cNvSpPr txBox="1"/>
           <p:nvPr/>
         </p:nvSpPr>
         <p:spPr>
           <a:xfrm>
-            <a:off x="7284567" y="1691640"/>
-            <a:ext cx="4084167" cy="411480"/>
+            <a:off x="6507327" y="1739188"/>
+            <a:ext cx="594360" cy="505206"/>
+          </a:xfrm>
+          <a:prstGeom prst="rect">
+            <a:avLst/>
+          </a:prstGeom>
+          <a:noFill/>
+        </p:spPr>
+        <p:txBody>
+          <a:bodyPr wrap="none">
+            <a:spAutoFit/>
+          </a:bodyPr>
+          <a:lstStyle/>
+          <a:p>
+            <a:pPr algn="ctr">
+              <a:defRPr sz="2300">
+                <a:solidFill>
+                  <a:srgbClr val="FFFFFF"/>
+                </a:solidFill>
+                <a:latin typeface="Segoe UI Emoji"/>
+              </a:defRPr>
+            </a:pPr>
+            <a:r>
+              <a:t>📱</a:t>
+            </a:r>
+          </a:p>
+        </p:txBody>
+      </p:sp>
+      <p:sp>
+        <p:nvSpPr>
+          <p:cNvPr id="15" name="TextBox 14"/>
+          <p:cNvSpPr txBox="1"/>
+          <p:nvPr/>
+        </p:nvSpPr>
+        <p:spPr>
+          <a:xfrm>
+            <a:off x="7330287" y="1691640"/>
+            <a:ext cx="3992727" cy="411480"/>
           </a:xfrm>
           <a:prstGeom prst="rect">
             <a:avLst/>
@@ -5736,14 +5522,14 @@
       </p:sp>
       <p:sp>
         <p:nvSpPr>
-          <p:cNvPr id="17" name="TextBox 16"/>
+          <p:cNvPr id="16" name="TextBox 15"/>
           <p:cNvSpPr txBox="1"/>
           <p:nvPr/>
         </p:nvSpPr>
         <p:spPr>
           <a:xfrm>
-            <a:off x="7284567" y="2194560"/>
-            <a:ext cx="4084167" cy="640080"/>
+            <a:off x="7330287" y="2194560"/>
+            <a:ext cx="3992727" cy="640080"/>
           </a:xfrm>
           <a:prstGeom prst="rect">
             <a:avLst/>
@@ -5776,7 +5562,7 @@
       </p:sp>
       <p:sp>
         <p:nvSpPr>
-          <p:cNvPr id="18" name="Rounded Rectangle 17"/>
+          <p:cNvPr id="17" name="Rounded Rectangle 16"/>
           <p:cNvSpPr/>
           <p:nvPr/>
         </p:nvSpPr>
@@ -5823,16 +5609,16 @@
       </p:sp>
       <p:sp>
         <p:nvSpPr>
-          <p:cNvPr id="19" name="Rectangle 18"/>
+          <p:cNvPr id="18" name="Rounded Rectangle 17"/>
           <p:cNvSpPr/>
           <p:nvPr/>
         </p:nvSpPr>
         <p:spPr>
           <a:xfrm>
-            <a:off x="777239" y="3822191"/>
-            <a:ext cx="548640" cy="384048"/>
-          </a:xfrm>
-          <a:prstGeom prst="rect">
+            <a:off x="777239" y="3657600"/>
+            <a:ext cx="594360" cy="594360"/>
+          </a:xfrm>
+          <a:prstGeom prst="roundRect">
             <a:avLst/>
           </a:prstGeom>
           <a:solidFill>
@@ -5866,100 +5652,50 @@
       </p:sp>
       <p:sp>
         <p:nvSpPr>
-          <p:cNvPr id="20" name="Isosceles Triangle 19"/>
-          <p:cNvSpPr/>
-          <p:nvPr/>
-        </p:nvSpPr>
-        <p:spPr>
-          <a:xfrm>
-            <a:off x="777239" y="3657600"/>
-            <a:ext cx="548640" cy="274320"/>
-          </a:xfrm>
-          <a:prstGeom prst="triangle">
-            <a:avLst/>
-          </a:prstGeom>
-          <a:solidFill>
-            <a:srgbClr val="0D9488"/>
-          </a:solidFill>
-          <a:ln>
-            <a:noFill/>
-          </a:ln>
-        </p:spPr>
-        <p:style>
-          <a:lnRef idx="1">
-            <a:schemeClr val="accent1"/>
-          </a:lnRef>
-          <a:fillRef idx="3">
-            <a:schemeClr val="accent1"/>
-          </a:fillRef>
-          <a:effectRef idx="2">
-            <a:schemeClr val="accent1"/>
-          </a:effectRef>
-          <a:fontRef idx="minor">
-            <a:schemeClr val="lt1"/>
-          </a:fontRef>
-        </p:style>
-        <p:txBody>
-          <a:bodyPr rtlCol="0" anchor="ctr"/>
-          <a:lstStyle/>
-          <a:p>
-            <a:pPr algn="ctr"/>
-          </a:p>
-        </p:txBody>
-      </p:sp>
-      <p:sp>
-        <p:nvSpPr>
-          <p:cNvPr id="21" name="Rectangle 20"/>
-          <p:cNvSpPr/>
-          <p:nvPr/>
-        </p:nvSpPr>
-        <p:spPr>
-          <a:xfrm>
-            <a:off x="941831" y="3931920"/>
-            <a:ext cx="82296" cy="82296"/>
-          </a:xfrm>
-          <a:prstGeom prst="rect">
-            <a:avLst/>
-          </a:prstGeom>
-          <a:solidFill>
-            <a:srgbClr val="FFFFFF"/>
-          </a:solidFill>
-          <a:ln>
-            <a:noFill/>
-          </a:ln>
-        </p:spPr>
-        <p:style>
-          <a:lnRef idx="1">
-            <a:schemeClr val="accent1"/>
-          </a:lnRef>
-          <a:fillRef idx="3">
-            <a:schemeClr val="accent1"/>
-          </a:fillRef>
-          <a:effectRef idx="2">
-            <a:schemeClr val="accent1"/>
-          </a:effectRef>
-          <a:fontRef idx="minor">
-            <a:schemeClr val="lt1"/>
-          </a:fontRef>
-        </p:style>
-        <p:txBody>
-          <a:bodyPr rtlCol="0" anchor="ctr"/>
-          <a:lstStyle/>
-          <a:p>
-            <a:pPr algn="ctr"/>
-          </a:p>
-        </p:txBody>
-      </p:sp>
-      <p:sp>
-        <p:nvSpPr>
-          <p:cNvPr id="22" name="TextBox 21"/>
+          <p:cNvPr id="19" name="TextBox 18"/>
           <p:cNvSpPr txBox="1"/>
           <p:nvPr/>
         </p:nvSpPr>
         <p:spPr>
           <a:xfrm>
-            <a:off x="1554479" y="3657600"/>
-            <a:ext cx="4084167" cy="411480"/>
+            <a:off x="777239" y="3705148"/>
+            <a:ext cx="594360" cy="505206"/>
+          </a:xfrm>
+          <a:prstGeom prst="rect">
+            <a:avLst/>
+          </a:prstGeom>
+          <a:noFill/>
+        </p:spPr>
+        <p:txBody>
+          <a:bodyPr wrap="none">
+            <a:spAutoFit/>
+          </a:bodyPr>
+          <a:lstStyle/>
+          <a:p>
+            <a:pPr algn="ctr">
+              <a:defRPr sz="2300">
+                <a:solidFill>
+                  <a:srgbClr val="FFFFFF"/>
+                </a:solidFill>
+                <a:latin typeface="Segoe UI Emoji"/>
+              </a:defRPr>
+            </a:pPr>
+            <a:r>
+              <a:t>🌆</a:t>
+            </a:r>
+          </a:p>
+        </p:txBody>
+      </p:sp>
+      <p:sp>
+        <p:nvSpPr>
+          <p:cNvPr id="20" name="TextBox 19"/>
+          <p:cNvSpPr txBox="1"/>
+          <p:nvPr/>
+        </p:nvSpPr>
+        <p:spPr>
+          <a:xfrm>
+            <a:off x="1600199" y="3657600"/>
+            <a:ext cx="3992727" cy="411480"/>
           </a:xfrm>
           <a:prstGeom prst="rect">
             <a:avLst/>
@@ -5988,14 +5724,14 @@
       </p:sp>
       <p:sp>
         <p:nvSpPr>
-          <p:cNvPr id="23" name="TextBox 22"/>
+          <p:cNvPr id="21" name="TextBox 20"/>
           <p:cNvSpPr txBox="1"/>
           <p:nvPr/>
         </p:nvSpPr>
         <p:spPr>
           <a:xfrm>
-            <a:off x="1554479" y="4160520"/>
-            <a:ext cx="4084167" cy="640080"/>
+            <a:off x="1600199" y="4160520"/>
+            <a:ext cx="3992727" cy="640080"/>
           </a:xfrm>
           <a:prstGeom prst="rect">
             <a:avLst/>
@@ -6028,7 +5764,7 @@
       </p:sp>
       <p:sp>
         <p:nvSpPr>
-          <p:cNvPr id="24" name="Rounded Rectangle 23"/>
+          <p:cNvPr id="22" name="Rounded Rectangle 21"/>
           <p:cNvSpPr/>
           <p:nvPr/>
         </p:nvSpPr>
@@ -6075,16 +5811,16 @@
       </p:sp>
       <p:sp>
         <p:nvSpPr>
-          <p:cNvPr id="25" name="Parallelogram 24"/>
+          <p:cNvPr id="23" name="Rounded Rectangle 22"/>
           <p:cNvSpPr/>
           <p:nvPr/>
         </p:nvSpPr>
         <p:spPr>
           <a:xfrm>
             <a:off x="6507327" y="3657600"/>
-            <a:ext cx="384048" cy="548640"/>
-          </a:xfrm>
-          <a:prstGeom prst="parallelogram">
+            <a:ext cx="594360" cy="594360"/>
+          </a:xfrm>
+          <a:prstGeom prst="roundRect">
             <a:avLst/>
           </a:prstGeom>
           <a:solidFill>
@@ -6118,57 +5854,50 @@
       </p:sp>
       <p:sp>
         <p:nvSpPr>
-          <p:cNvPr id="26" name="Parallelogram 25"/>
-          <p:cNvSpPr/>
-          <p:nvPr/>
-        </p:nvSpPr>
-        <p:spPr>
-          <a:xfrm>
-            <a:off x="6671919" y="3657600"/>
-            <a:ext cx="384048" cy="548640"/>
-          </a:xfrm>
-          <a:prstGeom prst="parallelogram">
-            <a:avLst/>
-          </a:prstGeom>
-          <a:solidFill>
-            <a:srgbClr val="FFFFFF"/>
-          </a:solidFill>
-          <a:ln>
-            <a:noFill/>
-          </a:ln>
-        </p:spPr>
-        <p:style>
-          <a:lnRef idx="1">
-            <a:schemeClr val="accent1"/>
-          </a:lnRef>
-          <a:fillRef idx="3">
-            <a:schemeClr val="accent1"/>
-          </a:fillRef>
-          <a:effectRef idx="2">
-            <a:schemeClr val="accent1"/>
-          </a:effectRef>
-          <a:fontRef idx="minor">
-            <a:schemeClr val="lt1"/>
-          </a:fontRef>
-        </p:style>
-        <p:txBody>
-          <a:bodyPr rtlCol="0" anchor="ctr"/>
-          <a:lstStyle/>
-          <a:p>
-            <a:pPr algn="ctr"/>
-          </a:p>
-        </p:txBody>
-      </p:sp>
-      <p:sp>
-        <p:nvSpPr>
-          <p:cNvPr id="27" name="TextBox 26"/>
+          <p:cNvPr id="24" name="TextBox 23"/>
           <p:cNvSpPr txBox="1"/>
           <p:nvPr/>
         </p:nvSpPr>
         <p:spPr>
           <a:xfrm>
-            <a:off x="7284567" y="3657600"/>
-            <a:ext cx="4084167" cy="411480"/>
+            <a:off x="6507327" y="3705148"/>
+            <a:ext cx="594360" cy="505206"/>
+          </a:xfrm>
+          <a:prstGeom prst="rect">
+            <a:avLst/>
+          </a:prstGeom>
+          <a:noFill/>
+        </p:spPr>
+        <p:txBody>
+          <a:bodyPr wrap="none">
+            <a:spAutoFit/>
+          </a:bodyPr>
+          <a:lstStyle/>
+          <a:p>
+            <a:pPr algn="ctr">
+              <a:defRPr sz="2300">
+                <a:solidFill>
+                  <a:srgbClr val="FFFFFF"/>
+                </a:solidFill>
+                <a:latin typeface="Segoe UI Emoji"/>
+              </a:defRPr>
+            </a:pPr>
+            <a:r>
+              <a:t>🔗</a:t>
+            </a:r>
+          </a:p>
+        </p:txBody>
+      </p:sp>
+      <p:sp>
+        <p:nvSpPr>
+          <p:cNvPr id="25" name="TextBox 24"/>
+          <p:cNvSpPr txBox="1"/>
+          <p:nvPr/>
+        </p:nvSpPr>
+        <p:spPr>
+          <a:xfrm>
+            <a:off x="7330287" y="3657600"/>
+            <a:ext cx="3992727" cy="411480"/>
           </a:xfrm>
           <a:prstGeom prst="rect">
             <a:avLst/>
@@ -6197,14 +5926,14 @@
       </p:sp>
       <p:sp>
         <p:nvSpPr>
-          <p:cNvPr id="28" name="TextBox 27"/>
+          <p:cNvPr id="26" name="TextBox 25"/>
           <p:cNvSpPr txBox="1"/>
           <p:nvPr/>
         </p:nvSpPr>
         <p:spPr>
           <a:xfrm>
-            <a:off x="7284567" y="4160520"/>
-            <a:ext cx="4084167" cy="640080"/>
+            <a:off x="7330287" y="4160520"/>
+            <a:ext cx="3992727" cy="640080"/>
           </a:xfrm>
           <a:prstGeom prst="rect">
             <a:avLst/>
@@ -6237,7 +5966,7 @@
       </p:sp>
       <p:sp>
         <p:nvSpPr>
-          <p:cNvPr id="29" name="Rectangle 28"/>
+          <p:cNvPr id="27" name="Rectangle 26"/>
           <p:cNvSpPr/>
           <p:nvPr/>
         </p:nvSpPr>
@@ -6280,7 +6009,7 @@
       </p:sp>
       <p:sp>
         <p:nvSpPr>
-          <p:cNvPr id="30" name="Rectangle 29"/>
+          <p:cNvPr id="28" name="Rectangle 27"/>
           <p:cNvSpPr/>
           <p:nvPr/>
         </p:nvSpPr>
@@ -6323,7 +6052,7 @@
       </p:sp>
       <p:sp>
         <p:nvSpPr>
-          <p:cNvPr id="31" name="TextBox 30"/>
+          <p:cNvPr id="29" name="TextBox 28"/>
           <p:cNvSpPr txBox="1"/>
           <p:nvPr/>
         </p:nvSpPr>
@@ -6359,7 +6088,7 @@
       </p:sp>
       <p:sp>
         <p:nvSpPr>
-          <p:cNvPr id="32" name="TextBox 31"/>
+          <p:cNvPr id="30" name="TextBox 29"/>
           <p:cNvSpPr txBox="1"/>
           <p:nvPr/>
         </p:nvSpPr>
@@ -6708,44 +6437,37 @@
       </p:sp>
       <p:sp>
         <p:nvSpPr>
-          <p:cNvPr id="9" name="Diamond 8"/>
-          <p:cNvSpPr/>
-          <p:nvPr/>
-        </p:nvSpPr>
-        <p:spPr>
-          <a:xfrm>
-            <a:off x="960120" y="1737360"/>
-            <a:ext cx="274320" cy="274320"/>
-          </a:xfrm>
-          <a:prstGeom prst="diamond">
-            <a:avLst/>
-          </a:prstGeom>
-          <a:solidFill>
-            <a:srgbClr val="FFFFFF"/>
-          </a:solidFill>
-          <a:ln>
-            <a:noFill/>
-          </a:ln>
-        </p:spPr>
-        <p:style>
-          <a:lnRef idx="1">
-            <a:schemeClr val="accent1"/>
-          </a:lnRef>
-          <a:fillRef idx="3">
-            <a:schemeClr val="accent1"/>
-          </a:fillRef>
-          <a:effectRef idx="2">
-            <a:schemeClr val="accent1"/>
-          </a:effectRef>
-          <a:fontRef idx="minor">
-            <a:schemeClr val="lt1"/>
-          </a:fontRef>
-        </p:style>
-        <p:txBody>
-          <a:bodyPr rtlCol="0" anchor="ctr"/>
-          <a:lstStyle/>
-          <a:p>
-            <a:pPr algn="ctr"/>
+          <p:cNvPr id="9" name="TextBox 8"/>
+          <p:cNvSpPr txBox="1"/>
+          <p:nvPr/>
+        </p:nvSpPr>
+        <p:spPr>
+          <a:xfrm>
+            <a:off x="868680" y="1682496"/>
+            <a:ext cx="457200" cy="388620"/>
+          </a:xfrm>
+          <a:prstGeom prst="rect">
+            <a:avLst/>
+          </a:prstGeom>
+          <a:noFill/>
+        </p:spPr>
+        <p:txBody>
+          <a:bodyPr wrap="none">
+            <a:spAutoFit/>
+          </a:bodyPr>
+          <a:lstStyle/>
+          <a:p>
+            <a:pPr algn="ctr">
+              <a:defRPr sz="1800">
+                <a:solidFill>
+                  <a:srgbClr val="FFFFFF"/>
+                </a:solidFill>
+                <a:latin typeface="Segoe UI Emoji"/>
+              </a:defRPr>
+            </a:pPr>
+            <a:r>
+              <a:t>✅</a:t>
+            </a:r>
           </a:p>
         </p:txBody>
       </p:sp>
@@ -6757,7 +6479,7 @@
         </p:nvSpPr>
         <p:spPr>
           <a:xfrm>
-            <a:off x="1078992" y="2194560"/>
+            <a:off x="1097280" y="2194560"/>
             <a:ext cx="17419320000" cy="457200"/>
           </a:xfrm>
           <a:prstGeom prst="rect">
@@ -6800,8 +6522,8 @@
         </p:nvSpPr>
         <p:spPr>
           <a:xfrm>
-            <a:off x="1554480" y="1682496"/>
-            <a:ext cx="9814255" cy="731520"/>
+            <a:off x="1600200" y="1682496"/>
+            <a:ext cx="9722815" cy="731520"/>
           </a:xfrm>
           <a:prstGeom prst="rect">
             <a:avLst/>
@@ -6849,16 +6571,16 @@
       </p:sp>
       <p:sp>
         <p:nvSpPr>
-          <p:cNvPr id="12" name="Parallelogram 11"/>
+          <p:cNvPr id="12" name="Rounded Rectangle 11"/>
           <p:cNvSpPr/>
           <p:nvPr/>
         </p:nvSpPr>
         <p:spPr>
           <a:xfrm>
             <a:off x="868680" y="2697480"/>
-            <a:ext cx="320040" cy="457200"/>
-          </a:xfrm>
-          <a:prstGeom prst="parallelogram">
+            <a:ext cx="457200" cy="457200"/>
+          </a:xfrm>
+          <a:prstGeom prst="roundRect">
             <a:avLst/>
           </a:prstGeom>
           <a:solidFill>
@@ -6892,44 +6614,37 @@
       </p:sp>
       <p:sp>
         <p:nvSpPr>
-          <p:cNvPr id="13" name="Parallelogram 12"/>
-          <p:cNvSpPr/>
-          <p:nvPr/>
-        </p:nvSpPr>
-        <p:spPr>
-          <a:xfrm>
-            <a:off x="1005839" y="2697480"/>
-            <a:ext cx="320040" cy="457200"/>
-          </a:xfrm>
-          <a:prstGeom prst="parallelogram">
-            <a:avLst/>
-          </a:prstGeom>
-          <a:solidFill>
-            <a:srgbClr val="FFFFFF"/>
-          </a:solidFill>
-          <a:ln>
-            <a:noFill/>
-          </a:ln>
-        </p:spPr>
-        <p:style>
-          <a:lnRef idx="1">
-            <a:schemeClr val="accent1"/>
-          </a:lnRef>
-          <a:fillRef idx="3">
-            <a:schemeClr val="accent1"/>
-          </a:fillRef>
-          <a:effectRef idx="2">
-            <a:schemeClr val="accent1"/>
-          </a:effectRef>
-          <a:fontRef idx="minor">
-            <a:schemeClr val="lt1"/>
-          </a:fontRef>
-        </p:style>
-        <p:txBody>
-          <a:bodyPr rtlCol="0" anchor="ctr"/>
-          <a:lstStyle/>
-          <a:p>
-            <a:pPr algn="ctr"/>
+          <p:cNvPr id="13" name="TextBox 12"/>
+          <p:cNvSpPr txBox="1"/>
+          <p:nvPr/>
+        </p:nvSpPr>
+        <p:spPr>
+          <a:xfrm>
+            <a:off x="868680" y="2734056"/>
+            <a:ext cx="457200" cy="388620"/>
+          </a:xfrm>
+          <a:prstGeom prst="rect">
+            <a:avLst/>
+          </a:prstGeom>
+          <a:noFill/>
+        </p:spPr>
+        <p:txBody>
+          <a:bodyPr wrap="none">
+            <a:spAutoFit/>
+          </a:bodyPr>
+          <a:lstStyle/>
+          <a:p>
+            <a:pPr algn="ctr">
+              <a:defRPr sz="1800">
+                <a:solidFill>
+                  <a:srgbClr val="FFFFFF"/>
+                </a:solidFill>
+                <a:latin typeface="Segoe UI Emoji"/>
+              </a:defRPr>
+            </a:pPr>
+            <a:r>
+              <a:t>🔗</a:t>
+            </a:r>
           </a:p>
         </p:txBody>
       </p:sp>
@@ -6941,7 +6656,7 @@
         </p:nvSpPr>
         <p:spPr>
           <a:xfrm>
-            <a:off x="1078992" y="3246120"/>
+            <a:off x="1097280" y="3246120"/>
             <a:ext cx="17419320000" cy="457200"/>
           </a:xfrm>
           <a:prstGeom prst="rect">
@@ -6984,8 +6699,8 @@
         </p:nvSpPr>
         <p:spPr>
           <a:xfrm>
-            <a:off x="1554480" y="2734056"/>
-            <a:ext cx="9814255" cy="731520"/>
+            <a:off x="1600200" y="2734056"/>
+            <a:ext cx="9722815" cy="731520"/>
           </a:xfrm>
           <a:prstGeom prst="rect">
             <a:avLst/>
@@ -7033,7 +6748,7 @@
       </p:sp>
       <p:sp>
         <p:nvSpPr>
-          <p:cNvPr id="16" name="Diamond 15"/>
+          <p:cNvPr id="16" name="Rounded Rectangle 15"/>
           <p:cNvSpPr/>
           <p:nvPr/>
         </p:nvSpPr>
@@ -7042,7 +6757,7 @@
             <a:off x="868680" y="3749039"/>
             <a:ext cx="457200" cy="457200"/>
           </a:xfrm>
-          <a:prstGeom prst="diamond">
+          <a:prstGeom prst="roundRect">
             <a:avLst/>
           </a:prstGeom>
           <a:solidFill>
@@ -7076,44 +6791,37 @@
       </p:sp>
       <p:sp>
         <p:nvSpPr>
-          <p:cNvPr id="17" name="Rectangle 16"/>
-          <p:cNvSpPr/>
-          <p:nvPr/>
-        </p:nvSpPr>
-        <p:spPr>
-          <a:xfrm>
-            <a:off x="868680" y="3941063"/>
-            <a:ext cx="457200" cy="73152"/>
-          </a:xfrm>
-          <a:prstGeom prst="rect">
-            <a:avLst/>
-          </a:prstGeom>
-          <a:solidFill>
-            <a:srgbClr val="FFFFFF"/>
-          </a:solidFill>
-          <a:ln>
-            <a:noFill/>
-          </a:ln>
-        </p:spPr>
-        <p:style>
-          <a:lnRef idx="1">
-            <a:schemeClr val="accent1"/>
-          </a:lnRef>
-          <a:fillRef idx="3">
-            <a:schemeClr val="accent1"/>
-          </a:fillRef>
-          <a:effectRef idx="2">
-            <a:schemeClr val="accent1"/>
-          </a:effectRef>
-          <a:fontRef idx="minor">
-            <a:schemeClr val="lt1"/>
-          </a:fontRef>
-        </p:style>
-        <p:txBody>
-          <a:bodyPr rtlCol="0" anchor="ctr"/>
-          <a:lstStyle/>
-          <a:p>
-            <a:pPr algn="ctr"/>
+          <p:cNvPr id="17" name="TextBox 16"/>
+          <p:cNvSpPr txBox="1"/>
+          <p:nvPr/>
+        </p:nvSpPr>
+        <p:spPr>
+          <a:xfrm>
+            <a:off x="868680" y="3785615"/>
+            <a:ext cx="457200" cy="388620"/>
+          </a:xfrm>
+          <a:prstGeom prst="rect">
+            <a:avLst/>
+          </a:prstGeom>
+          <a:noFill/>
+        </p:spPr>
+        <p:txBody>
+          <a:bodyPr wrap="none">
+            <a:spAutoFit/>
+          </a:bodyPr>
+          <a:lstStyle/>
+          <a:p>
+            <a:pPr algn="ctr">
+              <a:defRPr sz="1800">
+                <a:solidFill>
+                  <a:srgbClr val="FFFFFF"/>
+                </a:solidFill>
+                <a:latin typeface="Segoe UI Emoji"/>
+              </a:defRPr>
+            </a:pPr>
+            <a:r>
+              <a:t>🌐</a:t>
+            </a:r>
           </a:p>
         </p:txBody>
       </p:sp>
@@ -7125,7 +6833,7 @@
         </p:nvSpPr>
         <p:spPr>
           <a:xfrm>
-            <a:off x="1078992" y="4297679"/>
+            <a:off x="1097280" y="4297679"/>
             <a:ext cx="17419320000" cy="457200"/>
           </a:xfrm>
           <a:prstGeom prst="rect">
@@ -7168,8 +6876,8 @@
         </p:nvSpPr>
         <p:spPr>
           <a:xfrm>
-            <a:off x="1554480" y="3785615"/>
-            <a:ext cx="9814255" cy="731520"/>
+            <a:off x="1600200" y="3785615"/>
+            <a:ext cx="9722815" cy="731520"/>
           </a:xfrm>
           <a:prstGeom prst="rect">
             <a:avLst/>
@@ -7217,7 +6925,7 @@
       </p:sp>
       <p:sp>
         <p:nvSpPr>
-          <p:cNvPr id="20" name="Pentagon 19"/>
+          <p:cNvPr id="20" name="Rounded Rectangle 19"/>
           <p:cNvSpPr/>
           <p:nvPr/>
         </p:nvSpPr>
@@ -7226,7 +6934,7 @@
             <a:off x="868680" y="4800600"/>
             <a:ext cx="457200" cy="457200"/>
           </a:xfrm>
-          <a:prstGeom prst="homePlate">
+          <a:prstGeom prst="roundRect">
             <a:avLst/>
           </a:prstGeom>
           <a:solidFill>
@@ -7260,44 +6968,37 @@
       </p:sp>
       <p:sp>
         <p:nvSpPr>
-          <p:cNvPr id="21" name="Rectangle 20"/>
-          <p:cNvSpPr/>
-          <p:nvPr/>
-        </p:nvSpPr>
-        <p:spPr>
-          <a:xfrm>
-            <a:off x="1005839" y="4937760"/>
-            <a:ext cx="182880" cy="182880"/>
-          </a:xfrm>
-          <a:prstGeom prst="rect">
-            <a:avLst/>
-          </a:prstGeom>
-          <a:solidFill>
-            <a:srgbClr val="FFFFFF"/>
-          </a:solidFill>
-          <a:ln>
-            <a:noFill/>
-          </a:ln>
-        </p:spPr>
-        <p:style>
-          <a:lnRef idx="1">
-            <a:schemeClr val="accent1"/>
-          </a:lnRef>
-          <a:fillRef idx="3">
-            <a:schemeClr val="accent1"/>
-          </a:fillRef>
-          <a:effectRef idx="2">
-            <a:schemeClr val="accent1"/>
-          </a:effectRef>
-          <a:fontRef idx="minor">
-            <a:schemeClr val="lt1"/>
-          </a:fontRef>
-        </p:style>
-        <p:txBody>
-          <a:bodyPr rtlCol="0" anchor="ctr"/>
-          <a:lstStyle/>
-          <a:p>
-            <a:pPr algn="ctr"/>
+          <p:cNvPr id="21" name="TextBox 20"/>
+          <p:cNvSpPr txBox="1"/>
+          <p:nvPr/>
+        </p:nvSpPr>
+        <p:spPr>
+          <a:xfrm>
+            <a:off x="868680" y="4837176"/>
+            <a:ext cx="457200" cy="388620"/>
+          </a:xfrm>
+          <a:prstGeom prst="rect">
+            <a:avLst/>
+          </a:prstGeom>
+          <a:noFill/>
+        </p:spPr>
+        <p:txBody>
+          <a:bodyPr wrap="none">
+            <a:spAutoFit/>
+          </a:bodyPr>
+          <a:lstStyle/>
+          <a:p>
+            <a:pPr algn="ctr">
+              <a:defRPr sz="1800">
+                <a:solidFill>
+                  <a:srgbClr val="FFFFFF"/>
+                </a:solidFill>
+                <a:latin typeface="Segoe UI Emoji"/>
+              </a:defRPr>
+            </a:pPr>
+            <a:r>
+              <a:t>👥</a:t>
+            </a:r>
           </a:p>
         </p:txBody>
       </p:sp>
@@ -7309,8 +7010,8 @@
         </p:nvSpPr>
         <p:spPr>
           <a:xfrm>
-            <a:off x="1554480" y="4837176"/>
-            <a:ext cx="9814255" cy="731520"/>
+            <a:off x="1600200" y="4837176"/>
+            <a:ext cx="9722815" cy="731520"/>
           </a:xfrm>
           <a:prstGeom prst="rect">
             <a:avLst/>
@@ -7786,7 +7487,7 @@
       </p:sp>
       <p:sp>
         <p:nvSpPr>
-          <p:cNvPr id="8" name="Diamond 7"/>
+          <p:cNvPr id="8" name="Rounded Rectangle 7"/>
           <p:cNvSpPr/>
           <p:nvPr/>
         </p:nvSpPr>
@@ -7795,7 +7496,7 @@
             <a:off x="868680" y="1645920"/>
             <a:ext cx="457200" cy="457200"/>
           </a:xfrm>
-          <a:prstGeom prst="diamond">
+          <a:prstGeom prst="roundRect">
             <a:avLst/>
           </a:prstGeom>
           <a:solidFill>
@@ -7829,44 +7530,37 @@
       </p:sp>
       <p:sp>
         <p:nvSpPr>
-          <p:cNvPr id="9" name="Diamond 8"/>
-          <p:cNvSpPr/>
-          <p:nvPr/>
-        </p:nvSpPr>
-        <p:spPr>
-          <a:xfrm>
-            <a:off x="937259" y="1714500"/>
-            <a:ext cx="320040" cy="320040"/>
-          </a:xfrm>
-          <a:prstGeom prst="diamond">
-            <a:avLst/>
-          </a:prstGeom>
-          <a:solidFill>
-            <a:srgbClr val="FFFFFF"/>
-          </a:solidFill>
-          <a:ln>
-            <a:noFill/>
-          </a:ln>
-        </p:spPr>
-        <p:style>
-          <a:lnRef idx="1">
-            <a:schemeClr val="accent1"/>
-          </a:lnRef>
-          <a:fillRef idx="3">
-            <a:schemeClr val="accent1"/>
-          </a:fillRef>
-          <a:effectRef idx="2">
-            <a:schemeClr val="accent1"/>
-          </a:effectRef>
-          <a:fontRef idx="minor">
-            <a:schemeClr val="lt1"/>
-          </a:fontRef>
-        </p:style>
-        <p:txBody>
-          <a:bodyPr rtlCol="0" anchor="ctr"/>
-          <a:lstStyle/>
-          <a:p>
-            <a:pPr algn="ctr"/>
+          <p:cNvPr id="9" name="TextBox 8"/>
+          <p:cNvSpPr txBox="1"/>
+          <p:nvPr/>
+        </p:nvSpPr>
+        <p:spPr>
+          <a:xfrm>
+            <a:off x="868680" y="1682496"/>
+            <a:ext cx="457200" cy="388620"/>
+          </a:xfrm>
+          <a:prstGeom prst="rect">
+            <a:avLst/>
+          </a:prstGeom>
+          <a:noFill/>
+        </p:spPr>
+        <p:txBody>
+          <a:bodyPr wrap="none">
+            <a:spAutoFit/>
+          </a:bodyPr>
+          <a:lstStyle/>
+          <a:p>
+            <a:pPr algn="ctr">
+              <a:defRPr sz="1800">
+                <a:solidFill>
+                  <a:srgbClr val="FFFFFF"/>
+                </a:solidFill>
+                <a:latin typeface="Segoe UI Emoji"/>
+              </a:defRPr>
+            </a:pPr>
+            <a:r>
+              <a:t>⭐</a:t>
+            </a:r>
           </a:p>
         </p:txBody>
       </p:sp>
@@ -7878,7 +7572,7 @@
         </p:nvSpPr>
         <p:spPr>
           <a:xfrm>
-            <a:off x="1078992" y="2194560"/>
+            <a:off x="1097280" y="2194560"/>
             <a:ext cx="17419320000" cy="457200"/>
           </a:xfrm>
           <a:prstGeom prst="rect">
@@ -7921,8 +7615,8 @@
         </p:nvSpPr>
         <p:spPr>
           <a:xfrm>
-            <a:off x="1554480" y="1682496"/>
-            <a:ext cx="9814255" cy="731520"/>
+            <a:off x="1600200" y="1682496"/>
+            <a:ext cx="9722815" cy="731520"/>
           </a:xfrm>
           <a:prstGeom prst="rect">
             <a:avLst/>
@@ -7970,16 +7664,16 @@
       </p:sp>
       <p:sp>
         <p:nvSpPr>
-          <p:cNvPr id="12" name="Rectangle 11"/>
+          <p:cNvPr id="12" name="Rounded Rectangle 11"/>
           <p:cNvSpPr/>
           <p:nvPr/>
         </p:nvSpPr>
         <p:spPr>
           <a:xfrm>
-            <a:off x="868680" y="2834640"/>
-            <a:ext cx="457200" cy="320040"/>
-          </a:xfrm>
-          <a:prstGeom prst="rect">
+            <a:off x="868680" y="2697480"/>
+            <a:ext cx="457200" cy="457200"/>
+          </a:xfrm>
+          <a:prstGeom prst="roundRect">
             <a:avLst/>
           </a:prstGeom>
           <a:solidFill>
@@ -8013,16 +7707,150 @@
       </p:sp>
       <p:sp>
         <p:nvSpPr>
-          <p:cNvPr id="13" name="Isosceles Triangle 12"/>
+          <p:cNvPr id="13" name="TextBox 12"/>
+          <p:cNvSpPr txBox="1"/>
+          <p:nvPr/>
+        </p:nvSpPr>
+        <p:spPr>
+          <a:xfrm>
+            <a:off x="868680" y="2734056"/>
+            <a:ext cx="457200" cy="388620"/>
+          </a:xfrm>
+          <a:prstGeom prst="rect">
+            <a:avLst/>
+          </a:prstGeom>
+          <a:noFill/>
+        </p:spPr>
+        <p:txBody>
+          <a:bodyPr wrap="none">
+            <a:spAutoFit/>
+          </a:bodyPr>
+          <a:lstStyle/>
+          <a:p>
+            <a:pPr algn="ctr">
+              <a:defRPr sz="1800">
+                <a:solidFill>
+                  <a:srgbClr val="FFFFFF"/>
+                </a:solidFill>
+                <a:latin typeface="Segoe UI Emoji"/>
+              </a:defRPr>
+            </a:pPr>
+            <a:r>
+              <a:t>🌆</a:t>
+            </a:r>
+          </a:p>
+        </p:txBody>
+      </p:sp>
+      <p:sp>
+        <p:nvSpPr>
+          <p:cNvPr id="14" name="Rectangle 13"/>
           <p:cNvSpPr/>
           <p:nvPr/>
         </p:nvSpPr>
         <p:spPr>
           <a:xfrm>
-            <a:off x="868680" y="2697480"/>
-            <a:ext cx="457200" cy="228600"/>
-          </a:xfrm>
-          <a:prstGeom prst="triangle">
+            <a:off x="1097280" y="3246120"/>
+            <a:ext cx="17419320000" cy="457200"/>
+          </a:xfrm>
+          <a:prstGeom prst="rect">
+            <a:avLst/>
+          </a:prstGeom>
+          <a:solidFill>
+            <a:srgbClr val="E2E8F0"/>
+          </a:solidFill>
+          <a:ln>
+            <a:noFill/>
+          </a:ln>
+        </p:spPr>
+        <p:style>
+          <a:lnRef idx="1">
+            <a:schemeClr val="accent1"/>
+          </a:lnRef>
+          <a:fillRef idx="3">
+            <a:schemeClr val="accent1"/>
+          </a:fillRef>
+          <a:effectRef idx="2">
+            <a:schemeClr val="accent1"/>
+          </a:effectRef>
+          <a:fontRef idx="minor">
+            <a:schemeClr val="lt1"/>
+          </a:fontRef>
+        </p:style>
+        <p:txBody>
+          <a:bodyPr rtlCol="0" anchor="ctr"/>
+          <a:lstStyle/>
+          <a:p>
+            <a:pPr algn="ctr"/>
+          </a:p>
+        </p:txBody>
+      </p:sp>
+      <p:sp>
+        <p:nvSpPr>
+          <p:cNvPr id="15" name="TextBox 14"/>
+          <p:cNvSpPr txBox="1"/>
+          <p:nvPr/>
+        </p:nvSpPr>
+        <p:spPr>
+          <a:xfrm>
+            <a:off x="1600200" y="2734056"/>
+            <a:ext cx="9722815" cy="731520"/>
+          </a:xfrm>
+          <a:prstGeom prst="rect">
+            <a:avLst/>
+          </a:prstGeom>
+          <a:noFill/>
+        </p:spPr>
+        <p:txBody>
+          <a:bodyPr wrap="square">
+            <a:spAutoFit/>
+          </a:bodyPr>
+          <a:lstStyle/>
+          <a:p>
+            <a:pPr>
+              <a:spcAft>
+                <a:spcPts val="100"/>
+              </a:spcAft>
+              <a:defRPr sz="1400" b="1">
+                <a:solidFill>
+                  <a:srgbClr val="1E293B"/>
+                </a:solidFill>
+                <a:latin typeface="Calibri"/>
+              </a:defRPr>
+            </a:pPr>
+            <a:r>
+              <a:t>Membangun kolaborasi dengan pemangku</a:t>
+            </a:r>
+          </a:p>
+          <a:p>
+            <a:pPr>
+              <a:spcAft>
+                <a:spcPts val="100"/>
+              </a:spcAft>
+              <a:defRPr sz="1300" b="0">
+                <a:solidFill>
+                  <a:srgbClr val="1E293B"/>
+                </a:solidFill>
+                <a:latin typeface="Calibri"/>
+              </a:defRPr>
+            </a:pPr>
+            <a:r>
+              <a:t>kepentingan lintas sektor</a:t>
+            </a:r>
+          </a:p>
+        </p:txBody>
+      </p:sp>
+      <p:sp>
+        <p:nvSpPr>
+          <p:cNvPr id="16" name="Rounded Rectangle 15"/>
+          <p:cNvSpPr/>
+          <p:nvPr/>
+        </p:nvSpPr>
+        <p:spPr>
+          <a:xfrm>
+            <a:off x="868680" y="3749039"/>
+            <a:ext cx="457200" cy="457200"/>
+          </a:xfrm>
+          <a:prstGeom prst="roundRect">
             <a:avLst/>
           </a:prstGeom>
           <a:solidFill>
@@ -8056,56 +7884,49 @@
       </p:sp>
       <p:sp>
         <p:nvSpPr>
-          <p:cNvPr id="14" name="Rectangle 13"/>
+          <p:cNvPr id="17" name="TextBox 16"/>
+          <p:cNvSpPr txBox="1"/>
+          <p:nvPr/>
+        </p:nvSpPr>
+        <p:spPr>
+          <a:xfrm>
+            <a:off x="868680" y="3785615"/>
+            <a:ext cx="457200" cy="388620"/>
+          </a:xfrm>
+          <a:prstGeom prst="rect">
+            <a:avLst/>
+          </a:prstGeom>
+          <a:noFill/>
+        </p:spPr>
+        <p:txBody>
+          <a:bodyPr wrap="none">
+            <a:spAutoFit/>
+          </a:bodyPr>
+          <a:lstStyle/>
+          <a:p>
+            <a:pPr algn="ctr">
+              <a:defRPr sz="1800">
+                <a:solidFill>
+                  <a:srgbClr val="FFFFFF"/>
+                </a:solidFill>
+                <a:latin typeface="Segoe UI Emoji"/>
+              </a:defRPr>
+            </a:pPr>
+            <a:r>
+              <a:t>💻</a:t>
+            </a:r>
+          </a:p>
+        </p:txBody>
+      </p:sp>
+      <p:sp>
+        <p:nvSpPr>
+          <p:cNvPr id="18" name="Rectangle 17"/>
           <p:cNvSpPr/>
           <p:nvPr/>
         </p:nvSpPr>
         <p:spPr>
           <a:xfrm>
-            <a:off x="1005839" y="2926080"/>
-            <a:ext cx="68580" cy="68580"/>
-          </a:xfrm>
-          <a:prstGeom prst="rect">
-            <a:avLst/>
-          </a:prstGeom>
-          <a:solidFill>
-            <a:srgbClr val="FFFFFF"/>
-          </a:solidFill>
-          <a:ln>
-            <a:noFill/>
-          </a:ln>
-        </p:spPr>
-        <p:style>
-          <a:lnRef idx="1">
-            <a:schemeClr val="accent1"/>
-          </a:lnRef>
-          <a:fillRef idx="3">
-            <a:schemeClr val="accent1"/>
-          </a:fillRef>
-          <a:effectRef idx="2">
-            <a:schemeClr val="accent1"/>
-          </a:effectRef>
-          <a:fontRef idx="minor">
-            <a:schemeClr val="lt1"/>
-          </a:fontRef>
-        </p:style>
-        <p:txBody>
-          <a:bodyPr rtlCol="0" anchor="ctr"/>
-          <a:lstStyle/>
-          <a:p>
-            <a:pPr algn="ctr"/>
-          </a:p>
-        </p:txBody>
-      </p:sp>
-      <p:sp>
-        <p:nvSpPr>
-          <p:cNvPr id="15" name="Rectangle 14"/>
-          <p:cNvSpPr/>
-          <p:nvPr/>
-        </p:nvSpPr>
-        <p:spPr>
-          <a:xfrm>
-            <a:off x="1078992" y="3246120"/>
+            <a:off x="1097280" y="4297679"/>
             <a:ext cx="17419320000" cy="457200"/>
           </a:xfrm>
           <a:prstGeom prst="rect">
@@ -8142,14 +7963,14 @@
       </p:sp>
       <p:sp>
         <p:nvSpPr>
-          <p:cNvPr id="16" name="TextBox 15"/>
+          <p:cNvPr id="19" name="TextBox 18"/>
           <p:cNvSpPr txBox="1"/>
           <p:nvPr/>
         </p:nvSpPr>
         <p:spPr>
           <a:xfrm>
-            <a:off x="1554480" y="2734056"/>
-            <a:ext cx="9814255" cy="731520"/>
+            <a:off x="1600200" y="3785615"/>
+            <a:ext cx="9722815" cy="731520"/>
           </a:xfrm>
           <a:prstGeom prst="rect">
             <a:avLst/>
@@ -8174,7 +7995,7 @@
               </a:defRPr>
             </a:pPr>
             <a:r>
-              <a:t>Membangun kolaborasi dengan pemangku</a:t>
+              <a:t>Mengoordinasikan &amp; mengevaluasi</a:t>
             </a:r>
           </a:p>
           <a:p>
@@ -8190,20 +8011,20 @@
               </a:defRPr>
             </a:pPr>
             <a:r>
-              <a:t>kepentingan lintas sektor</a:t>
-            </a:r>
-          </a:p>
-        </p:txBody>
-      </p:sp>
-      <p:sp>
-        <p:nvSpPr>
-          <p:cNvPr id="17" name="Rounded Rectangle 16"/>
+              <a:t>program Kota Cerdas secara berkala</a:t>
+            </a:r>
+          </a:p>
+        </p:txBody>
+      </p:sp>
+      <p:sp>
+        <p:nvSpPr>
+          <p:cNvPr id="20" name="Rounded Rectangle 19"/>
           <p:cNvSpPr/>
           <p:nvPr/>
         </p:nvSpPr>
         <p:spPr>
           <a:xfrm>
-            <a:off x="868680" y="3749039"/>
+            <a:off x="868680" y="4800600"/>
             <a:ext cx="457200" cy="457200"/>
           </a:xfrm>
           <a:prstGeom prst="roundRect">
@@ -8240,20 +8061,111 @@
       </p:sp>
       <p:sp>
         <p:nvSpPr>
-          <p:cNvPr id="18" name="Rectangle 17"/>
+          <p:cNvPr id="21" name="TextBox 20"/>
+          <p:cNvSpPr txBox="1"/>
+          <p:nvPr/>
+        </p:nvSpPr>
+        <p:spPr>
+          <a:xfrm>
+            <a:off x="868680" y="4837176"/>
+            <a:ext cx="457200" cy="388620"/>
+          </a:xfrm>
+          <a:prstGeom prst="rect">
+            <a:avLst/>
+          </a:prstGeom>
+          <a:noFill/>
+        </p:spPr>
+        <p:txBody>
+          <a:bodyPr wrap="none">
+            <a:spAutoFit/>
+          </a:bodyPr>
+          <a:lstStyle/>
+          <a:p>
+            <a:pPr algn="ctr">
+              <a:defRPr sz="1800">
+                <a:solidFill>
+                  <a:srgbClr val="FFFFFF"/>
+                </a:solidFill>
+                <a:latin typeface="Segoe UI Emoji"/>
+              </a:defRPr>
+            </a:pPr>
+            <a:r>
+              <a:t>🔗</a:t>
+            </a:r>
+          </a:p>
+        </p:txBody>
+      </p:sp>
+      <p:sp>
+        <p:nvSpPr>
+          <p:cNvPr id="22" name="TextBox 21"/>
+          <p:cNvSpPr txBox="1"/>
+          <p:nvPr/>
+        </p:nvSpPr>
+        <p:spPr>
+          <a:xfrm>
+            <a:off x="1600200" y="4837176"/>
+            <a:ext cx="9722815" cy="731520"/>
+          </a:xfrm>
+          <a:prstGeom prst="rect">
+            <a:avLst/>
+          </a:prstGeom>
+          <a:noFill/>
+        </p:spPr>
+        <p:txBody>
+          <a:bodyPr wrap="square">
+            <a:spAutoFit/>
+          </a:bodyPr>
+          <a:lstStyle/>
+          <a:p>
+            <a:pPr>
+              <a:spcAft>
+                <a:spcPts val="100"/>
+              </a:spcAft>
+              <a:defRPr sz="1400" b="1">
+                <a:solidFill>
+                  <a:srgbClr val="1E293B"/>
+                </a:solidFill>
+                <a:latin typeface="Calibri"/>
+              </a:defRPr>
+            </a:pPr>
+            <a:r>
+              <a:t>Menyelaraskan rencana induk dengan</a:t>
+            </a:r>
+          </a:p>
+          <a:p>
+            <a:pPr>
+              <a:spcAft>
+                <a:spcPts val="100"/>
+              </a:spcAft>
+              <a:defRPr sz="1300" b="0">
+                <a:solidFill>
+                  <a:srgbClr val="1E293B"/>
+                </a:solidFill>
+                <a:latin typeface="Calibri"/>
+              </a:defRPr>
+            </a:pPr>
+            <a:r>
+              <a:t>dokumen perencanaan daerah</a:t>
+            </a:r>
+          </a:p>
+        </p:txBody>
+      </p:sp>
+      <p:sp>
+        <p:nvSpPr>
+          <p:cNvPr id="23" name="Rectangle 22"/>
           <p:cNvSpPr/>
           <p:nvPr/>
         </p:nvSpPr>
         <p:spPr>
           <a:xfrm>
-            <a:off x="1051560" y="3931920"/>
-            <a:ext cx="91439" cy="91439"/>
+            <a:off x="0" y="6446520"/>
+            <a:ext cx="12191695" cy="411480"/>
           </a:xfrm>
           <a:prstGeom prst="rect">
             <a:avLst/>
           </a:prstGeom>
           <a:solidFill>
-            <a:srgbClr val="FFFFFF"/>
+            <a:srgbClr val="F8FAFC"/>
           </a:solidFill>
           <a:ln>
             <a:noFill/>
@@ -8283,57 +8195,14 @@
       </p:sp>
       <p:sp>
         <p:nvSpPr>
-          <p:cNvPr id="19" name="Rectangle 18"/>
+          <p:cNvPr id="24" name="Rectangle 23"/>
           <p:cNvSpPr/>
           <p:nvPr/>
         </p:nvSpPr>
         <p:spPr>
           <a:xfrm>
-            <a:off x="1028700" y="3909059"/>
-            <a:ext cx="137160" cy="137160"/>
-          </a:xfrm>
-          <a:prstGeom prst="rect">
-            <a:avLst/>
-          </a:prstGeom>
-          <a:solidFill>
-            <a:srgbClr val="0D9488"/>
-          </a:solidFill>
-          <a:ln>
-            <a:noFill/>
-          </a:ln>
-        </p:spPr>
-        <p:style>
-          <a:lnRef idx="1">
-            <a:schemeClr val="accent1"/>
-          </a:lnRef>
-          <a:fillRef idx="3">
-            <a:schemeClr val="accent1"/>
-          </a:fillRef>
-          <a:effectRef idx="2">
-            <a:schemeClr val="accent1"/>
-          </a:effectRef>
-          <a:fontRef idx="minor">
-            <a:schemeClr val="lt1"/>
-          </a:fontRef>
-        </p:style>
-        <p:txBody>
-          <a:bodyPr rtlCol="0" anchor="ctr"/>
-          <a:lstStyle/>
-          <a:p>
-            <a:pPr algn="ctr"/>
-          </a:p>
-        </p:txBody>
-      </p:sp>
-      <p:sp>
-        <p:nvSpPr>
-          <p:cNvPr id="20" name="Rectangle 19"/>
-          <p:cNvSpPr/>
-          <p:nvPr/>
-        </p:nvSpPr>
-        <p:spPr>
-          <a:xfrm>
-            <a:off x="1078992" y="4297679"/>
-            <a:ext cx="17419320000" cy="457200"/>
+            <a:off x="0" y="6446520"/>
+            <a:ext cx="12191695" cy="17419320000"/>
           </a:xfrm>
           <a:prstGeom prst="rect">
             <a:avLst/>
@@ -8369,14 +8238,14 @@
       </p:sp>
       <p:sp>
         <p:nvSpPr>
-          <p:cNvPr id="21" name="TextBox 20"/>
+          <p:cNvPr id="25" name="TextBox 24"/>
           <p:cNvSpPr txBox="1"/>
           <p:nvPr/>
         </p:nvSpPr>
         <p:spPr>
           <a:xfrm>
-            <a:off x="1554480" y="3785615"/>
-            <a:ext cx="9814255" cy="731520"/>
+            <a:off x="548640" y="6510528"/>
+            <a:ext cx="3657600" cy="201168"/>
           </a:xfrm>
           <a:prstGeom prst="rect">
             <a:avLst/>
@@ -8389,288 +8258,6 @@
           </a:bodyPr>
           <a:lstStyle/>
           <a:p>
-            <a:pPr>
-              <a:spcAft>
-                <a:spcPts val="100"/>
-              </a:spcAft>
-              <a:defRPr sz="1400" b="1">
-                <a:solidFill>
-                  <a:srgbClr val="1E293B"/>
-                </a:solidFill>
-                <a:latin typeface="Calibri"/>
-              </a:defRPr>
-            </a:pPr>
-            <a:r>
-              <a:t>Mengoordinasikan &amp; mengevaluasi</a:t>
-            </a:r>
-          </a:p>
-          <a:p>
-            <a:pPr>
-              <a:spcAft>
-                <a:spcPts val="100"/>
-              </a:spcAft>
-              <a:defRPr sz="1300" b="0">
-                <a:solidFill>
-                  <a:srgbClr val="1E293B"/>
-                </a:solidFill>
-                <a:latin typeface="Calibri"/>
-              </a:defRPr>
-            </a:pPr>
-            <a:r>
-              <a:t>program Kota Cerdas secara berkala</a:t>
-            </a:r>
-          </a:p>
-        </p:txBody>
-      </p:sp>
-      <p:sp>
-        <p:nvSpPr>
-          <p:cNvPr id="22" name="Parallelogram 21"/>
-          <p:cNvSpPr/>
-          <p:nvPr/>
-        </p:nvSpPr>
-        <p:spPr>
-          <a:xfrm>
-            <a:off x="868680" y="4800600"/>
-            <a:ext cx="320040" cy="457200"/>
-          </a:xfrm>
-          <a:prstGeom prst="parallelogram">
-            <a:avLst/>
-          </a:prstGeom>
-          <a:solidFill>
-            <a:srgbClr val="0D9488"/>
-          </a:solidFill>
-          <a:ln>
-            <a:noFill/>
-          </a:ln>
-        </p:spPr>
-        <p:style>
-          <a:lnRef idx="1">
-            <a:schemeClr val="accent1"/>
-          </a:lnRef>
-          <a:fillRef idx="3">
-            <a:schemeClr val="accent1"/>
-          </a:fillRef>
-          <a:effectRef idx="2">
-            <a:schemeClr val="accent1"/>
-          </a:effectRef>
-          <a:fontRef idx="minor">
-            <a:schemeClr val="lt1"/>
-          </a:fontRef>
-        </p:style>
-        <p:txBody>
-          <a:bodyPr rtlCol="0" anchor="ctr"/>
-          <a:lstStyle/>
-          <a:p>
-            <a:pPr algn="ctr"/>
-          </a:p>
-        </p:txBody>
-      </p:sp>
-      <p:sp>
-        <p:nvSpPr>
-          <p:cNvPr id="23" name="Parallelogram 22"/>
-          <p:cNvSpPr/>
-          <p:nvPr/>
-        </p:nvSpPr>
-        <p:spPr>
-          <a:xfrm>
-            <a:off x="1005839" y="4800600"/>
-            <a:ext cx="320040" cy="457200"/>
-          </a:xfrm>
-          <a:prstGeom prst="parallelogram">
-            <a:avLst/>
-          </a:prstGeom>
-          <a:solidFill>
-            <a:srgbClr val="FFFFFF"/>
-          </a:solidFill>
-          <a:ln>
-            <a:noFill/>
-          </a:ln>
-        </p:spPr>
-        <p:style>
-          <a:lnRef idx="1">
-            <a:schemeClr val="accent1"/>
-          </a:lnRef>
-          <a:fillRef idx="3">
-            <a:schemeClr val="accent1"/>
-          </a:fillRef>
-          <a:effectRef idx="2">
-            <a:schemeClr val="accent1"/>
-          </a:effectRef>
-          <a:fontRef idx="minor">
-            <a:schemeClr val="lt1"/>
-          </a:fontRef>
-        </p:style>
-        <p:txBody>
-          <a:bodyPr rtlCol="0" anchor="ctr"/>
-          <a:lstStyle/>
-          <a:p>
-            <a:pPr algn="ctr"/>
-          </a:p>
-        </p:txBody>
-      </p:sp>
-      <p:sp>
-        <p:nvSpPr>
-          <p:cNvPr id="24" name="TextBox 23"/>
-          <p:cNvSpPr txBox="1"/>
-          <p:nvPr/>
-        </p:nvSpPr>
-        <p:spPr>
-          <a:xfrm>
-            <a:off x="1554480" y="4837176"/>
-            <a:ext cx="9814255" cy="731520"/>
-          </a:xfrm>
-          <a:prstGeom prst="rect">
-            <a:avLst/>
-          </a:prstGeom>
-          <a:noFill/>
-        </p:spPr>
-        <p:txBody>
-          <a:bodyPr wrap="square">
-            <a:spAutoFit/>
-          </a:bodyPr>
-          <a:lstStyle/>
-          <a:p>
-            <a:pPr>
-              <a:spcAft>
-                <a:spcPts val="100"/>
-              </a:spcAft>
-              <a:defRPr sz="1400" b="1">
-                <a:solidFill>
-                  <a:srgbClr val="1E293B"/>
-                </a:solidFill>
-                <a:latin typeface="Calibri"/>
-              </a:defRPr>
-            </a:pPr>
-            <a:r>
-              <a:t>Menyelaraskan rencana induk dengan</a:t>
-            </a:r>
-          </a:p>
-          <a:p>
-            <a:pPr>
-              <a:spcAft>
-                <a:spcPts val="100"/>
-              </a:spcAft>
-              <a:defRPr sz="1300" b="0">
-                <a:solidFill>
-                  <a:srgbClr val="1E293B"/>
-                </a:solidFill>
-                <a:latin typeface="Calibri"/>
-              </a:defRPr>
-            </a:pPr>
-            <a:r>
-              <a:t>dokumen perencanaan daerah</a:t>
-            </a:r>
-          </a:p>
-        </p:txBody>
-      </p:sp>
-      <p:sp>
-        <p:nvSpPr>
-          <p:cNvPr id="25" name="Rectangle 24"/>
-          <p:cNvSpPr/>
-          <p:nvPr/>
-        </p:nvSpPr>
-        <p:spPr>
-          <a:xfrm>
-            <a:off x="0" y="6446520"/>
-            <a:ext cx="12191695" cy="411480"/>
-          </a:xfrm>
-          <a:prstGeom prst="rect">
-            <a:avLst/>
-          </a:prstGeom>
-          <a:solidFill>
-            <a:srgbClr val="F8FAFC"/>
-          </a:solidFill>
-          <a:ln>
-            <a:noFill/>
-          </a:ln>
-        </p:spPr>
-        <p:style>
-          <a:lnRef idx="1">
-            <a:schemeClr val="accent1"/>
-          </a:lnRef>
-          <a:fillRef idx="3">
-            <a:schemeClr val="accent1"/>
-          </a:fillRef>
-          <a:effectRef idx="2">
-            <a:schemeClr val="accent1"/>
-          </a:effectRef>
-          <a:fontRef idx="minor">
-            <a:schemeClr val="lt1"/>
-          </a:fontRef>
-        </p:style>
-        <p:txBody>
-          <a:bodyPr rtlCol="0" anchor="ctr"/>
-          <a:lstStyle/>
-          <a:p>
-            <a:pPr algn="ctr"/>
-          </a:p>
-        </p:txBody>
-      </p:sp>
-      <p:sp>
-        <p:nvSpPr>
-          <p:cNvPr id="26" name="Rectangle 25"/>
-          <p:cNvSpPr/>
-          <p:nvPr/>
-        </p:nvSpPr>
-        <p:spPr>
-          <a:xfrm>
-            <a:off x="0" y="6446520"/>
-            <a:ext cx="12191695" cy="17419320000"/>
-          </a:xfrm>
-          <a:prstGeom prst="rect">
-            <a:avLst/>
-          </a:prstGeom>
-          <a:solidFill>
-            <a:srgbClr val="E2E8F0"/>
-          </a:solidFill>
-          <a:ln>
-            <a:noFill/>
-          </a:ln>
-        </p:spPr>
-        <p:style>
-          <a:lnRef idx="1">
-            <a:schemeClr val="accent1"/>
-          </a:lnRef>
-          <a:fillRef idx="3">
-            <a:schemeClr val="accent1"/>
-          </a:fillRef>
-          <a:effectRef idx="2">
-            <a:schemeClr val="accent1"/>
-          </a:effectRef>
-          <a:fontRef idx="minor">
-            <a:schemeClr val="lt1"/>
-          </a:fontRef>
-        </p:style>
-        <p:txBody>
-          <a:bodyPr rtlCol="0" anchor="ctr"/>
-          <a:lstStyle/>
-          <a:p>
-            <a:pPr algn="ctr"/>
-          </a:p>
-        </p:txBody>
-      </p:sp>
-      <p:sp>
-        <p:nvSpPr>
-          <p:cNvPr id="27" name="TextBox 26"/>
-          <p:cNvSpPr txBox="1"/>
-          <p:nvPr/>
-        </p:nvSpPr>
-        <p:spPr>
-          <a:xfrm>
-            <a:off x="548640" y="6510528"/>
-            <a:ext cx="3657600" cy="201168"/>
-          </a:xfrm>
-          <a:prstGeom prst="rect">
-            <a:avLst/>
-          </a:prstGeom>
-          <a:noFill/>
-        </p:spPr>
-        <p:txBody>
-          <a:bodyPr wrap="square">
-            <a:spAutoFit/>
-          </a:bodyPr>
-          <a:lstStyle/>
-          <a:p>
             <a:pPr algn="l">
               <a:defRPr sz="700" b="0">
                 <a:solidFill>
@@ -8687,7 +8274,7 @@
       </p:sp>
       <p:sp>
         <p:nvSpPr>
-          <p:cNvPr id="28" name="TextBox 27"/>
+          <p:cNvPr id="26" name="TextBox 25"/>
           <p:cNvSpPr txBox="1"/>
           <p:nvPr/>
         </p:nvSpPr>
@@ -8993,7 +8580,7 @@
       </p:sp>
       <p:sp>
         <p:nvSpPr>
-          <p:cNvPr id="8" name="Pentagon 7"/>
+          <p:cNvPr id="8" name="Rounded Rectangle 7"/>
           <p:cNvSpPr/>
           <p:nvPr/>
         </p:nvSpPr>
@@ -9002,7 +8589,7 @@
             <a:off x="868680" y="1645920"/>
             <a:ext cx="457200" cy="457200"/>
           </a:xfrm>
-          <a:prstGeom prst="homePlate">
+          <a:prstGeom prst="roundRect">
             <a:avLst/>
           </a:prstGeom>
           <a:solidFill>
@@ -9036,44 +8623,37 @@
       </p:sp>
       <p:sp>
         <p:nvSpPr>
-          <p:cNvPr id="9" name="Rectangle 8"/>
-          <p:cNvSpPr/>
-          <p:nvPr/>
-        </p:nvSpPr>
-        <p:spPr>
-          <a:xfrm>
-            <a:off x="1005839" y="1783080"/>
-            <a:ext cx="182880" cy="182880"/>
-          </a:xfrm>
-          <a:prstGeom prst="rect">
-            <a:avLst/>
-          </a:prstGeom>
-          <a:solidFill>
-            <a:srgbClr val="FFFFFF"/>
-          </a:solidFill>
-          <a:ln>
-            <a:noFill/>
-          </a:ln>
-        </p:spPr>
-        <p:style>
-          <a:lnRef idx="1">
-            <a:schemeClr val="accent1"/>
-          </a:lnRef>
-          <a:fillRef idx="3">
-            <a:schemeClr val="accent1"/>
-          </a:fillRef>
-          <a:effectRef idx="2">
-            <a:schemeClr val="accent1"/>
-          </a:effectRef>
-          <a:fontRef idx="minor">
-            <a:schemeClr val="lt1"/>
-          </a:fontRef>
-        </p:style>
-        <p:txBody>
-          <a:bodyPr rtlCol="0" anchor="ctr"/>
-          <a:lstStyle/>
-          <a:p>
-            <a:pPr algn="ctr"/>
+          <p:cNvPr id="9" name="TextBox 8"/>
+          <p:cNvSpPr txBox="1"/>
+          <p:nvPr/>
+        </p:nvSpPr>
+        <p:spPr>
+          <a:xfrm>
+            <a:off x="868680" y="1682496"/>
+            <a:ext cx="457200" cy="388620"/>
+          </a:xfrm>
+          <a:prstGeom prst="rect">
+            <a:avLst/>
+          </a:prstGeom>
+          <a:noFill/>
+        </p:spPr>
+        <p:txBody>
+          <a:bodyPr wrap="none">
+            <a:spAutoFit/>
+          </a:bodyPr>
+          <a:lstStyle/>
+          <a:p>
+            <a:pPr algn="ctr">
+              <a:defRPr sz="1800">
+                <a:solidFill>
+                  <a:srgbClr val="FFFFFF"/>
+                </a:solidFill>
+                <a:latin typeface="Segoe UI Emoji"/>
+              </a:defRPr>
+            </a:pPr>
+            <a:r>
+              <a:t>⚙️</a:t>
+            </a:r>
           </a:p>
         </p:txBody>
       </p:sp>
@@ -9085,7 +8665,7 @@
         </p:nvSpPr>
         <p:spPr>
           <a:xfrm>
-            <a:off x="1078992" y="2194560"/>
+            <a:off x="1097280" y="2194560"/>
             <a:ext cx="17419320000" cy="457200"/>
           </a:xfrm>
           <a:prstGeom prst="rect">
@@ -9128,8 +8708,8 @@
         </p:nvSpPr>
         <p:spPr>
           <a:xfrm>
-            <a:off x="1554480" y="1682496"/>
-            <a:ext cx="9814255" cy="731520"/>
+            <a:off x="1600200" y="1682496"/>
+            <a:ext cx="9722815" cy="731520"/>
           </a:xfrm>
           <a:prstGeom prst="rect">
             <a:avLst/>
@@ -9177,7 +8757,7 @@
       </p:sp>
       <p:sp>
         <p:nvSpPr>
-          <p:cNvPr id="12" name="Right Arrow 11"/>
+          <p:cNvPr id="12" name="Rounded Rectangle 11"/>
           <p:cNvSpPr/>
           <p:nvPr/>
         </p:nvSpPr>
@@ -9186,7 +8766,7 @@
             <a:off x="868680" y="2697480"/>
             <a:ext cx="457200" cy="457200"/>
           </a:xfrm>
-          <a:prstGeom prst="rightArrow">
+          <a:prstGeom prst="roundRect">
             <a:avLst/>
           </a:prstGeom>
           <a:solidFill>
@@ -9220,13 +8800,49 @@
       </p:sp>
       <p:sp>
         <p:nvSpPr>
-          <p:cNvPr id="13" name="Rectangle 12"/>
+          <p:cNvPr id="13" name="TextBox 12"/>
+          <p:cNvSpPr txBox="1"/>
+          <p:nvPr/>
+        </p:nvSpPr>
+        <p:spPr>
+          <a:xfrm>
+            <a:off x="868680" y="2734056"/>
+            <a:ext cx="457200" cy="388620"/>
+          </a:xfrm>
+          <a:prstGeom prst="rect">
+            <a:avLst/>
+          </a:prstGeom>
+          <a:noFill/>
+        </p:spPr>
+        <p:txBody>
+          <a:bodyPr wrap="none">
+            <a:spAutoFit/>
+          </a:bodyPr>
+          <a:lstStyle/>
+          <a:p>
+            <a:pPr algn="ctr">
+              <a:defRPr sz="1800">
+                <a:solidFill>
+                  <a:srgbClr val="FFFFFF"/>
+                </a:solidFill>
+                <a:latin typeface="Segoe UI Emoji"/>
+              </a:defRPr>
+            </a:pPr>
+            <a:r>
+              <a:t>📋</a:t>
+            </a:r>
+          </a:p>
+        </p:txBody>
+      </p:sp>
+      <p:sp>
+        <p:nvSpPr>
+          <p:cNvPr id="14" name="Rectangle 13"/>
           <p:cNvSpPr/>
           <p:nvPr/>
         </p:nvSpPr>
         <p:spPr>
           <a:xfrm>
-            <a:off x="1078992" y="3246120"/>
+            <a:off x="1097280" y="3246120"/>
             <a:ext cx="17419320000" cy="457200"/>
           </a:xfrm>
           <a:prstGeom prst="rect">
@@ -9263,14 +8879,14 @@
       </p:sp>
       <p:sp>
         <p:nvSpPr>
-          <p:cNvPr id="14" name="TextBox 13"/>
+          <p:cNvPr id="15" name="TextBox 14"/>
           <p:cNvSpPr txBox="1"/>
           <p:nvPr/>
         </p:nvSpPr>
         <p:spPr>
           <a:xfrm>
-            <a:off x="1554480" y="2734056"/>
-            <a:ext cx="9814255" cy="731520"/>
+            <a:off x="1600200" y="2734056"/>
+            <a:ext cx="9722815" cy="731520"/>
           </a:xfrm>
           <a:prstGeom prst="rect">
             <a:avLst/>
@@ -9318,7 +8934,7 @@
       </p:sp>
       <p:sp>
         <p:nvSpPr>
-          <p:cNvPr id="15" name="Rounded Rectangle 14"/>
+          <p:cNvPr id="16" name="Rounded Rectangle 15"/>
           <p:cNvSpPr/>
           <p:nvPr/>
         </p:nvSpPr>
@@ -9361,20 +8977,56 @@
       </p:sp>
       <p:sp>
         <p:nvSpPr>
-          <p:cNvPr id="16" name="Rectangle 15"/>
+          <p:cNvPr id="17" name="TextBox 16"/>
+          <p:cNvSpPr txBox="1"/>
+          <p:nvPr/>
+        </p:nvSpPr>
+        <p:spPr>
+          <a:xfrm>
+            <a:off x="868680" y="3785615"/>
+            <a:ext cx="457200" cy="388620"/>
+          </a:xfrm>
+          <a:prstGeom prst="rect">
+            <a:avLst/>
+          </a:prstGeom>
+          <a:noFill/>
+        </p:spPr>
+        <p:txBody>
+          <a:bodyPr wrap="none">
+            <a:spAutoFit/>
+          </a:bodyPr>
+          <a:lstStyle/>
+          <a:p>
+            <a:pPr algn="ctr">
+              <a:defRPr sz="1800">
+                <a:solidFill>
+                  <a:srgbClr val="FFFFFF"/>
+                </a:solidFill>
+                <a:latin typeface="Segoe UI Emoji"/>
+              </a:defRPr>
+            </a:pPr>
+            <a:r>
+              <a:t>📝</a:t>
+            </a:r>
+          </a:p>
+        </p:txBody>
+      </p:sp>
+      <p:sp>
+        <p:nvSpPr>
+          <p:cNvPr id="18" name="Rectangle 17"/>
           <p:cNvSpPr/>
           <p:nvPr/>
         </p:nvSpPr>
         <p:spPr>
           <a:xfrm>
-            <a:off x="1051560" y="3931920"/>
-            <a:ext cx="91439" cy="91439"/>
+            <a:off x="1097280" y="4297679"/>
+            <a:ext cx="17419320000" cy="457200"/>
           </a:xfrm>
           <a:prstGeom prst="rect">
             <a:avLst/>
           </a:prstGeom>
           <a:solidFill>
-            <a:srgbClr val="FFFFFF"/>
+            <a:srgbClr val="E2E8F0"/>
           </a:solidFill>
           <a:ln>
             <a:noFill/>
@@ -9404,16 +9056,71 @@
       </p:sp>
       <p:sp>
         <p:nvSpPr>
-          <p:cNvPr id="17" name="Rectangle 16"/>
+          <p:cNvPr id="19" name="TextBox 18"/>
+          <p:cNvSpPr txBox="1"/>
+          <p:nvPr/>
+        </p:nvSpPr>
+        <p:spPr>
+          <a:xfrm>
+            <a:off x="1600200" y="3785615"/>
+            <a:ext cx="9722815" cy="731520"/>
+          </a:xfrm>
+          <a:prstGeom prst="rect">
+            <a:avLst/>
+          </a:prstGeom>
+          <a:noFill/>
+        </p:spPr>
+        <p:txBody>
+          <a:bodyPr wrap="square">
+            <a:spAutoFit/>
+          </a:bodyPr>
+          <a:lstStyle/>
+          <a:p>
+            <a:pPr>
+              <a:spcAft>
+                <a:spcPts val="100"/>
+              </a:spcAft>
+              <a:defRPr sz="1400" b="1">
+                <a:solidFill>
+                  <a:srgbClr val="1E293B"/>
+                </a:solidFill>
+                <a:latin typeface="Calibri"/>
+              </a:defRPr>
+            </a:pPr>
+            <a:r>
+              <a:t>Mengembangkan kebijakan &amp;</a:t>
+            </a:r>
+          </a:p>
+          <a:p>
+            <a:pPr>
+              <a:spcAft>
+                <a:spcPts val="100"/>
+              </a:spcAft>
+              <a:defRPr sz="1300" b="0">
+                <a:solidFill>
+                  <a:srgbClr val="1E293B"/>
+                </a:solidFill>
+                <a:latin typeface="Calibri"/>
+              </a:defRPr>
+            </a:pPr>
+            <a:r>
+              <a:t>tata kelola SPBE yang adaptif</a:t>
+            </a:r>
+          </a:p>
+        </p:txBody>
+      </p:sp>
+      <p:sp>
+        <p:nvSpPr>
+          <p:cNvPr id="20" name="Rounded Rectangle 19"/>
           <p:cNvSpPr/>
           <p:nvPr/>
         </p:nvSpPr>
         <p:spPr>
           <a:xfrm>
-            <a:off x="1028700" y="3909059"/>
-            <a:ext cx="137160" cy="137160"/>
-          </a:xfrm>
-          <a:prstGeom prst="rect">
+            <a:off x="868680" y="4800600"/>
+            <a:ext cx="457200" cy="457200"/>
+          </a:xfrm>
+          <a:prstGeom prst="roundRect">
             <a:avLst/>
           </a:prstGeom>
           <a:solidFill>
@@ -9447,57 +9154,14 @@
       </p:sp>
       <p:sp>
         <p:nvSpPr>
-          <p:cNvPr id="18" name="Rectangle 17"/>
-          <p:cNvSpPr/>
-          <p:nvPr/>
-        </p:nvSpPr>
-        <p:spPr>
-          <a:xfrm>
-            <a:off x="1078992" y="4297679"/>
-            <a:ext cx="17419320000" cy="457200"/>
-          </a:xfrm>
-          <a:prstGeom prst="rect">
-            <a:avLst/>
-          </a:prstGeom>
-          <a:solidFill>
-            <a:srgbClr val="E2E8F0"/>
-          </a:solidFill>
-          <a:ln>
-            <a:noFill/>
-          </a:ln>
-        </p:spPr>
-        <p:style>
-          <a:lnRef idx="1">
-            <a:schemeClr val="accent1"/>
-          </a:lnRef>
-          <a:fillRef idx="3">
-            <a:schemeClr val="accent1"/>
-          </a:fillRef>
-          <a:effectRef idx="2">
-            <a:schemeClr val="accent1"/>
-          </a:effectRef>
-          <a:fontRef idx="minor">
-            <a:schemeClr val="lt1"/>
-          </a:fontRef>
-        </p:style>
-        <p:txBody>
-          <a:bodyPr rtlCol="0" anchor="ctr"/>
-          <a:lstStyle/>
-          <a:p>
-            <a:pPr algn="ctr"/>
-          </a:p>
-        </p:txBody>
-      </p:sp>
-      <p:sp>
-        <p:nvSpPr>
-          <p:cNvPr id="19" name="TextBox 18"/>
+          <p:cNvPr id="21" name="TextBox 20"/>
           <p:cNvSpPr txBox="1"/>
           <p:nvPr/>
         </p:nvSpPr>
         <p:spPr>
           <a:xfrm>
-            <a:off x="1554480" y="3785615"/>
-            <a:ext cx="9814255" cy="731520"/>
+            <a:off x="868680" y="4837176"/>
+            <a:ext cx="457200" cy="388620"/>
           </a:xfrm>
           <a:prstGeom prst="rect">
             <a:avLst/>
@@ -9505,127 +9169,22 @@
           <a:noFill/>
         </p:spPr>
         <p:txBody>
-          <a:bodyPr wrap="square">
+          <a:bodyPr wrap="none">
             <a:spAutoFit/>
           </a:bodyPr>
           <a:lstStyle/>
           <a:p>
-            <a:pPr>
-              <a:spcAft>
-                <a:spcPts val="100"/>
-              </a:spcAft>
-              <a:defRPr sz="1400" b="1">
-                <a:solidFill>
-                  <a:srgbClr val="1E293B"/>
-                </a:solidFill>
-                <a:latin typeface="Calibri"/>
+            <a:pPr algn="ctr">
+              <a:defRPr sz="1800">
+                <a:solidFill>
+                  <a:srgbClr val="FFFFFF"/>
+                </a:solidFill>
+                <a:latin typeface="Segoe UI Emoji"/>
               </a:defRPr>
             </a:pPr>
             <a:r>
-              <a:t>Mengembangkan kebijakan &amp;</a:t>
-            </a:r>
-          </a:p>
-          <a:p>
-            <a:pPr>
-              <a:spcAft>
-                <a:spcPts val="100"/>
-              </a:spcAft>
-              <a:defRPr sz="1300" b="0">
-                <a:solidFill>
-                  <a:srgbClr val="1E293B"/>
-                </a:solidFill>
-                <a:latin typeface="Calibri"/>
-              </a:defRPr>
-            </a:pPr>
-            <a:r>
-              <a:t>tata kelola SPBE yang adaptif</a:t>
-            </a:r>
-          </a:p>
-        </p:txBody>
-      </p:sp>
-      <p:sp>
-        <p:nvSpPr>
-          <p:cNvPr id="20" name="Diamond 19"/>
-          <p:cNvSpPr/>
-          <p:nvPr/>
-        </p:nvSpPr>
-        <p:spPr>
-          <a:xfrm>
-            <a:off x="868680" y="4800600"/>
-            <a:ext cx="457200" cy="457200"/>
-          </a:xfrm>
-          <a:prstGeom prst="diamond">
-            <a:avLst/>
-          </a:prstGeom>
-          <a:solidFill>
-            <a:srgbClr val="1A5676"/>
-          </a:solidFill>
-          <a:ln>
-            <a:noFill/>
-          </a:ln>
-        </p:spPr>
-        <p:style>
-          <a:lnRef idx="1">
-            <a:schemeClr val="accent1"/>
-          </a:lnRef>
-          <a:fillRef idx="3">
-            <a:schemeClr val="accent1"/>
-          </a:fillRef>
-          <a:effectRef idx="2">
-            <a:schemeClr val="accent1"/>
-          </a:effectRef>
-          <a:fontRef idx="minor">
-            <a:schemeClr val="lt1"/>
-          </a:fontRef>
-        </p:style>
-        <p:txBody>
-          <a:bodyPr rtlCol="0" anchor="ctr"/>
-          <a:lstStyle/>
-          <a:p>
-            <a:pPr algn="ctr"/>
-          </a:p>
-        </p:txBody>
-      </p:sp>
-      <p:sp>
-        <p:nvSpPr>
-          <p:cNvPr id="21" name="Diamond 20"/>
-          <p:cNvSpPr/>
-          <p:nvPr/>
-        </p:nvSpPr>
-        <p:spPr>
-          <a:xfrm>
-            <a:off x="937259" y="4869180"/>
-            <a:ext cx="320040" cy="320040"/>
-          </a:xfrm>
-          <a:prstGeom prst="diamond">
-            <a:avLst/>
-          </a:prstGeom>
-          <a:solidFill>
-            <a:srgbClr val="FFFFFF"/>
-          </a:solidFill>
-          <a:ln>
-            <a:noFill/>
-          </a:ln>
-        </p:spPr>
-        <p:style>
-          <a:lnRef idx="1">
-            <a:schemeClr val="accent1"/>
-          </a:lnRef>
-          <a:fillRef idx="3">
-            <a:schemeClr val="accent1"/>
-          </a:fillRef>
-          <a:effectRef idx="2">
-            <a:schemeClr val="accent1"/>
-          </a:effectRef>
-          <a:fontRef idx="minor">
-            <a:schemeClr val="lt1"/>
-          </a:fontRef>
-        </p:style>
-        <p:txBody>
-          <a:bodyPr rtlCol="0" anchor="ctr"/>
-          <a:lstStyle/>
-          <a:p>
-            <a:pPr algn="ctr"/>
+              <a:t>📊</a:t>
+            </a:r>
           </a:p>
         </p:txBody>
       </p:sp>
@@ -9637,8 +9196,8 @@
         </p:nvSpPr>
         <p:spPr>
           <a:xfrm>
-            <a:off x="1554480" y="4837176"/>
-            <a:ext cx="9814255" cy="731520"/>
+            <a:off x="1600200" y="4837176"/>
+            <a:ext cx="9722815" cy="731520"/>
           </a:xfrm>
           <a:prstGeom prst="rect">
             <a:avLst/>
@@ -9999,7 +9558,7 @@
       </p:sp>
       <p:sp>
         <p:nvSpPr>
-          <p:cNvPr id="5" name="Diamond 4"/>
+          <p:cNvPr id="5" name="Rounded Rectangle 4"/>
           <p:cNvSpPr/>
           <p:nvPr/>
         </p:nvSpPr>
@@ -10008,7 +9567,7 @@
             <a:off x="5730087" y="1097280"/>
             <a:ext cx="731520" cy="731520"/>
           </a:xfrm>
-          <a:prstGeom prst="diamond">
+          <a:prstGeom prst="roundRect">
             <a:avLst/>
           </a:prstGeom>
           <a:solidFill>
@@ -10042,44 +9601,37 @@
       </p:sp>
       <p:sp>
         <p:nvSpPr>
-          <p:cNvPr id="6" name="Diamond 5"/>
-          <p:cNvSpPr/>
-          <p:nvPr/>
-        </p:nvSpPr>
-        <p:spPr>
-          <a:xfrm>
-            <a:off x="5839815" y="1207007"/>
-            <a:ext cx="512063" cy="512063"/>
-          </a:xfrm>
-          <a:prstGeom prst="diamond">
-            <a:avLst/>
-          </a:prstGeom>
-          <a:solidFill>
-            <a:srgbClr val="FFFFFF"/>
-          </a:solidFill>
-          <a:ln>
-            <a:noFill/>
-          </a:ln>
-        </p:spPr>
-        <p:style>
-          <a:lnRef idx="1">
-            <a:schemeClr val="accent1"/>
-          </a:lnRef>
-          <a:fillRef idx="3">
-            <a:schemeClr val="accent1"/>
-          </a:fillRef>
-          <a:effectRef idx="2">
-            <a:schemeClr val="accent1"/>
-          </a:effectRef>
-          <a:fontRef idx="minor">
-            <a:schemeClr val="lt1"/>
-          </a:fontRef>
-        </p:style>
-        <p:txBody>
-          <a:bodyPr rtlCol="0" anchor="ctr"/>
-          <a:lstStyle/>
-          <a:p>
-            <a:pPr algn="ctr"/>
+          <p:cNvPr id="6" name="TextBox 5"/>
+          <p:cNvSpPr txBox="1"/>
+          <p:nvPr/>
+        </p:nvSpPr>
+        <p:spPr>
+          <a:xfrm>
+            <a:off x="5730087" y="1155801"/>
+            <a:ext cx="731520" cy="621792"/>
+          </a:xfrm>
+          <a:prstGeom prst="rect">
+            <a:avLst/>
+          </a:prstGeom>
+          <a:noFill/>
+        </p:spPr>
+        <p:txBody>
+          <a:bodyPr wrap="none">
+            <a:spAutoFit/>
+          </a:bodyPr>
+          <a:lstStyle/>
+          <a:p>
+            <a:pPr algn="ctr">
+              <a:defRPr sz="2800">
+                <a:solidFill>
+                  <a:srgbClr val="FFFFFF"/>
+                </a:solidFill>
+                <a:latin typeface="Segoe UI Emoji"/>
+              </a:defRPr>
+            </a:pPr>
+            <a:r>
+              <a:t>⭐</a:t>
+            </a:r>
           </a:p>
         </p:txBody>
       </p:sp>

</xml_diff>

<commit_message>
feat: 2 versi — Indonesia + English
- 🇮🇩 RESUME_TUPOKSI_egov.pptx (Indonesia)
- 🇬🇧 RESUME_TUPOKSI_egov_EN.pptx (English)
- Semua konten diterjemahkan ke English
- Label: DISKOMINFOSTANDI (full caps)
- Code refactor: CONTENT dict per language
</commit_message>
<xml_diff>
--- a/RESUME_TUPOKSI_egov.pptx
+++ b/RESUME_TUPOKSI_egov.pptx
@@ -3456,7 +3456,7 @@
               </a:defRPr>
             </a:pPr>
             <a:r>
-              <a:t>Diskominfostandi Kota Bekasi</a:t>
+              <a:t>DISKOMINFOSTANDI Kota Bekasi</a:t>
             </a:r>
           </a:p>
         </p:txBody>
@@ -9702,7 +9702,7 @@
               </a:defRPr>
             </a:pPr>
             <a:r>
-              <a:t>Bidang e-Government — Diskominfostandi Kota Bekasi</a:t>
+              <a:t>Bidang e-Government DISKOMINFOSTANDI Kota Bekasi</a:t>
             </a:r>
           </a:p>
         </p:txBody>

</xml_diff>